<commit_message>
Rewrite Lecture 8: real CSS alongside every visual-effects screenshot
Converts the remaining image-only slides to codeImage, pairing each with
its exact book CSS: rainbow gradient stops, box-shadow hover, text-shadow,
multiple/glow shadows, opacity, 2D transforms comparison, the 3D hover
flip, the transition button, and the @keyframes bounce animation.
border-radius, the basic gradients, and CSS variables already had a
matching code slide immediately before them -- left those as is.

Co-Authored-By: Claude Sonnet 5 <noreply@anthropic.com>
</commit_message>
<xml_diff>
--- a/slides/CSC336-Lecture-08-CSS3-Features.pptx
+++ b/slides/CSC336-Lecture-08-CSS3-Features.pptx
@@ -3291,57 +3291,102 @@
       </p:sp>
       <p:sp>
         <p:nvSpPr>
-          <p:cNvPr id="4" name="Text 2"/>
-          <p:cNvSpPr txBox="1"/>
-          <p:nvPr/>
-        </p:nvSpPr>
-        <p:spPr>
-          <a:xfrm>
-            <a:off x="640080" y="1691640"/>
-            <a:ext cx="10911535" cy="411480"/>
-          </a:xfrm>
-          <a:prstGeom prst="rect">
-            <a:avLst/>
-          </a:prstGeom>
-          <a:noFill/>
-          <a:ln/>
-        </p:spPr>
-        <p:txBody>
-          <a:bodyPr wrap="square" lIns="0" tIns="0" rIns="0" bIns="0" rtlCol="0" anchor="ctr"/>
-          <a:lstStyle/>
-          <a:p>
-            <a:pPr indent="0" marL="0">
-              <a:buNone/>
-            </a:pPr>
-            <a:r>
-              <a:rPr lang="en-US" sz="1350" i="1" dirty="0">
-                <a:solidFill>
-                  <a:srgbClr val="5D5D72"/>
-                </a:solidFill>
-                <a:latin typeface="Calibri" pitchFamily="34" charset="0"/>
-                <a:ea typeface="Calibri" pitchFamily="34" charset="-122"/>
-                <a:cs typeface="Calibri" pitchFamily="34" charset="-120"/>
-              </a:rPr>
-              <a:t>box-shadow: 0 1px 2px #000, 0 0 20px gold; — stack shadows by separating them with commas.</a:t>
-            </a:r>
-            <a:endParaRPr lang="en-US" sz="1350" dirty="0"/>
-          </a:p>
-        </p:txBody>
-      </p:sp>
-      <p:sp>
-        <p:nvSpPr>
-          <p:cNvPr id="5" name="Shape 3"/>
+          <p:cNvPr id="4" name="Shape 2"/>
           <p:cNvSpPr/>
           <p:nvPr/>
         </p:nvSpPr>
         <p:spPr>
           <a:xfrm>
-            <a:off x="530352" y="2221992"/>
-            <a:ext cx="11130991" cy="4059936"/>
+            <a:off x="640080" y="1965960"/>
+            <a:ext cx="10911535" cy="1024890"/>
           </a:xfrm>
           <a:prstGeom prst="roundRect">
             <a:avLst>
-              <a:gd name="adj" fmla="val 1351"/>
+              <a:gd name="adj" fmla="val 7138"/>
+            </a:avLst>
+          </a:prstGeom>
+          <a:solidFill>
+            <a:srgbClr val="1E1E4C"/>
+          </a:solidFill>
+          <a:ln/>
+        </p:spPr>
+      </p:sp>
+      <p:sp>
+        <p:nvSpPr>
+          <p:cNvPr id="5" name="Text 3"/>
+          <p:cNvSpPr txBox="1"/>
+          <p:nvPr/>
+        </p:nvSpPr>
+        <p:spPr>
+          <a:xfrm>
+            <a:off x="960120" y="2194560"/>
+            <a:ext cx="10271455" cy="567690"/>
+          </a:xfrm>
+          <a:prstGeom prst="rect">
+            <a:avLst/>
+          </a:prstGeom>
+          <a:noFill/>
+          <a:ln/>
+        </p:spPr>
+        <p:txBody>
+          <a:bodyPr wrap="square" lIns="0" tIns="0" rIns="0" bIns="0" rtlCol="0" anchor="t"/>
+          <a:lstStyle/>
+          <a:p>
+            <a:pPr indent="0" marL="0">
+              <a:lnSpc>
+                <a:spcPct val="125000"/>
+              </a:lnSpc>
+              <a:buNone/>
+            </a:pPr>
+            <a:r>
+              <a:rPr lang="en-US" sz="1250" dirty="0">
+                <a:solidFill>
+                  <a:srgbClr val="C9D3F5"/>
+                </a:solidFill>
+                <a:latin typeface="Courier New" pitchFamily="34" charset="0"/>
+                <a:ea typeface="Courier New" pitchFamily="34" charset="-122"/>
+                <a:cs typeface="Courier New" pitchFamily="34" charset="-120"/>
+              </a:rPr>
+              <a:t>box-shadow: 0 1px 2px #000, 0 0 20px gold;</a:t>
+            </a:r>
+            <a:endParaRPr lang="en-US" sz="1250" dirty="0"/>
+          </a:p>
+          <a:p>
+            <a:pPr indent="0" marL="0">
+              <a:lnSpc>
+                <a:spcPct val="125000"/>
+              </a:lnSpc>
+              <a:buNone/>
+            </a:pPr>
+            <a:r>
+              <a:rPr lang="en-US" sz="1250" dirty="0">
+                <a:solidFill>
+                  <a:srgbClr val="C9D3F5"/>
+                </a:solidFill>
+                <a:latin typeface="Courier New" pitchFamily="34" charset="0"/>
+                <a:ea typeface="Courier New" pitchFamily="34" charset="-122"/>
+                <a:cs typeface="Courier New" pitchFamily="34" charset="-120"/>
+              </a:rPr>
+              <a:t>/* stack shadows by separating them with commas */</a:t>
+            </a:r>
+            <a:endParaRPr lang="en-US" sz="1250" dirty="0"/>
+          </a:p>
+        </p:txBody>
+      </p:sp>
+      <p:sp>
+        <p:nvSpPr>
+          <p:cNvPr id="6" name="Shape 4"/>
+          <p:cNvSpPr/>
+          <p:nvPr/>
+        </p:nvSpPr>
+        <p:spPr>
+          <a:xfrm>
+            <a:off x="530352" y="3155442"/>
+            <a:ext cx="11130991" cy="3172206"/>
+          </a:xfrm>
+          <a:prstGeom prst="roundRect">
+            <a:avLst>
+              <a:gd name="adj" fmla="val 1730"/>
             </a:avLst>
           </a:prstGeom>
           <a:solidFill>
@@ -3364,7 +3409,7 @@
       </p:sp>
       <p:pic>
         <p:nvPicPr>
-          <p:cNvPr id="6" name="Image 0" descr="D:/GitHub/mern-web-book/docs/assets/img/lecture-08/multiple-shadows-glow.png">    </p:cNvPr>
+          <p:cNvPr id="7" name="Image 0" descr="D:/GitHub/mern-web-book/docs/assets/img/lecture-08/multiple-shadows-glow.png">    </p:cNvPr>
           <p:cNvPicPr>
             <a:picLocks noChangeAspect="1"/>
           </p:cNvPicPr>
@@ -3378,8 +3423,8 @@
         </p:blipFill>
         <p:spPr>
           <a:xfrm>
-            <a:off x="3680700" y="2331720"/>
-            <a:ext cx="4830294" cy="3840480"/>
+            <a:off x="4238964" y="3265170"/>
+            <a:ext cx="3713768" cy="2952750"/>
           </a:xfrm>
           <a:prstGeom prst="rect">
             <a:avLst/>
@@ -3388,7 +3433,7 @@
       </p:pic>
       <p:sp>
         <p:nvSpPr>
-          <p:cNvPr id="7" name="Text 4"/>
+          <p:cNvPr id="8" name="Text 5"/>
           <p:cNvSpPr txBox="1"/>
           <p:nvPr/>
         </p:nvSpPr>
@@ -3427,7 +3472,7 @@
       </p:sp>
       <p:sp>
         <p:nvSpPr>
-          <p:cNvPr id="8" name="Text 5"/>
+          <p:cNvPr id="9" name="Text 6"/>
           <p:cNvSpPr txBox="1"/>
           <p:nvPr/>
         </p:nvSpPr>
@@ -3607,7 +3652,7 @@
                 <a:ea typeface="Calibri" pitchFamily="34" charset="-122"/>
                 <a:cs typeface="Calibri" pitchFamily="34" charset="-120"/>
               </a:rPr>
-              <a:t>.faded { opacity: 0.5; } — fades EVERYTHING inside, including text; use rgba() for a transparent background with solid text.</a:t>
+              <a:t>opacity fades EVERYTHING inside, including text; use rgba() for a transparent background with solid text.</a:t>
             </a:r>
             <a:endParaRPr lang="en-US" sz="1350" dirty="0"/>
           </a:p>
@@ -3621,12 +3666,116 @@
         </p:nvSpPr>
         <p:spPr>
           <a:xfrm>
-            <a:off x="530352" y="2221992"/>
-            <a:ext cx="11130991" cy="4059936"/>
+            <a:off x="640080" y="2240280"/>
+            <a:ext cx="10911535" cy="1263015"/>
           </a:xfrm>
           <a:prstGeom prst="roundRect">
             <a:avLst>
-              <a:gd name="adj" fmla="val 1351"/>
+              <a:gd name="adj" fmla="val 5792"/>
+            </a:avLst>
+          </a:prstGeom>
+          <a:solidFill>
+            <a:srgbClr val="1E1E4C"/>
+          </a:solidFill>
+          <a:ln/>
+        </p:spPr>
+      </p:sp>
+      <p:sp>
+        <p:nvSpPr>
+          <p:cNvPr id="6" name="Text 4"/>
+          <p:cNvSpPr txBox="1"/>
+          <p:nvPr/>
+        </p:nvSpPr>
+        <p:spPr>
+          <a:xfrm>
+            <a:off x="960120" y="2468880"/>
+            <a:ext cx="10271455" cy="805815"/>
+          </a:xfrm>
+          <a:prstGeom prst="rect">
+            <a:avLst/>
+          </a:prstGeom>
+          <a:noFill/>
+          <a:ln/>
+        </p:spPr>
+        <p:txBody>
+          <a:bodyPr wrap="square" lIns="0" tIns="0" rIns="0" bIns="0" rtlCol="0" anchor="t"/>
+          <a:lstStyle/>
+          <a:p>
+            <a:pPr indent="0" marL="0">
+              <a:lnSpc>
+                <a:spcPct val="125000"/>
+              </a:lnSpc>
+              <a:buNone/>
+            </a:pPr>
+            <a:r>
+              <a:rPr lang="en-US" sz="1250" dirty="0">
+                <a:solidFill>
+                  <a:srgbClr val="C9D3F5"/>
+                </a:solidFill>
+                <a:latin typeface="Courier New" pitchFamily="34" charset="0"/>
+                <a:ea typeface="Courier New" pitchFamily="34" charset="-122"/>
+                <a:cs typeface="Courier New" pitchFamily="34" charset="-120"/>
+              </a:rPr>
+              <a:t>.faded {</a:t>
+            </a:r>
+            <a:endParaRPr lang="en-US" sz="1250" dirty="0"/>
+          </a:p>
+          <a:p>
+            <a:pPr indent="0" marL="0">
+              <a:lnSpc>
+                <a:spcPct val="125000"/>
+              </a:lnSpc>
+              <a:buNone/>
+            </a:pPr>
+            <a:r>
+              <a:rPr lang="en-US" sz="1250" dirty="0">
+                <a:solidFill>
+                  <a:srgbClr val="C9D3F5"/>
+                </a:solidFill>
+                <a:latin typeface="Courier New" pitchFamily="34" charset="0"/>
+                <a:ea typeface="Courier New" pitchFamily="34" charset="-122"/>
+                <a:cs typeface="Courier New" pitchFamily="34" charset="-120"/>
+              </a:rPr>
+              <a:t>  opacity: 0.5; /* 50% transparent */</a:t>
+            </a:r>
+            <a:endParaRPr lang="en-US" sz="1250" dirty="0"/>
+          </a:p>
+          <a:p>
+            <a:pPr indent="0" marL="0">
+              <a:lnSpc>
+                <a:spcPct val="125000"/>
+              </a:lnSpc>
+              <a:buNone/>
+            </a:pPr>
+            <a:r>
+              <a:rPr lang="en-US" sz="1250" dirty="0">
+                <a:solidFill>
+                  <a:srgbClr val="C9D3F5"/>
+                </a:solidFill>
+                <a:latin typeface="Courier New" pitchFamily="34" charset="0"/>
+                <a:ea typeface="Courier New" pitchFamily="34" charset="-122"/>
+                <a:cs typeface="Courier New" pitchFamily="34" charset="-120"/>
+              </a:rPr>
+              <a:t>}</a:t>
+            </a:r>
+            <a:endParaRPr lang="en-US" sz="1250" dirty="0"/>
+          </a:p>
+        </p:txBody>
+      </p:sp>
+      <p:sp>
+        <p:nvSpPr>
+          <p:cNvPr id="7" name="Shape 5"/>
+          <p:cNvSpPr/>
+          <p:nvPr/>
+        </p:nvSpPr>
+        <p:spPr>
+          <a:xfrm>
+            <a:off x="530352" y="3667887"/>
+            <a:ext cx="11130991" cy="2659761"/>
+          </a:xfrm>
+          <a:prstGeom prst="roundRect">
+            <a:avLst>
+              <a:gd name="adj" fmla="val 2063"/>
             </a:avLst>
           </a:prstGeom>
           <a:solidFill>
@@ -3649,7 +3798,7 @@
       </p:sp>
       <p:pic>
         <p:nvPicPr>
-          <p:cNvPr id="6" name="Image 0" descr="D:/GitHub/mern-web-book/docs/assets/img/lecture-08/opacity-comparison.png">    </p:cNvPr>
+          <p:cNvPr id="8" name="Image 0" descr="D:/GitHub/mern-web-book/docs/assets/img/lecture-08/opacity-comparison.png">    </p:cNvPr>
           <p:cNvPicPr>
             <a:picLocks noChangeAspect="1"/>
           </p:cNvPicPr>
@@ -3663,8 +3812,8 @@
         </p:blipFill>
         <p:spPr>
           <a:xfrm>
-            <a:off x="1860024" y="2331720"/>
-            <a:ext cx="8471647" cy="3840480"/>
+            <a:off x="3404335" y="3777615"/>
+            <a:ext cx="5383026" cy="2440305"/>
           </a:xfrm>
           <a:prstGeom prst="rect">
             <a:avLst/>
@@ -3673,7 +3822,7 @@
       </p:pic>
       <p:sp>
         <p:nvSpPr>
-          <p:cNvPr id="7" name="Text 4"/>
+          <p:cNvPr id="9" name="Text 6"/>
           <p:cNvSpPr txBox="1"/>
           <p:nvPr/>
         </p:nvSpPr>
@@ -3712,7 +3861,7 @@
       </p:sp>
       <p:sp>
         <p:nvSpPr>
-          <p:cNvPr id="8" name="Text 5"/>
+          <p:cNvPr id="10" name="Text 7"/>
           <p:cNvSpPr txBox="1"/>
           <p:nvPr/>
         </p:nvSpPr>
@@ -4775,12 +4924,156 @@
         </p:nvSpPr>
         <p:spPr>
           <a:xfrm>
-            <a:off x="530352" y="1947672"/>
-            <a:ext cx="11130991" cy="4334256"/>
+            <a:off x="640080" y="1965960"/>
+            <a:ext cx="10911535" cy="1739265"/>
           </a:xfrm>
           <a:prstGeom prst="roundRect">
             <a:avLst>
-              <a:gd name="adj" fmla="val 1266"/>
+              <a:gd name="adj" fmla="val 4206"/>
+            </a:avLst>
+          </a:prstGeom>
+          <a:solidFill>
+            <a:srgbClr val="1E1E4C"/>
+          </a:solidFill>
+          <a:ln/>
+        </p:spPr>
+      </p:sp>
+      <p:sp>
+        <p:nvSpPr>
+          <p:cNvPr id="5" name="Text 3"/>
+          <p:cNvSpPr txBox="1"/>
+          <p:nvPr/>
+        </p:nvSpPr>
+        <p:spPr>
+          <a:xfrm>
+            <a:off x="960120" y="2194560"/>
+            <a:ext cx="10271455" cy="1282065"/>
+          </a:xfrm>
+          <a:prstGeom prst="rect">
+            <a:avLst/>
+          </a:prstGeom>
+          <a:noFill/>
+          <a:ln/>
+        </p:spPr>
+        <p:txBody>
+          <a:bodyPr wrap="square" lIns="0" tIns="0" rIns="0" bIns="0" rtlCol="0" anchor="t"/>
+          <a:lstStyle/>
+          <a:p>
+            <a:pPr indent="0" marL="0">
+              <a:lnSpc>
+                <a:spcPct val="125000"/>
+              </a:lnSpc>
+              <a:buNone/>
+            </a:pPr>
+            <a:r>
+              <a:rPr lang="en-US" sz="1250" dirty="0">
+                <a:solidFill>
+                  <a:srgbClr val="C9D3F5"/>
+                </a:solidFill>
+                <a:latin typeface="Courier New" pitchFamily="34" charset="0"/>
+                <a:ea typeface="Courier New" pitchFamily="34" charset="-122"/>
+                <a:cs typeface="Courier New" pitchFamily="34" charset="-120"/>
+              </a:rPr>
+              <a:t>.box  { transform: rotate(15deg); }</a:t>
+            </a:r>
+            <a:endParaRPr lang="en-US" sz="1250" dirty="0"/>
+          </a:p>
+          <a:p>
+            <a:pPr indent="0" marL="0">
+              <a:lnSpc>
+                <a:spcPct val="125000"/>
+              </a:lnSpc>
+              <a:buNone/>
+            </a:pPr>
+            <a:r>
+              <a:rPr lang="en-US" sz="1250" dirty="0">
+                <a:solidFill>
+                  <a:srgbClr val="C9D3F5"/>
+                </a:solidFill>
+                <a:latin typeface="Courier New" pitchFamily="34" charset="0"/>
+                <a:ea typeface="Courier New" pitchFamily="34" charset="-122"/>
+                <a:cs typeface="Courier New" pitchFamily="34" charset="-120"/>
+              </a:rPr>
+              <a:t>.box2 { transform: scale(1.2); }</a:t>
+            </a:r>
+            <a:endParaRPr lang="en-US" sz="1250" dirty="0"/>
+          </a:p>
+          <a:p>
+            <a:pPr indent="0" marL="0">
+              <a:lnSpc>
+                <a:spcPct val="125000"/>
+              </a:lnSpc>
+              <a:buNone/>
+            </a:pPr>
+            <a:r>
+              <a:rPr lang="en-US" sz="1250" dirty="0">
+                <a:solidFill>
+                  <a:srgbClr val="C9D3F5"/>
+                </a:solidFill>
+                <a:latin typeface="Courier New" pitchFamily="34" charset="0"/>
+                <a:ea typeface="Courier New" pitchFamily="34" charset="-122"/>
+                <a:cs typeface="Courier New" pitchFamily="34" charset="-120"/>
+              </a:rPr>
+              <a:t>.box3 { transform: translate(50px, 20px); }</a:t>
+            </a:r>
+            <a:endParaRPr lang="en-US" sz="1250" dirty="0"/>
+          </a:p>
+          <a:p>
+            <a:pPr indent="0" marL="0">
+              <a:lnSpc>
+                <a:spcPct val="125000"/>
+              </a:lnSpc>
+              <a:buNone/>
+            </a:pPr>
+            <a:r>
+              <a:rPr lang="en-US" sz="1250" dirty="0">
+                <a:solidFill>
+                  <a:srgbClr val="C9D3F5"/>
+                </a:solidFill>
+                <a:latin typeface="Courier New" pitchFamily="34" charset="0"/>
+                <a:ea typeface="Courier New" pitchFamily="34" charset="-122"/>
+                <a:cs typeface="Courier New" pitchFamily="34" charset="-120"/>
+              </a:rPr>
+              <a:t>.box4 { transform: skew(10deg, 0deg); }</a:t>
+            </a:r>
+            <a:endParaRPr lang="en-US" sz="1250" dirty="0"/>
+          </a:p>
+          <a:p>
+            <a:pPr indent="0" marL="0">
+              <a:lnSpc>
+                <a:spcPct val="125000"/>
+              </a:lnSpc>
+              <a:buNone/>
+            </a:pPr>
+            <a:r>
+              <a:rPr lang="en-US" sz="1250" dirty="0">
+                <a:solidFill>
+                  <a:srgbClr val="C9D3F5"/>
+                </a:solidFill>
+                <a:latin typeface="Courier New" pitchFamily="34" charset="0"/>
+                <a:ea typeface="Courier New" pitchFamily="34" charset="-122"/>
+                <a:cs typeface="Courier New" pitchFamily="34" charset="-120"/>
+              </a:rPr>
+              <a:t>.box5 { transform: translate(20px, 0) rotate(10deg) scale(1.1); }</a:t>
+            </a:r>
+            <a:endParaRPr lang="en-US" sz="1250" dirty="0"/>
+          </a:p>
+        </p:txBody>
+      </p:sp>
+      <p:sp>
+        <p:nvSpPr>
+          <p:cNvPr id="6" name="Shape 4"/>
+          <p:cNvSpPr/>
+          <p:nvPr/>
+        </p:nvSpPr>
+        <p:spPr>
+          <a:xfrm>
+            <a:off x="530352" y="3869817"/>
+            <a:ext cx="11130991" cy="2457831"/>
+          </a:xfrm>
+          <a:prstGeom prst="roundRect">
+            <a:avLst>
+              <a:gd name="adj" fmla="val 2232"/>
             </a:avLst>
           </a:prstGeom>
           <a:solidFill>
@@ -4803,7 +5096,7 @@
       </p:sp>
       <p:pic>
         <p:nvPicPr>
-          <p:cNvPr id="5" name="Image 0" descr="D:/GitHub/mern-web-book/docs/assets/img/lecture-08/transforms-2d-comparison.png">    </p:cNvPr>
+          <p:cNvPr id="7" name="Image 0" descr="D:/GitHub/mern-web-book/docs/assets/img/lecture-08/transforms-2d-comparison.png">    </p:cNvPr>
           <p:cNvPicPr>
             <a:picLocks noChangeAspect="1"/>
           </p:cNvPicPr>
@@ -4817,8 +5110,8 @@
         </p:blipFill>
         <p:spPr>
           <a:xfrm>
-            <a:off x="1856680" y="2057400"/>
-            <a:ext cx="8478336" cy="4114800"/>
+            <a:off x="3789819" y="3979545"/>
+            <a:ext cx="4612058" cy="2238375"/>
           </a:xfrm>
           <a:prstGeom prst="rect">
             <a:avLst/>
@@ -4827,7 +5120,7 @@
       </p:pic>
       <p:sp>
         <p:nvSpPr>
-          <p:cNvPr id="6" name="Text 3"/>
+          <p:cNvPr id="8" name="Text 5"/>
           <p:cNvSpPr txBox="1"/>
           <p:nvPr/>
         </p:nvSpPr>
@@ -4866,7 +5159,7 @@
       </p:sp>
       <p:sp>
         <p:nvSpPr>
-          <p:cNvPr id="7" name="Text 4"/>
+          <p:cNvPr id="9" name="Text 6"/>
           <p:cNvSpPr txBox="1"/>
           <p:nvPr/>
         </p:nvSpPr>
@@ -5015,57 +5308,191 @@
       </p:sp>
       <p:sp>
         <p:nvSpPr>
-          <p:cNvPr id="4" name="Text 2"/>
-          <p:cNvSpPr txBox="1"/>
-          <p:nvPr/>
-        </p:nvSpPr>
-        <p:spPr>
-          <a:xfrm>
-            <a:off x="640080" y="1691640"/>
-            <a:ext cx="10911535" cy="411480"/>
-          </a:xfrm>
-          <a:prstGeom prst="rect">
-            <a:avLst/>
-          </a:prstGeom>
-          <a:noFill/>
-          <a:ln/>
-        </p:spPr>
-        <p:txBody>
-          <a:bodyPr wrap="square" lIns="0" tIns="0" rIns="0" bIns="0" rtlCol="0" anchor="ctr"/>
-          <a:lstStyle/>
-          <a:p>
-            <a:pPr indent="0" marL="0">
-              <a:buNone/>
-            </a:pPr>
-            <a:r>
-              <a:rPr lang="en-US" sz="1350" i="1" dirty="0">
-                <a:solidFill>
-                  <a:srgbClr val="5D5D72"/>
-                </a:solidFill>
-                <a:latin typeface="Calibri" pitchFamily="34" charset="0"/>
-                <a:ea typeface="Calibri" pitchFamily="34" charset="-122"/>
-                <a:cs typeface="Calibri" pitchFamily="34" charset="-120"/>
-              </a:rPr>
-              <a:t>perspective: 800px on the parent, transform: rotateY(25deg) on the card, rotateY(0deg) on hover.</a:t>
-            </a:r>
-            <a:endParaRPr lang="en-US" sz="1350" dirty="0"/>
-          </a:p>
-        </p:txBody>
-      </p:sp>
-      <p:sp>
-        <p:nvSpPr>
-          <p:cNvPr id="5" name="Shape 3"/>
+          <p:cNvPr id="4" name="Shape 2"/>
           <p:cNvSpPr/>
           <p:nvPr/>
         </p:nvSpPr>
         <p:spPr>
           <a:xfrm>
-            <a:off x="530352" y="2221992"/>
-            <a:ext cx="11130991" cy="4059936"/>
+            <a:off x="640080" y="1965960"/>
+            <a:ext cx="10911535" cy="2215515"/>
           </a:xfrm>
           <a:prstGeom prst="roundRect">
             <a:avLst>
-              <a:gd name="adj" fmla="val 1351"/>
+              <a:gd name="adj" fmla="val 3302"/>
+            </a:avLst>
+          </a:prstGeom>
+          <a:solidFill>
+            <a:srgbClr val="1E1E4C"/>
+          </a:solidFill>
+          <a:ln/>
+        </p:spPr>
+      </p:sp>
+      <p:sp>
+        <p:nvSpPr>
+          <p:cNvPr id="5" name="Text 3"/>
+          <p:cNvSpPr txBox="1"/>
+          <p:nvPr/>
+        </p:nvSpPr>
+        <p:spPr>
+          <a:xfrm>
+            <a:off x="960120" y="2194560"/>
+            <a:ext cx="10271455" cy="1758315"/>
+          </a:xfrm>
+          <a:prstGeom prst="rect">
+            <a:avLst/>
+          </a:prstGeom>
+          <a:noFill/>
+          <a:ln/>
+        </p:spPr>
+        <p:txBody>
+          <a:bodyPr wrap="square" lIns="0" tIns="0" rIns="0" bIns="0" rtlCol="0" anchor="t"/>
+          <a:lstStyle/>
+          <a:p>
+            <a:pPr indent="0" marL="0">
+              <a:lnSpc>
+                <a:spcPct val="125000"/>
+              </a:lnSpc>
+              <a:buNone/>
+            </a:pPr>
+            <a:r>
+              <a:rPr lang="en-US" sz="1250" dirty="0">
+                <a:solidFill>
+                  <a:srgbClr val="C9D3F5"/>
+                </a:solidFill>
+                <a:latin typeface="Courier New" pitchFamily="34" charset="0"/>
+                <a:ea typeface="Courier New" pitchFamily="34" charset="-122"/>
+                <a:cs typeface="Courier New" pitchFamily="34" charset="-120"/>
+              </a:rPr>
+              <a:t>.scene { perspective: 800px; }</a:t>
+            </a:r>
+            <a:endParaRPr lang="en-US" sz="1250" dirty="0"/>
+          </a:p>
+          <a:p>
+            <a:pPr indent="0" marL="0">
+              <a:lnSpc>
+                <a:spcPct val="125000"/>
+              </a:lnSpc>
+              <a:buNone/>
+            </a:pPr>
+            <a:endParaRPr lang="en-US" sz="1250" dirty="0"/>
+          </a:p>
+          <a:p>
+            <a:pPr indent="0" marL="0">
+              <a:lnSpc>
+                <a:spcPct val="125000"/>
+              </a:lnSpc>
+              <a:buNone/>
+            </a:pPr>
+            <a:r>
+              <a:rPr lang="en-US" sz="1250" dirty="0">
+                <a:solidFill>
+                  <a:srgbClr val="C9D3F5"/>
+                </a:solidFill>
+                <a:latin typeface="Courier New" pitchFamily="34" charset="0"/>
+                <a:ea typeface="Courier New" pitchFamily="34" charset="-122"/>
+                <a:cs typeface="Courier New" pitchFamily="34" charset="-120"/>
+              </a:rPr>
+              <a:t>.card-3d {</a:t>
+            </a:r>
+            <a:endParaRPr lang="en-US" sz="1250" dirty="0"/>
+          </a:p>
+          <a:p>
+            <a:pPr indent="0" marL="0">
+              <a:lnSpc>
+                <a:spcPct val="125000"/>
+              </a:lnSpc>
+              <a:buNone/>
+            </a:pPr>
+            <a:r>
+              <a:rPr lang="en-US" sz="1250" dirty="0">
+                <a:solidFill>
+                  <a:srgbClr val="C9D3F5"/>
+                </a:solidFill>
+                <a:latin typeface="Courier New" pitchFamily="34" charset="0"/>
+                <a:ea typeface="Courier New" pitchFamily="34" charset="-122"/>
+                <a:cs typeface="Courier New" pitchFamily="34" charset="-120"/>
+              </a:rPr>
+              <a:t>  transform: rotateY(25deg);</a:t>
+            </a:r>
+            <a:endParaRPr lang="en-US" sz="1250" dirty="0"/>
+          </a:p>
+          <a:p>
+            <a:pPr indent="0" marL="0">
+              <a:lnSpc>
+                <a:spcPct val="125000"/>
+              </a:lnSpc>
+              <a:buNone/>
+            </a:pPr>
+            <a:r>
+              <a:rPr lang="en-US" sz="1250" dirty="0">
+                <a:solidFill>
+                  <a:srgbClr val="C9D3F5"/>
+                </a:solidFill>
+                <a:latin typeface="Courier New" pitchFamily="34" charset="0"/>
+                <a:ea typeface="Courier New" pitchFamily="34" charset="-122"/>
+                <a:cs typeface="Courier New" pitchFamily="34" charset="-120"/>
+              </a:rPr>
+              <a:t>  transition: transform 0.4s ease;</a:t>
+            </a:r>
+            <a:endParaRPr lang="en-US" sz="1250" dirty="0"/>
+          </a:p>
+          <a:p>
+            <a:pPr indent="0" marL="0">
+              <a:lnSpc>
+                <a:spcPct val="125000"/>
+              </a:lnSpc>
+              <a:buNone/>
+            </a:pPr>
+            <a:r>
+              <a:rPr lang="en-US" sz="1250" dirty="0">
+                <a:solidFill>
+                  <a:srgbClr val="C9D3F5"/>
+                </a:solidFill>
+                <a:latin typeface="Courier New" pitchFamily="34" charset="0"/>
+                <a:ea typeface="Courier New" pitchFamily="34" charset="-122"/>
+                <a:cs typeface="Courier New" pitchFamily="34" charset="-120"/>
+              </a:rPr>
+              <a:t>}</a:t>
+            </a:r>
+            <a:endParaRPr lang="en-US" sz="1250" dirty="0"/>
+          </a:p>
+          <a:p>
+            <a:pPr indent="0" marL="0">
+              <a:lnSpc>
+                <a:spcPct val="125000"/>
+              </a:lnSpc>
+              <a:buNone/>
+            </a:pPr>
+            <a:r>
+              <a:rPr lang="en-US" sz="1250" dirty="0">
+                <a:solidFill>
+                  <a:srgbClr val="C9D3F5"/>
+                </a:solidFill>
+                <a:latin typeface="Courier New" pitchFamily="34" charset="0"/>
+                <a:ea typeface="Courier New" pitchFamily="34" charset="-122"/>
+                <a:cs typeface="Courier New" pitchFamily="34" charset="-120"/>
+              </a:rPr>
+              <a:t>.card-3d:hover { transform: rotateY(0deg); }</a:t>
+            </a:r>
+            <a:endParaRPr lang="en-US" sz="1250" dirty="0"/>
+          </a:p>
+        </p:txBody>
+      </p:sp>
+      <p:sp>
+        <p:nvSpPr>
+          <p:cNvPr id="6" name="Shape 4"/>
+          <p:cNvSpPr/>
+          <p:nvPr/>
+        </p:nvSpPr>
+        <p:spPr>
+          <a:xfrm>
+            <a:off x="530352" y="4346067"/>
+            <a:ext cx="11130991" cy="1981581"/>
+          </a:xfrm>
+          <a:prstGeom prst="roundRect">
+            <a:avLst>
+              <a:gd name="adj" fmla="val 2769"/>
             </a:avLst>
           </a:prstGeom>
           <a:solidFill>
@@ -5088,7 +5515,7 @@
       </p:sp>
       <p:pic>
         <p:nvPicPr>
-          <p:cNvPr id="6" name="Image 0" descr="D:/GitHub/mern-web-book/slides/assets/lecture-08/card3d.png">    </p:cNvPr>
+          <p:cNvPr id="7" name="Image 0" descr="D:/GitHub/mern-web-book/slides/assets/lecture-08/card3d.png">    </p:cNvPr>
           <p:cNvPicPr>
             <a:picLocks noChangeAspect="1"/>
           </p:cNvPicPr>
@@ -5102,8 +5529,8 @@
         </p:blipFill>
         <p:spPr>
           <a:xfrm>
-            <a:off x="859365" y="2331720"/>
-            <a:ext cx="10472965" cy="3840480"/>
+            <a:off x="3693196" y="4455795"/>
+            <a:ext cx="4805304" cy="1762125"/>
           </a:xfrm>
           <a:prstGeom prst="rect">
             <a:avLst/>
@@ -5112,7 +5539,7 @@
       </p:pic>
       <p:sp>
         <p:nvSpPr>
-          <p:cNvPr id="7" name="Text 4"/>
+          <p:cNvPr id="8" name="Text 5"/>
           <p:cNvSpPr txBox="1"/>
           <p:nvPr/>
         </p:nvSpPr>
@@ -5151,7 +5578,7 @@
       </p:sp>
       <p:sp>
         <p:nvSpPr>
-          <p:cNvPr id="8" name="Text 5"/>
+          <p:cNvPr id="9" name="Text 6"/>
           <p:cNvSpPr txBox="1"/>
           <p:nvPr/>
         </p:nvSpPr>
@@ -5300,57 +5727,222 @@
       </p:sp>
       <p:sp>
         <p:nvSpPr>
-          <p:cNvPr id="4" name="Text 2"/>
-          <p:cNvSpPr txBox="1"/>
-          <p:nvPr/>
-        </p:nvSpPr>
-        <p:spPr>
-          <a:xfrm>
-            <a:off x="640080" y="1691640"/>
-            <a:ext cx="10911535" cy="411480"/>
-          </a:xfrm>
-          <a:prstGeom prst="rect">
-            <a:avLst/>
-          </a:prstGeom>
-          <a:noFill/>
-          <a:ln/>
-        </p:spPr>
-        <p:txBody>
-          <a:bodyPr wrap="square" lIns="0" tIns="0" rIns="0" bIns="0" rtlCol="0" anchor="ctr"/>
-          <a:lstStyle/>
-          <a:p>
-            <a:pPr indent="0" marL="0">
-              <a:buNone/>
-            </a:pPr>
-            <a:r>
-              <a:rPr lang="en-US" sz="1350" i="1" dirty="0">
-                <a:solidFill>
-                  <a:srgbClr val="5D5D72"/>
-                </a:solidFill>
-                <a:latin typeface="Calibri" pitchFamily="34" charset="0"/>
-                <a:ea typeface="Calibri" pitchFamily="34" charset="-122"/>
-                <a:cs typeface="Calibri" pitchFamily="34" charset="-120"/>
-              </a:rPr>
-              <a:t>transition: background-color 0.3s ease, transform 0.3s ease; — the button genuinely animates on the live page.</a:t>
-            </a:r>
-            <a:endParaRPr lang="en-US" sz="1350" dirty="0"/>
-          </a:p>
-        </p:txBody>
-      </p:sp>
-      <p:sp>
-        <p:nvSpPr>
-          <p:cNvPr id="5" name="Shape 3"/>
+          <p:cNvPr id="4" name="Shape 2"/>
           <p:cNvSpPr/>
           <p:nvPr/>
         </p:nvSpPr>
         <p:spPr>
           <a:xfrm>
-            <a:off x="530352" y="2221992"/>
-            <a:ext cx="11130991" cy="4059936"/>
+            <a:off x="640080" y="1965960"/>
+            <a:ext cx="10911535" cy="2453640"/>
           </a:xfrm>
           <a:prstGeom prst="roundRect">
             <a:avLst>
-              <a:gd name="adj" fmla="val 1351"/>
+              <a:gd name="adj" fmla="val 2981"/>
+            </a:avLst>
+          </a:prstGeom>
+          <a:solidFill>
+            <a:srgbClr val="1E1E4C"/>
+          </a:solidFill>
+          <a:ln/>
+        </p:spPr>
+      </p:sp>
+      <p:sp>
+        <p:nvSpPr>
+          <p:cNvPr id="5" name="Text 3"/>
+          <p:cNvSpPr txBox="1"/>
+          <p:nvPr/>
+        </p:nvSpPr>
+        <p:spPr>
+          <a:xfrm>
+            <a:off x="960120" y="2194560"/>
+            <a:ext cx="10271455" cy="1996440"/>
+          </a:xfrm>
+          <a:prstGeom prst="rect">
+            <a:avLst/>
+          </a:prstGeom>
+          <a:noFill/>
+          <a:ln/>
+        </p:spPr>
+        <p:txBody>
+          <a:bodyPr wrap="square" lIns="0" tIns="0" rIns="0" bIns="0" rtlCol="0" anchor="t"/>
+          <a:lstStyle/>
+          <a:p>
+            <a:pPr indent="0" marL="0">
+              <a:lnSpc>
+                <a:spcPct val="125000"/>
+              </a:lnSpc>
+              <a:buNone/>
+            </a:pPr>
+            <a:r>
+              <a:rPr lang="en-US" sz="1250" dirty="0">
+                <a:solidFill>
+                  <a:srgbClr val="C9D3F5"/>
+                </a:solidFill>
+                <a:latin typeface="Courier New" pitchFamily="34" charset="0"/>
+                <a:ea typeface="Courier New" pitchFamily="34" charset="-122"/>
+                <a:cs typeface="Courier New" pitchFamily="34" charset="-120"/>
+              </a:rPr>
+              <a:t>button {</a:t>
+            </a:r>
+            <a:endParaRPr lang="en-US" sz="1250" dirty="0"/>
+          </a:p>
+          <a:p>
+            <a:pPr indent="0" marL="0">
+              <a:lnSpc>
+                <a:spcPct val="125000"/>
+              </a:lnSpc>
+              <a:buNone/>
+            </a:pPr>
+            <a:r>
+              <a:rPr lang="en-US" sz="1250" dirty="0">
+                <a:solidFill>
+                  <a:srgbClr val="C9D3F5"/>
+                </a:solidFill>
+                <a:latin typeface="Courier New" pitchFamily="34" charset="0"/>
+                <a:ea typeface="Courier New" pitchFamily="34" charset="-122"/>
+                <a:cs typeface="Courier New" pitchFamily="34" charset="-120"/>
+              </a:rPr>
+              <a:t>  background-color: royalblue;</a:t>
+            </a:r>
+            <a:endParaRPr lang="en-US" sz="1250" dirty="0"/>
+          </a:p>
+          <a:p>
+            <a:pPr indent="0" marL="0">
+              <a:lnSpc>
+                <a:spcPct val="125000"/>
+              </a:lnSpc>
+              <a:buNone/>
+            </a:pPr>
+            <a:r>
+              <a:rPr lang="en-US" sz="1250" dirty="0">
+                <a:solidFill>
+                  <a:srgbClr val="C9D3F5"/>
+                </a:solidFill>
+                <a:latin typeface="Courier New" pitchFamily="34" charset="0"/>
+                <a:ea typeface="Courier New" pitchFamily="34" charset="-122"/>
+                <a:cs typeface="Courier New" pitchFamily="34" charset="-120"/>
+              </a:rPr>
+              <a:t>  transition: background-color 0.3s ease, transform 0.3s ease;</a:t>
+            </a:r>
+            <a:endParaRPr lang="en-US" sz="1250" dirty="0"/>
+          </a:p>
+          <a:p>
+            <a:pPr indent="0" marL="0">
+              <a:lnSpc>
+                <a:spcPct val="125000"/>
+              </a:lnSpc>
+              <a:buNone/>
+            </a:pPr>
+            <a:r>
+              <a:rPr lang="en-US" sz="1250" dirty="0">
+                <a:solidFill>
+                  <a:srgbClr val="C9D3F5"/>
+                </a:solidFill>
+                <a:latin typeface="Courier New" pitchFamily="34" charset="0"/>
+                <a:ea typeface="Courier New" pitchFamily="34" charset="-122"/>
+                <a:cs typeface="Courier New" pitchFamily="34" charset="-120"/>
+              </a:rPr>
+              <a:t>}</a:t>
+            </a:r>
+            <a:endParaRPr lang="en-US" sz="1250" dirty="0"/>
+          </a:p>
+          <a:p>
+            <a:pPr indent="0" marL="0">
+              <a:lnSpc>
+                <a:spcPct val="125000"/>
+              </a:lnSpc>
+              <a:buNone/>
+            </a:pPr>
+            <a:r>
+              <a:rPr lang="en-US" sz="1250" dirty="0">
+                <a:solidFill>
+                  <a:srgbClr val="C9D3F5"/>
+                </a:solidFill>
+                <a:latin typeface="Courier New" pitchFamily="34" charset="0"/>
+                <a:ea typeface="Courier New" pitchFamily="34" charset="-122"/>
+                <a:cs typeface="Courier New" pitchFamily="34" charset="-120"/>
+              </a:rPr>
+              <a:t>button:hover {</a:t>
+            </a:r>
+            <a:endParaRPr lang="en-US" sz="1250" dirty="0"/>
+          </a:p>
+          <a:p>
+            <a:pPr indent="0" marL="0">
+              <a:lnSpc>
+                <a:spcPct val="125000"/>
+              </a:lnSpc>
+              <a:buNone/>
+            </a:pPr>
+            <a:r>
+              <a:rPr lang="en-US" sz="1250" dirty="0">
+                <a:solidFill>
+                  <a:srgbClr val="C9D3F5"/>
+                </a:solidFill>
+                <a:latin typeface="Courier New" pitchFamily="34" charset="0"/>
+                <a:ea typeface="Courier New" pitchFamily="34" charset="-122"/>
+                <a:cs typeface="Courier New" pitchFamily="34" charset="-120"/>
+              </a:rPr>
+              <a:t>  background-color: darkblue;</a:t>
+            </a:r>
+            <a:endParaRPr lang="en-US" sz="1250" dirty="0"/>
+          </a:p>
+          <a:p>
+            <a:pPr indent="0" marL="0">
+              <a:lnSpc>
+                <a:spcPct val="125000"/>
+              </a:lnSpc>
+              <a:buNone/>
+            </a:pPr>
+            <a:r>
+              <a:rPr lang="en-US" sz="1250" dirty="0">
+                <a:solidFill>
+                  <a:srgbClr val="C9D3F5"/>
+                </a:solidFill>
+                <a:latin typeface="Courier New" pitchFamily="34" charset="0"/>
+                <a:ea typeface="Courier New" pitchFamily="34" charset="-122"/>
+                <a:cs typeface="Courier New" pitchFamily="34" charset="-120"/>
+              </a:rPr>
+              <a:t>  transform: scale(1.05);</a:t>
+            </a:r>
+            <a:endParaRPr lang="en-US" sz="1250" dirty="0"/>
+          </a:p>
+          <a:p>
+            <a:pPr indent="0" marL="0">
+              <a:lnSpc>
+                <a:spcPct val="125000"/>
+              </a:lnSpc>
+              <a:buNone/>
+            </a:pPr>
+            <a:r>
+              <a:rPr lang="en-US" sz="1250" dirty="0">
+                <a:solidFill>
+                  <a:srgbClr val="C9D3F5"/>
+                </a:solidFill>
+                <a:latin typeface="Courier New" pitchFamily="34" charset="0"/>
+                <a:ea typeface="Courier New" pitchFamily="34" charset="-122"/>
+                <a:cs typeface="Courier New" pitchFamily="34" charset="-120"/>
+              </a:rPr>
+              <a:t>}</a:t>
+            </a:r>
+            <a:endParaRPr lang="en-US" sz="1250" dirty="0"/>
+          </a:p>
+        </p:txBody>
+      </p:sp>
+      <p:sp>
+        <p:nvSpPr>
+          <p:cNvPr id="6" name="Shape 4"/>
+          <p:cNvSpPr/>
+          <p:nvPr/>
+        </p:nvSpPr>
+        <p:spPr>
+          <a:xfrm>
+            <a:off x="530352" y="4584192"/>
+            <a:ext cx="11130991" cy="1743456"/>
+          </a:xfrm>
+          <a:prstGeom prst="roundRect">
+            <a:avLst>
+              <a:gd name="adj" fmla="val 3147"/>
             </a:avLst>
           </a:prstGeom>
           <a:solidFill>
@@ -5373,7 +5965,7 @@
       </p:sp>
       <p:pic>
         <p:nvPicPr>
-          <p:cNvPr id="6" name="Image 0" descr="D:/GitHub/mern-web-book/slides/assets/lecture-08/transition-btn.png">    </p:cNvPr>
+          <p:cNvPr id="7" name="Image 0" descr="D:/GitHub/mern-web-book/slides/assets/lecture-08/transition-btn.png">    </p:cNvPr>
           <p:cNvPicPr>
             <a:picLocks noChangeAspect="1"/>
           </p:cNvPicPr>
@@ -5387,8 +5979,8 @@
         </p:blipFill>
         <p:spPr>
           <a:xfrm>
-            <a:off x="640080" y="2582508"/>
-            <a:ext cx="10911535" cy="3338903"/>
+            <a:off x="3605632" y="4693920"/>
+            <a:ext cx="4980432" cy="1524000"/>
           </a:xfrm>
           <a:prstGeom prst="rect">
             <a:avLst/>
@@ -5397,7 +5989,7 @@
       </p:pic>
       <p:sp>
         <p:nvSpPr>
-          <p:cNvPr id="7" name="Text 4"/>
+          <p:cNvPr id="8" name="Text 5"/>
           <p:cNvSpPr txBox="1"/>
           <p:nvPr/>
         </p:nvSpPr>
@@ -5436,7 +6028,7 @@
       </p:sp>
       <p:sp>
         <p:nvSpPr>
-          <p:cNvPr id="8" name="Text 5"/>
+          <p:cNvPr id="9" name="Text 6"/>
           <p:cNvSpPr txBox="1"/>
           <p:nvPr/>
         </p:nvSpPr>
@@ -5585,57 +6177,191 @@
       </p:sp>
       <p:sp>
         <p:nvSpPr>
-          <p:cNvPr id="4" name="Text 2"/>
-          <p:cNvSpPr txBox="1"/>
-          <p:nvPr/>
-        </p:nvSpPr>
-        <p:spPr>
-          <a:xfrm>
-            <a:off x="640080" y="1691640"/>
-            <a:ext cx="10911535" cy="411480"/>
-          </a:xfrm>
-          <a:prstGeom prst="rect">
-            <a:avLst/>
-          </a:prstGeom>
-          <a:noFill/>
-          <a:ln/>
-        </p:spPr>
-        <p:txBody>
-          <a:bodyPr wrap="square" lIns="0" tIns="0" rIns="0" bIns="0" rtlCol="0" anchor="ctr"/>
-          <a:lstStyle/>
-          <a:p>
-            <a:pPr indent="0" marL="0">
-              <a:buNone/>
-            </a:pPr>
-            <a:r>
-              <a:rPr lang="en-US" sz="1350" i="1" dirty="0">
-                <a:solidFill>
-                  <a:srgbClr val="5D5D72"/>
-                </a:solidFill>
-                <a:latin typeface="Calibri" pitchFamily="34" charset="0"/>
-                <a:ea typeface="Calibri" pitchFamily="34" charset="-122"/>
-                <a:cs typeface="Calibri" pitchFamily="34" charset="-120"/>
-              </a:rPr>
-              <a:t>animation: bounce 1s ease-in-out infinite; — shown here at its three keyframe positions.</a:t>
-            </a:r>
-            <a:endParaRPr lang="en-US" sz="1350" dirty="0"/>
-          </a:p>
-        </p:txBody>
-      </p:sp>
-      <p:sp>
-        <p:nvSpPr>
-          <p:cNvPr id="5" name="Shape 3"/>
+          <p:cNvPr id="4" name="Shape 2"/>
           <p:cNvSpPr/>
           <p:nvPr/>
         </p:nvSpPr>
         <p:spPr>
           <a:xfrm>
-            <a:off x="530352" y="2221992"/>
-            <a:ext cx="11130991" cy="4059936"/>
+            <a:off x="640080" y="1965960"/>
+            <a:ext cx="10911535" cy="2215515"/>
           </a:xfrm>
           <a:prstGeom prst="roundRect">
             <a:avLst>
-              <a:gd name="adj" fmla="val 1351"/>
+              <a:gd name="adj" fmla="val 3302"/>
+            </a:avLst>
+          </a:prstGeom>
+          <a:solidFill>
+            <a:srgbClr val="1E1E4C"/>
+          </a:solidFill>
+          <a:ln/>
+        </p:spPr>
+      </p:sp>
+      <p:sp>
+        <p:nvSpPr>
+          <p:cNvPr id="5" name="Text 3"/>
+          <p:cNvSpPr txBox="1"/>
+          <p:nvPr/>
+        </p:nvSpPr>
+        <p:spPr>
+          <a:xfrm>
+            <a:off x="960120" y="2194560"/>
+            <a:ext cx="10271455" cy="1758315"/>
+          </a:xfrm>
+          <a:prstGeom prst="rect">
+            <a:avLst/>
+          </a:prstGeom>
+          <a:noFill/>
+          <a:ln/>
+        </p:spPr>
+        <p:txBody>
+          <a:bodyPr wrap="square" lIns="0" tIns="0" rIns="0" bIns="0" rtlCol="0" anchor="t"/>
+          <a:lstStyle/>
+          <a:p>
+            <a:pPr indent="0" marL="0">
+              <a:lnSpc>
+                <a:spcPct val="125000"/>
+              </a:lnSpc>
+              <a:buNone/>
+            </a:pPr>
+            <a:r>
+              <a:rPr lang="en-US" sz="1250" dirty="0">
+                <a:solidFill>
+                  <a:srgbClr val="C9D3F5"/>
+                </a:solidFill>
+                <a:latin typeface="Courier New" pitchFamily="34" charset="0"/>
+                <a:ea typeface="Courier New" pitchFamily="34" charset="-122"/>
+                <a:cs typeface="Courier New" pitchFamily="34" charset="-120"/>
+              </a:rPr>
+              <a:t>@keyframes bounce {</a:t>
+            </a:r>
+            <a:endParaRPr lang="en-US" sz="1250" dirty="0"/>
+          </a:p>
+          <a:p>
+            <a:pPr indent="0" marL="0">
+              <a:lnSpc>
+                <a:spcPct val="125000"/>
+              </a:lnSpc>
+              <a:buNone/>
+            </a:pPr>
+            <a:r>
+              <a:rPr lang="en-US" sz="1250" dirty="0">
+                <a:solidFill>
+                  <a:srgbClr val="C9D3F5"/>
+                </a:solidFill>
+                <a:latin typeface="Courier New" pitchFamily="34" charset="0"/>
+                <a:ea typeface="Courier New" pitchFamily="34" charset="-122"/>
+                <a:cs typeface="Courier New" pitchFamily="34" charset="-120"/>
+              </a:rPr>
+              <a:t>  0%   { transform: translateY(0); }</a:t>
+            </a:r>
+            <a:endParaRPr lang="en-US" sz="1250" dirty="0"/>
+          </a:p>
+          <a:p>
+            <a:pPr indent="0" marL="0">
+              <a:lnSpc>
+                <a:spcPct val="125000"/>
+              </a:lnSpc>
+              <a:buNone/>
+            </a:pPr>
+            <a:r>
+              <a:rPr lang="en-US" sz="1250" dirty="0">
+                <a:solidFill>
+                  <a:srgbClr val="C9D3F5"/>
+                </a:solidFill>
+                <a:latin typeface="Courier New" pitchFamily="34" charset="0"/>
+                <a:ea typeface="Courier New" pitchFamily="34" charset="-122"/>
+                <a:cs typeface="Courier New" pitchFamily="34" charset="-120"/>
+              </a:rPr>
+              <a:t>  50%  { transform: translateY(-20px); }</a:t>
+            </a:r>
+            <a:endParaRPr lang="en-US" sz="1250" dirty="0"/>
+          </a:p>
+          <a:p>
+            <a:pPr indent="0" marL="0">
+              <a:lnSpc>
+                <a:spcPct val="125000"/>
+              </a:lnSpc>
+              <a:buNone/>
+            </a:pPr>
+            <a:r>
+              <a:rPr lang="en-US" sz="1250" dirty="0">
+                <a:solidFill>
+                  <a:srgbClr val="C9D3F5"/>
+                </a:solidFill>
+                <a:latin typeface="Courier New" pitchFamily="34" charset="0"/>
+                <a:ea typeface="Courier New" pitchFamily="34" charset="-122"/>
+                <a:cs typeface="Courier New" pitchFamily="34" charset="-120"/>
+              </a:rPr>
+              <a:t>  100% { transform: translateY(0); }</a:t>
+            </a:r>
+            <a:endParaRPr lang="en-US" sz="1250" dirty="0"/>
+          </a:p>
+          <a:p>
+            <a:pPr indent="0" marL="0">
+              <a:lnSpc>
+                <a:spcPct val="125000"/>
+              </a:lnSpc>
+              <a:buNone/>
+            </a:pPr>
+            <a:r>
+              <a:rPr lang="en-US" sz="1250" dirty="0">
+                <a:solidFill>
+                  <a:srgbClr val="C9D3F5"/>
+                </a:solidFill>
+                <a:latin typeface="Courier New" pitchFamily="34" charset="0"/>
+                <a:ea typeface="Courier New" pitchFamily="34" charset="-122"/>
+                <a:cs typeface="Courier New" pitchFamily="34" charset="-120"/>
+              </a:rPr>
+              <a:t>}</a:t>
+            </a:r>
+            <a:endParaRPr lang="en-US" sz="1250" dirty="0"/>
+          </a:p>
+          <a:p>
+            <a:pPr indent="0" marL="0">
+              <a:lnSpc>
+                <a:spcPct val="125000"/>
+              </a:lnSpc>
+              <a:buNone/>
+            </a:pPr>
+            <a:endParaRPr lang="en-US" sz="1250" dirty="0"/>
+          </a:p>
+          <a:p>
+            <a:pPr indent="0" marL="0">
+              <a:lnSpc>
+                <a:spcPct val="125000"/>
+              </a:lnSpc>
+              <a:buNone/>
+            </a:pPr>
+            <a:r>
+              <a:rPr lang="en-US" sz="1250" dirty="0">
+                <a:solidFill>
+                  <a:srgbClr val="C9D3F5"/>
+                </a:solidFill>
+                <a:latin typeface="Courier New" pitchFamily="34" charset="0"/>
+                <a:ea typeface="Courier New" pitchFamily="34" charset="-122"/>
+                <a:cs typeface="Courier New" pitchFamily="34" charset="-120"/>
+              </a:rPr>
+              <a:t>.ball { animation: bounce 1s ease-in-out infinite; }</a:t>
+            </a:r>
+            <a:endParaRPr lang="en-US" sz="1250" dirty="0"/>
+          </a:p>
+        </p:txBody>
+      </p:sp>
+      <p:sp>
+        <p:nvSpPr>
+          <p:cNvPr id="6" name="Shape 4"/>
+          <p:cNvSpPr/>
+          <p:nvPr/>
+        </p:nvSpPr>
+        <p:spPr>
+          <a:xfrm>
+            <a:off x="530352" y="4346067"/>
+            <a:ext cx="11130991" cy="1981581"/>
+          </a:xfrm>
+          <a:prstGeom prst="roundRect">
+            <a:avLst>
+              <a:gd name="adj" fmla="val 2769"/>
             </a:avLst>
           </a:prstGeom>
           <a:solidFill>
@@ -5658,7 +6384,7 @@
       </p:sp>
       <p:pic>
         <p:nvPicPr>
-          <p:cNvPr id="6" name="Image 0" descr="D:/GitHub/mern-web-book/slides/assets/lecture-08/bounce-frames.png">    </p:cNvPr>
+          <p:cNvPr id="7" name="Image 0" descr="D:/GitHub/mern-web-book/slides/assets/lecture-08/bounce-frames.png">    </p:cNvPr>
           <p:cNvPicPr>
             <a:picLocks noChangeAspect="1"/>
           </p:cNvPicPr>
@@ -5672,8 +6398,8 @@
         </p:blipFill>
         <p:spPr>
           <a:xfrm>
-            <a:off x="640080" y="2452474"/>
-            <a:ext cx="10911535" cy="3598973"/>
+            <a:off x="3424601" y="4455795"/>
+            <a:ext cx="5342494" cy="1762125"/>
           </a:xfrm>
           <a:prstGeom prst="rect">
             <a:avLst/>
@@ -5682,7 +6408,7 @@
       </p:pic>
       <p:sp>
         <p:nvSpPr>
-          <p:cNvPr id="7" name="Text 4"/>
+          <p:cNvPr id="8" name="Text 5"/>
           <p:cNvSpPr txBox="1"/>
           <p:nvPr/>
         </p:nvSpPr>
@@ -5721,7 +6447,7 @@
       </p:sp>
       <p:sp>
         <p:nvSpPr>
-          <p:cNvPr id="8" name="Text 5"/>
+          <p:cNvPr id="9" name="Text 6"/>
           <p:cNvSpPr txBox="1"/>
           <p:nvPr/>
         </p:nvSpPr>
@@ -8121,11 +8847,11 @@
         <p:spPr>
           <a:xfrm>
             <a:off x="640080" y="1965960"/>
-            <a:ext cx="10911535" cy="3291840"/>
+            <a:ext cx="10911535" cy="2948940"/>
           </a:xfrm>
           <a:prstGeom prst="roundRect">
             <a:avLst>
-              <a:gd name="adj" fmla="val 2222"/>
+              <a:gd name="adj" fmla="val 2481"/>
             </a:avLst>
           </a:prstGeom>
           <a:solidFill>
@@ -8143,7 +8869,7 @@
         <p:spPr>
           <a:xfrm>
             <a:off x="960120" y="2194560"/>
-            <a:ext cx="10271455" cy="2834640"/>
+            <a:ext cx="10271455" cy="2491740"/>
           </a:xfrm>
           <a:prstGeom prst="rect">
             <a:avLst/>
@@ -8333,8 +9059,8 @@
         </p:nvSpPr>
         <p:spPr>
           <a:xfrm>
-            <a:off x="640080" y="5486400"/>
-            <a:ext cx="10911535" cy="777240"/>
+            <a:off x="640080" y="5143500"/>
+            <a:ext cx="10911535" cy="1120140"/>
           </a:xfrm>
           <a:prstGeom prst="rect">
             <a:avLst/>
@@ -10934,11 +11660,11 @@
         <p:spPr>
           <a:xfrm>
             <a:off x="640080" y="1965960"/>
-            <a:ext cx="10911535" cy="1837944"/>
+            <a:ext cx="10911535" cy="1348740"/>
           </a:xfrm>
           <a:prstGeom prst="roundRect">
             <a:avLst>
-              <a:gd name="adj" fmla="val 3980"/>
+              <a:gd name="adj" fmla="val 5424"/>
             </a:avLst>
           </a:prstGeom>
           <a:solidFill>
@@ -10956,7 +11682,7 @@
         <p:spPr>
           <a:xfrm>
             <a:off x="960120" y="2194560"/>
-            <a:ext cx="10271455" cy="1380744"/>
+            <a:ext cx="10271455" cy="891540"/>
           </a:xfrm>
           <a:prstGeom prst="rect">
             <a:avLst/>
@@ -11037,8 +11763,8 @@
         </p:nvSpPr>
         <p:spPr>
           <a:xfrm>
-            <a:off x="640080" y="4032504"/>
-            <a:ext cx="10911535" cy="2231136"/>
+            <a:off x="640080" y="3543300"/>
+            <a:ext cx="10911535" cy="2720340"/>
           </a:xfrm>
           <a:prstGeom prst="rect">
             <a:avLst/>
@@ -11511,11 +12237,11 @@
         <p:spPr>
           <a:xfrm>
             <a:off x="640080" y="1965960"/>
-            <a:ext cx="10911535" cy="1837944"/>
+            <a:ext cx="10911535" cy="1348740"/>
           </a:xfrm>
           <a:prstGeom prst="roundRect">
             <a:avLst>
-              <a:gd name="adj" fmla="val 3980"/>
+              <a:gd name="adj" fmla="val 5424"/>
             </a:avLst>
           </a:prstGeom>
           <a:solidFill>
@@ -11533,7 +12259,7 @@
         <p:spPr>
           <a:xfrm>
             <a:off x="960120" y="2194560"/>
-            <a:ext cx="10271455" cy="1380744"/>
+            <a:ext cx="10271455" cy="891540"/>
           </a:xfrm>
           <a:prstGeom prst="rect">
             <a:avLst/>
@@ -12042,57 +12768,182 @@
       </p:sp>
       <p:sp>
         <p:nvSpPr>
-          <p:cNvPr id="4" name="Text 2"/>
-          <p:cNvSpPr txBox="1"/>
-          <p:nvPr/>
-        </p:nvSpPr>
-        <p:spPr>
-          <a:xfrm>
-            <a:off x="640080" y="1691640"/>
-            <a:ext cx="10911535" cy="411480"/>
-          </a:xfrm>
-          <a:prstGeom prst="rect">
-            <a:avLst/>
-          </a:prstGeom>
-          <a:noFill/>
-          <a:ln/>
-        </p:spPr>
-        <p:txBody>
-          <a:bodyPr wrap="square" lIns="0" tIns="0" rIns="0" bIns="0" rtlCol="0" anchor="ctr"/>
-          <a:lstStyle/>
-          <a:p>
-            <a:pPr indent="0" marL="0">
-              <a:buNone/>
-            </a:pPr>
-            <a:r>
-              <a:rPr lang="en-US" sz="1350" i="1" dirty="0">
-                <a:solidFill>
-                  <a:srgbClr val="5D5D72"/>
-                </a:solidFill>
-                <a:latin typeface="Calibri" pitchFamily="34" charset="0"/>
-                <a:ea typeface="Calibri" pitchFamily="34" charset="-122"/>
-                <a:cs typeface="Calibri" pitchFamily="34" charset="-120"/>
-              </a:rPr>
-              <a:t>linear-gradient(to right, red 0%, yellow 25%, green 50%, blue 75%, violet 100%)</a:t>
-            </a:r>
-            <a:endParaRPr lang="en-US" sz="1350" dirty="0"/>
-          </a:p>
-        </p:txBody>
-      </p:sp>
-      <p:sp>
-        <p:nvSpPr>
-          <p:cNvPr id="5" name="Shape 3"/>
+          <p:cNvPr id="4" name="Shape 2"/>
           <p:cNvSpPr/>
           <p:nvPr/>
         </p:nvSpPr>
         <p:spPr>
           <a:xfrm>
-            <a:off x="530352" y="2221992"/>
-            <a:ext cx="11130991" cy="4059936"/>
+            <a:off x="640080" y="1965960"/>
+            <a:ext cx="10911535" cy="1977390"/>
           </a:xfrm>
           <a:prstGeom prst="roundRect">
             <a:avLst>
-              <a:gd name="adj" fmla="val 1351"/>
+              <a:gd name="adj" fmla="val 3699"/>
+            </a:avLst>
+          </a:prstGeom>
+          <a:solidFill>
+            <a:srgbClr val="1E1E4C"/>
+          </a:solidFill>
+          <a:ln/>
+        </p:spPr>
+      </p:sp>
+      <p:sp>
+        <p:nvSpPr>
+          <p:cNvPr id="5" name="Text 3"/>
+          <p:cNvSpPr txBox="1"/>
+          <p:nvPr/>
+        </p:nvSpPr>
+        <p:spPr>
+          <a:xfrm>
+            <a:off x="960120" y="2194560"/>
+            <a:ext cx="10271455" cy="1520190"/>
+          </a:xfrm>
+          <a:prstGeom prst="rect">
+            <a:avLst/>
+          </a:prstGeom>
+          <a:noFill/>
+          <a:ln/>
+        </p:spPr>
+        <p:txBody>
+          <a:bodyPr wrap="square" lIns="0" tIns="0" rIns="0" bIns="0" rtlCol="0" anchor="t"/>
+          <a:lstStyle/>
+          <a:p>
+            <a:pPr indent="0" marL="0">
+              <a:lnSpc>
+                <a:spcPct val="125000"/>
+              </a:lnSpc>
+              <a:buNone/>
+            </a:pPr>
+            <a:r>
+              <a:rPr lang="en-US" sz="1250" dirty="0">
+                <a:solidFill>
+                  <a:srgbClr val="C9D3F5"/>
+                </a:solidFill>
+                <a:latin typeface="Courier New" pitchFamily="34" charset="0"/>
+                <a:ea typeface="Courier New" pitchFamily="34" charset="-122"/>
+                <a:cs typeface="Courier New" pitchFamily="34" charset="-120"/>
+              </a:rPr>
+              <a:t>.rainbow {</a:t>
+            </a:r>
+            <a:endParaRPr lang="en-US" sz="1250" dirty="0"/>
+          </a:p>
+          <a:p>
+            <a:pPr indent="0" marL="0">
+              <a:lnSpc>
+                <a:spcPct val="125000"/>
+              </a:lnSpc>
+              <a:buNone/>
+            </a:pPr>
+            <a:r>
+              <a:rPr lang="en-US" sz="1250" dirty="0">
+                <a:solidFill>
+                  <a:srgbClr val="C9D3F5"/>
+                </a:solidFill>
+                <a:latin typeface="Courier New" pitchFamily="34" charset="0"/>
+                <a:ea typeface="Courier New" pitchFamily="34" charset="-122"/>
+                <a:cs typeface="Courier New" pitchFamily="34" charset="-120"/>
+              </a:rPr>
+              <a:t>  background: linear-gradient(</a:t>
+            </a:r>
+            <a:endParaRPr lang="en-US" sz="1250" dirty="0"/>
+          </a:p>
+          <a:p>
+            <a:pPr indent="0" marL="0">
+              <a:lnSpc>
+                <a:spcPct val="125000"/>
+              </a:lnSpc>
+              <a:buNone/>
+            </a:pPr>
+            <a:r>
+              <a:rPr lang="en-US" sz="1250" dirty="0">
+                <a:solidFill>
+                  <a:srgbClr val="C9D3F5"/>
+                </a:solidFill>
+                <a:latin typeface="Courier New" pitchFamily="34" charset="0"/>
+                <a:ea typeface="Courier New" pitchFamily="34" charset="-122"/>
+                <a:cs typeface="Courier New" pitchFamily="34" charset="-120"/>
+              </a:rPr>
+              <a:t>    to right,</a:t>
+            </a:r>
+            <a:endParaRPr lang="en-US" sz="1250" dirty="0"/>
+          </a:p>
+          <a:p>
+            <a:pPr indent="0" marL="0">
+              <a:lnSpc>
+                <a:spcPct val="125000"/>
+              </a:lnSpc>
+              <a:buNone/>
+            </a:pPr>
+            <a:r>
+              <a:rPr lang="en-US" sz="1250" dirty="0">
+                <a:solidFill>
+                  <a:srgbClr val="C9D3F5"/>
+                </a:solidFill>
+                <a:latin typeface="Courier New" pitchFamily="34" charset="0"/>
+                <a:ea typeface="Courier New" pitchFamily="34" charset="-122"/>
+                <a:cs typeface="Courier New" pitchFamily="34" charset="-120"/>
+              </a:rPr>
+              <a:t>    red 0%, yellow 25%, green 50%, blue 75%, violet 100%</a:t>
+            </a:r>
+            <a:endParaRPr lang="en-US" sz="1250" dirty="0"/>
+          </a:p>
+          <a:p>
+            <a:pPr indent="0" marL="0">
+              <a:lnSpc>
+                <a:spcPct val="125000"/>
+              </a:lnSpc>
+              <a:buNone/>
+            </a:pPr>
+            <a:r>
+              <a:rPr lang="en-US" sz="1250" dirty="0">
+                <a:solidFill>
+                  <a:srgbClr val="C9D3F5"/>
+                </a:solidFill>
+                <a:latin typeface="Courier New" pitchFamily="34" charset="0"/>
+                <a:ea typeface="Courier New" pitchFamily="34" charset="-122"/>
+                <a:cs typeface="Courier New" pitchFamily="34" charset="-120"/>
+              </a:rPr>
+              <a:t>  );</a:t>
+            </a:r>
+            <a:endParaRPr lang="en-US" sz="1250" dirty="0"/>
+          </a:p>
+          <a:p>
+            <a:pPr indent="0" marL="0">
+              <a:lnSpc>
+                <a:spcPct val="125000"/>
+              </a:lnSpc>
+              <a:buNone/>
+            </a:pPr>
+            <a:r>
+              <a:rPr lang="en-US" sz="1250" dirty="0">
+                <a:solidFill>
+                  <a:srgbClr val="C9D3F5"/>
+                </a:solidFill>
+                <a:latin typeface="Courier New" pitchFamily="34" charset="0"/>
+                <a:ea typeface="Courier New" pitchFamily="34" charset="-122"/>
+                <a:cs typeface="Courier New" pitchFamily="34" charset="-120"/>
+              </a:rPr>
+              <a:t>}</a:t>
+            </a:r>
+            <a:endParaRPr lang="en-US" sz="1250" dirty="0"/>
+          </a:p>
+        </p:txBody>
+      </p:sp>
+      <p:sp>
+        <p:nvSpPr>
+          <p:cNvPr id="6" name="Shape 4"/>
+          <p:cNvSpPr/>
+          <p:nvPr/>
+        </p:nvSpPr>
+        <p:spPr>
+          <a:xfrm>
+            <a:off x="530352" y="4107942"/>
+            <a:ext cx="11130991" cy="2219706"/>
+          </a:xfrm>
+          <a:prstGeom prst="roundRect">
+            <a:avLst>
+              <a:gd name="adj" fmla="val 2472"/>
             </a:avLst>
           </a:prstGeom>
           <a:solidFill>
@@ -12115,7 +12966,7 @@
       </p:sp>
       <p:pic>
         <p:nvPicPr>
-          <p:cNvPr id="6" name="Image 0" descr="D:/GitHub/mern-web-book/docs/assets/img/lecture-08/gradient-rainbow-stops.png">    </p:cNvPr>
+          <p:cNvPr id="7" name="Image 0" descr="D:/GitHub/mern-web-book/docs/assets/img/lecture-08/gradient-rainbow-stops.png">    </p:cNvPr>
           <p:cNvPicPr>
             <a:picLocks noChangeAspect="1"/>
           </p:cNvPicPr>
@@ -12129,8 +12980,8 @@
         </p:blipFill>
         <p:spPr>
           <a:xfrm>
-            <a:off x="640080" y="3096910"/>
-            <a:ext cx="10911535" cy="2310100"/>
+            <a:off x="1371853" y="4217670"/>
+            <a:ext cx="9447989" cy="2000250"/>
           </a:xfrm>
           <a:prstGeom prst="rect">
             <a:avLst/>
@@ -12139,7 +12990,7 @@
       </p:pic>
       <p:sp>
         <p:nvSpPr>
-          <p:cNvPr id="7" name="Text 4"/>
+          <p:cNvPr id="8" name="Text 5"/>
           <p:cNvSpPr txBox="1"/>
           <p:nvPr/>
         </p:nvSpPr>
@@ -12178,7 +13029,7 @@
       </p:sp>
       <p:sp>
         <p:nvSpPr>
-          <p:cNvPr id="8" name="Text 5"/>
+          <p:cNvPr id="9" name="Text 6"/>
           <p:cNvSpPr txBox="1"/>
           <p:nvPr/>
         </p:nvSpPr>
@@ -12358,7 +13209,7 @@
                 <a:ea typeface="Calibri" pitchFamily="34" charset="-122"/>
                 <a:cs typeface="Calibri" pitchFamily="34" charset="-120"/>
               </a:rPr>
-              <a:t>.card:hover { box-shadow: 0 8px 20px rgba(0,0,0,0.35); } — genuinely live on the deployed page; shown here at both states.</a:t>
+              <a:t>Genuinely live on the deployed page — shown here at both states.</a:t>
             </a:r>
             <a:endParaRPr lang="en-US" sz="1350" dirty="0"/>
           </a:p>
@@ -12372,12 +13223,176 @@
         </p:nvSpPr>
         <p:spPr>
           <a:xfrm>
-            <a:off x="530352" y="2221992"/>
-            <a:ext cx="11130991" cy="4059936"/>
+            <a:off x="640080" y="2240280"/>
+            <a:ext cx="10911535" cy="1977390"/>
           </a:xfrm>
           <a:prstGeom prst="roundRect">
             <a:avLst>
-              <a:gd name="adj" fmla="val 1351"/>
+              <a:gd name="adj" fmla="val 3699"/>
+            </a:avLst>
+          </a:prstGeom>
+          <a:solidFill>
+            <a:srgbClr val="1E1E4C"/>
+          </a:solidFill>
+          <a:ln/>
+        </p:spPr>
+      </p:sp>
+      <p:sp>
+        <p:nvSpPr>
+          <p:cNvPr id="6" name="Text 4"/>
+          <p:cNvSpPr txBox="1"/>
+          <p:nvPr/>
+        </p:nvSpPr>
+        <p:spPr>
+          <a:xfrm>
+            <a:off x="960120" y="2468880"/>
+            <a:ext cx="10271455" cy="1520190"/>
+          </a:xfrm>
+          <a:prstGeom prst="rect">
+            <a:avLst/>
+          </a:prstGeom>
+          <a:noFill/>
+          <a:ln/>
+        </p:spPr>
+        <p:txBody>
+          <a:bodyPr wrap="square" lIns="0" tIns="0" rIns="0" bIns="0" rtlCol="0" anchor="t"/>
+          <a:lstStyle/>
+          <a:p>
+            <a:pPr indent="0" marL="0">
+              <a:lnSpc>
+                <a:spcPct val="125000"/>
+              </a:lnSpc>
+              <a:buNone/>
+            </a:pPr>
+            <a:r>
+              <a:rPr lang="en-US" sz="1250" dirty="0">
+                <a:solidFill>
+                  <a:srgbClr val="C9D3F5"/>
+                </a:solidFill>
+                <a:latin typeface="Courier New" pitchFamily="34" charset="0"/>
+                <a:ea typeface="Courier New" pitchFamily="34" charset="-122"/>
+                <a:cs typeface="Courier New" pitchFamily="34" charset="-120"/>
+              </a:rPr>
+              <a:t>.card {</a:t>
+            </a:r>
+            <a:endParaRPr lang="en-US" sz="1250" dirty="0"/>
+          </a:p>
+          <a:p>
+            <a:pPr indent="0" marL="0">
+              <a:lnSpc>
+                <a:spcPct val="125000"/>
+              </a:lnSpc>
+              <a:buNone/>
+            </a:pPr>
+            <a:r>
+              <a:rPr lang="en-US" sz="1250" dirty="0">
+                <a:solidFill>
+                  <a:srgbClr val="C9D3F5"/>
+                </a:solidFill>
+                <a:latin typeface="Courier New" pitchFamily="34" charset="0"/>
+                <a:ea typeface="Courier New" pitchFamily="34" charset="-122"/>
+                <a:cs typeface="Courier New" pitchFamily="34" charset="-120"/>
+              </a:rPr>
+              <a:t>  box-shadow: 0 4px 10px rgba(0, 0, 0, 0.2);</a:t>
+            </a:r>
+            <a:endParaRPr lang="en-US" sz="1250" dirty="0"/>
+          </a:p>
+          <a:p>
+            <a:pPr indent="0" marL="0">
+              <a:lnSpc>
+                <a:spcPct val="125000"/>
+              </a:lnSpc>
+              <a:buNone/>
+            </a:pPr>
+            <a:r>
+              <a:rPr lang="en-US" sz="1250" dirty="0">
+                <a:solidFill>
+                  <a:srgbClr val="C9D3F5"/>
+                </a:solidFill>
+                <a:latin typeface="Courier New" pitchFamily="34" charset="0"/>
+                <a:ea typeface="Courier New" pitchFamily="34" charset="-122"/>
+                <a:cs typeface="Courier New" pitchFamily="34" charset="-120"/>
+              </a:rPr>
+              <a:t>}</a:t>
+            </a:r>
+            <a:endParaRPr lang="en-US" sz="1250" dirty="0"/>
+          </a:p>
+          <a:p>
+            <a:pPr indent="0" marL="0">
+              <a:lnSpc>
+                <a:spcPct val="125000"/>
+              </a:lnSpc>
+              <a:buNone/>
+            </a:pPr>
+            <a:r>
+              <a:rPr lang="en-US" sz="1250" dirty="0">
+                <a:solidFill>
+                  <a:srgbClr val="C9D3F5"/>
+                </a:solidFill>
+                <a:latin typeface="Courier New" pitchFamily="34" charset="0"/>
+                <a:ea typeface="Courier New" pitchFamily="34" charset="-122"/>
+                <a:cs typeface="Courier New" pitchFamily="34" charset="-120"/>
+              </a:rPr>
+              <a:t>.card:hover {</a:t>
+            </a:r>
+            <a:endParaRPr lang="en-US" sz="1250" dirty="0"/>
+          </a:p>
+          <a:p>
+            <a:pPr indent="0" marL="0">
+              <a:lnSpc>
+                <a:spcPct val="125000"/>
+              </a:lnSpc>
+              <a:buNone/>
+            </a:pPr>
+            <a:r>
+              <a:rPr lang="en-US" sz="1250" dirty="0">
+                <a:solidFill>
+                  <a:srgbClr val="C9D3F5"/>
+                </a:solidFill>
+                <a:latin typeface="Courier New" pitchFamily="34" charset="0"/>
+                <a:ea typeface="Courier New" pitchFamily="34" charset="-122"/>
+                <a:cs typeface="Courier New" pitchFamily="34" charset="-120"/>
+              </a:rPr>
+              <a:t>  box-shadow: 0 8px 20px rgba(0, 0, 0, 0.35);</a:t>
+            </a:r>
+            <a:endParaRPr lang="en-US" sz="1250" dirty="0"/>
+          </a:p>
+          <a:p>
+            <a:pPr indent="0" marL="0">
+              <a:lnSpc>
+                <a:spcPct val="125000"/>
+              </a:lnSpc>
+              <a:buNone/>
+            </a:pPr>
+            <a:r>
+              <a:rPr lang="en-US" sz="1250" dirty="0">
+                <a:solidFill>
+                  <a:srgbClr val="C9D3F5"/>
+                </a:solidFill>
+                <a:latin typeface="Courier New" pitchFamily="34" charset="0"/>
+                <a:ea typeface="Courier New" pitchFamily="34" charset="-122"/>
+                <a:cs typeface="Courier New" pitchFamily="34" charset="-120"/>
+              </a:rPr>
+              <a:t>}</a:t>
+            </a:r>
+            <a:endParaRPr lang="en-US" sz="1250" dirty="0"/>
+          </a:p>
+        </p:txBody>
+      </p:sp>
+      <p:sp>
+        <p:nvSpPr>
+          <p:cNvPr id="7" name="Shape 5"/>
+          <p:cNvSpPr/>
+          <p:nvPr/>
+        </p:nvSpPr>
+        <p:spPr>
+          <a:xfrm>
+            <a:off x="530352" y="4382262"/>
+            <a:ext cx="11130991" cy="1945386"/>
+          </a:xfrm>
+          <a:prstGeom prst="roundRect">
+            <a:avLst>
+              <a:gd name="adj" fmla="val 2820"/>
             </a:avLst>
           </a:prstGeom>
           <a:solidFill>
@@ -12400,7 +13415,7 @@
       </p:sp>
       <p:pic>
         <p:nvPicPr>
-          <p:cNvPr id="6" name="Image 0" descr="D:/GitHub/mern-web-book/slides/assets/lecture-08/shadow-hover.png">    </p:cNvPr>
+          <p:cNvPr id="8" name="Image 0" descr="D:/GitHub/mern-web-book/slides/assets/lecture-08/shadow-hover.png">    </p:cNvPr>
           <p:cNvPicPr>
             <a:picLocks noChangeAspect="1"/>
           </p:cNvPicPr>
@@ -12414,8 +13429,8 @@
         </p:blipFill>
         <p:spPr>
           <a:xfrm>
-            <a:off x="640080" y="2860810"/>
-            <a:ext cx="10911535" cy="2782300"/>
+            <a:off x="2711498" y="4491990"/>
+            <a:ext cx="6768698" cy="1725930"/>
           </a:xfrm>
           <a:prstGeom prst="rect">
             <a:avLst/>
@@ -12424,7 +13439,7 @@
       </p:pic>
       <p:sp>
         <p:nvSpPr>
-          <p:cNvPr id="7" name="Text 4"/>
+          <p:cNvPr id="9" name="Text 6"/>
           <p:cNvSpPr txBox="1"/>
           <p:nvPr/>
         </p:nvSpPr>
@@ -12463,7 +13478,7 @@
       </p:sp>
       <p:sp>
         <p:nvSpPr>
-          <p:cNvPr id="8" name="Text 5"/>
+          <p:cNvPr id="10" name="Text 7"/>
           <p:cNvSpPr txBox="1"/>
           <p:nvPr/>
         </p:nvSpPr>
@@ -12612,57 +13627,122 @@
       </p:sp>
       <p:sp>
         <p:nvSpPr>
-          <p:cNvPr id="4" name="Text 2"/>
-          <p:cNvSpPr txBox="1"/>
-          <p:nvPr/>
-        </p:nvSpPr>
-        <p:spPr>
-          <a:xfrm>
-            <a:off x="640080" y="1691640"/>
-            <a:ext cx="10911535" cy="411480"/>
-          </a:xfrm>
-          <a:prstGeom prst="rect">
-            <a:avLst/>
-          </a:prstGeom>
-          <a:noFill/>
-          <a:ln/>
-        </p:spPr>
-        <p:txBody>
-          <a:bodyPr wrap="square" lIns="0" tIns="0" rIns="0" bIns="0" rtlCol="0" anchor="ctr"/>
-          <a:lstStyle/>
-          <a:p>
-            <a:pPr indent="0" marL="0">
-              <a:buNone/>
-            </a:pPr>
-            <a:r>
-              <a:rPr lang="en-US" sz="1350" i="1" dirty="0">
-                <a:solidFill>
-                  <a:srgbClr val="5D5D72"/>
-                </a:solidFill>
-                <a:latin typeface="Calibri" pitchFamily="34" charset="0"/>
-                <a:ea typeface="Calibri" pitchFamily="34" charset="-122"/>
-                <a:cs typeface="Calibri" pitchFamily="34" charset="-120"/>
-              </a:rPr>
-              <a:t>h1 { text-shadow: 2px 2px 4px rgba(0,0,0,0.5); }</a:t>
-            </a:r>
-            <a:endParaRPr lang="en-US" sz="1350" dirty="0"/>
-          </a:p>
-        </p:txBody>
-      </p:sp>
-      <p:sp>
-        <p:nvSpPr>
-          <p:cNvPr id="5" name="Shape 3"/>
+          <p:cNvPr id="4" name="Shape 2"/>
           <p:cNvSpPr/>
           <p:nvPr/>
         </p:nvSpPr>
         <p:spPr>
           <a:xfrm>
-            <a:off x="530352" y="2221992"/>
-            <a:ext cx="11130991" cy="4059936"/>
+            <a:off x="640080" y="1965960"/>
+            <a:ext cx="10911535" cy="1263015"/>
           </a:xfrm>
           <a:prstGeom prst="roundRect">
             <a:avLst>
-              <a:gd name="adj" fmla="val 1351"/>
+              <a:gd name="adj" fmla="val 5792"/>
+            </a:avLst>
+          </a:prstGeom>
+          <a:solidFill>
+            <a:srgbClr val="1E1E4C"/>
+          </a:solidFill>
+          <a:ln/>
+        </p:spPr>
+      </p:sp>
+      <p:sp>
+        <p:nvSpPr>
+          <p:cNvPr id="5" name="Text 3"/>
+          <p:cNvSpPr txBox="1"/>
+          <p:nvPr/>
+        </p:nvSpPr>
+        <p:spPr>
+          <a:xfrm>
+            <a:off x="960120" y="2194560"/>
+            <a:ext cx="10271455" cy="805815"/>
+          </a:xfrm>
+          <a:prstGeom prst="rect">
+            <a:avLst/>
+          </a:prstGeom>
+          <a:noFill/>
+          <a:ln/>
+        </p:spPr>
+        <p:txBody>
+          <a:bodyPr wrap="square" lIns="0" tIns="0" rIns="0" bIns="0" rtlCol="0" anchor="t"/>
+          <a:lstStyle/>
+          <a:p>
+            <a:pPr indent="0" marL="0">
+              <a:lnSpc>
+                <a:spcPct val="125000"/>
+              </a:lnSpc>
+              <a:buNone/>
+            </a:pPr>
+            <a:r>
+              <a:rPr lang="en-US" sz="1250" dirty="0">
+                <a:solidFill>
+                  <a:srgbClr val="C9D3F5"/>
+                </a:solidFill>
+                <a:latin typeface="Courier New" pitchFamily="34" charset="0"/>
+                <a:ea typeface="Courier New" pitchFamily="34" charset="-122"/>
+                <a:cs typeface="Courier New" pitchFamily="34" charset="-120"/>
+              </a:rPr>
+              <a:t>h1 {</a:t>
+            </a:r>
+            <a:endParaRPr lang="en-US" sz="1250" dirty="0"/>
+          </a:p>
+          <a:p>
+            <a:pPr indent="0" marL="0">
+              <a:lnSpc>
+                <a:spcPct val="125000"/>
+              </a:lnSpc>
+              <a:buNone/>
+            </a:pPr>
+            <a:r>
+              <a:rPr lang="en-US" sz="1250" dirty="0">
+                <a:solidFill>
+                  <a:srgbClr val="C9D3F5"/>
+                </a:solidFill>
+                <a:latin typeface="Courier New" pitchFamily="34" charset="0"/>
+                <a:ea typeface="Courier New" pitchFamily="34" charset="-122"/>
+                <a:cs typeface="Courier New" pitchFamily="34" charset="-120"/>
+              </a:rPr>
+              <a:t>  text-shadow: 2px 2px 4px rgba(0, 0, 0, 0.5);</a:t>
+            </a:r>
+            <a:endParaRPr lang="en-US" sz="1250" dirty="0"/>
+          </a:p>
+          <a:p>
+            <a:pPr indent="0" marL="0">
+              <a:lnSpc>
+                <a:spcPct val="125000"/>
+              </a:lnSpc>
+              <a:buNone/>
+            </a:pPr>
+            <a:r>
+              <a:rPr lang="en-US" sz="1250" dirty="0">
+                <a:solidFill>
+                  <a:srgbClr val="C9D3F5"/>
+                </a:solidFill>
+                <a:latin typeface="Courier New" pitchFamily="34" charset="0"/>
+                <a:ea typeface="Courier New" pitchFamily="34" charset="-122"/>
+                <a:cs typeface="Courier New" pitchFamily="34" charset="-120"/>
+              </a:rPr>
+              <a:t>}</a:t>
+            </a:r>
+            <a:endParaRPr lang="en-US" sz="1250" dirty="0"/>
+          </a:p>
+        </p:txBody>
+      </p:sp>
+      <p:sp>
+        <p:nvSpPr>
+          <p:cNvPr id="6" name="Shape 4"/>
+          <p:cNvSpPr/>
+          <p:nvPr/>
+        </p:nvSpPr>
+        <p:spPr>
+          <a:xfrm>
+            <a:off x="530352" y="3393567"/>
+            <a:ext cx="11130991" cy="2934081"/>
+          </a:xfrm>
+          <a:prstGeom prst="roundRect">
+            <a:avLst>
+              <a:gd name="adj" fmla="val 1870"/>
             </a:avLst>
           </a:prstGeom>
           <a:solidFill>
@@ -12685,7 +13765,7 @@
       </p:sp>
       <p:pic>
         <p:nvPicPr>
-          <p:cNvPr id="6" name="Image 0" descr="D:/GitHub/mern-web-book/docs/assets/img/lecture-08/text-shadow-heading.png">    </p:cNvPr>
+          <p:cNvPr id="7" name="Image 0" descr="D:/GitHub/mern-web-book/docs/assets/img/lecture-08/text-shadow-heading.png">    </p:cNvPr>
           <p:cNvPicPr>
             <a:picLocks noChangeAspect="1"/>
           </p:cNvPicPr>
@@ -12699,7 +13779,7 @@
         </p:blipFill>
         <p:spPr>
           <a:xfrm>
-            <a:off x="1127608" y="3268980"/>
+            <a:off x="1127608" y="3877627"/>
             <a:ext cx="9936480" cy="1965960"/>
           </a:xfrm>
           <a:prstGeom prst="rect">
@@ -12709,7 +13789,7 @@
       </p:pic>
       <p:sp>
         <p:nvSpPr>
-          <p:cNvPr id="7" name="Text 4"/>
+          <p:cNvPr id="8" name="Text 5"/>
           <p:cNvSpPr txBox="1"/>
           <p:nvPr/>
         </p:nvSpPr>
@@ -12748,7 +13828,7 @@
       </p:sp>
       <p:sp>
         <p:nvSpPr>
-          <p:cNvPr id="8" name="Text 5"/>
+          <p:cNvPr id="9" name="Text 6"/>
           <p:cNvSpPr txBox="1"/>
           <p:nvPr/>
         </p:nvSpPr>

</xml_diff>

<commit_message>
Fix non-clickable W3Schools links in CSC336 lectures 8 and 10 PDFs
python-pptx's run-level hyperlink.address on the "Try it yourself" boxes
produced structurally valid XML but PowerPoint's PDF export silently
dropped the link annotation. Fixed by setting the hyperlink via
PowerPoint COM's shape-level ActionSettings instead (also makes the
whole box clickable, not just the text run) - confirmed present in the
exported PDF's link annotations this time, not just the pptx XML.

Co-Authored-By: Claude Sonnet 5 <noreply@anthropic.com>
</commit_message>
<xml_diff>
--- a/slides/CSC336-Lecture-08-CSS3-Features.pptx
+++ b/slides/CSC336-Lecture-08-CSS3-Features.pptx
@@ -4,6 +4,9 @@
   <p:sldMasterIdLst>
     <p:sldMasterId id="2147483648" r:id="rId1"/>
   </p:sldMasterIdLst>
+  <p:notesMasterIdLst>
+    <p:notesMasterId r:id="rId27"/>
+  </p:notesMasterIdLst>
   <p:sldIdLst>
     <p:sldId id="256" r:id="rId2"/>
     <p:sldId id="257" r:id="rId3"/>
@@ -31,9 +34,6 @@
     <p:sldId id="279" r:id="rId25"/>
     <p:sldId id="280" r:id="rId26"/>
   </p:sldIdLst>
-  <p:notesMasterIdLst>
-    <p:notesMasterId r:id="rId27"/>
-  </p:notesMasterIdLst>
   <p:sldSz cx="12192000" cy="6858000"/>
   <p:notesSz cx="6858000" cy="12192000"/>
   <p:defaultTextStyle>
@@ -128,6 +128,11 @@
       </a:defRPr>
     </a:lvl9pPr>
   </p:defaultTextStyle>
+  <p:extLst>
+    <p:ext uri="{EFAFB233-063F-42B5-8137-9DF3F51BA10A}">
+      <p15:sldGuideLst xmlns:p15="http://schemas.microsoft.com/office/powerpoint/2012/main"/>
+    </p:ext>
+  </p:extLst>
 </p:presentation>
 </file>
 
@@ -153,234 +158,10 @@
           <a:chExt cx="0" cy="0"/>
         </a:xfrm>
       </p:grpSpPr>
-      <p:sp>
-        <p:nvSpPr>
-          <p:cNvPr id="2" name="Header Placeholder 1"/>
-          <p:cNvSpPr>
-            <a:spLocks noGrp="1"/>
-          </p:cNvSpPr>
-          <p:nvPr>
-            <p:ph type="hdr" sz="quarter"/>
-          </p:nvPr>
-        </p:nvSpPr>
-        <p:spPr>
-          <a:xfrm>
-            <a:off x="0" y="0"/>
-            <a:ext cx="2971800" cy="458788"/>
-          </a:xfrm>
-          <a:prstGeom prst="rect">
-            <a:avLst/>
-          </a:prstGeom>
-        </p:spPr>
-        <p:txBody>
-          <a:bodyPr vert="horz" lIns="91440" tIns="45720" rIns="91440" bIns="45720" rtlCol="0"/>
-          <a:lstStyle>
-            <a:lvl1pPr algn="l">
-              <a:defRPr sz="1200"/>
-            </a:lvl1pPr>
-          </a:lstStyle>
-          <a:p>
-            <a:endParaRPr lang="en-US"/>
-          </a:p>
-        </p:txBody>
-      </p:sp>
-      <p:sp>
-        <p:nvSpPr>
-          <p:cNvPr id="3" name="Date Placeholder 2"/>
-          <p:cNvSpPr>
-            <a:spLocks noGrp="1"/>
-          </p:cNvSpPr>
-          <p:nvPr>
-            <p:ph type="dt" idx="1"/>
-          </p:nvPr>
-        </p:nvSpPr>
-        <p:spPr>
-          <a:xfrm>
-            <a:off x="3884613" y="0"/>
-            <a:ext cx="2971800" cy="458788"/>
-          </a:xfrm>
-          <a:prstGeom prst="rect">
-            <a:avLst/>
-          </a:prstGeom>
-        </p:spPr>
-        <p:txBody>
-          <a:bodyPr vert="horz" lIns="91440" tIns="45720" rIns="91440" bIns="45720" rtlCol="0"/>
-          <a:lstStyle>
-            <a:lvl1pPr algn="r">
-              <a:defRPr sz="1200"/>
-            </a:lvl1pPr>
-          </a:lstStyle>
-          <a:p>
-            <a:fld id="{5282F153-3F37-0F45-9E97-73ACFA13230C}" type="datetimeFigureOut">
-              <a:rPr lang="en-US"/>
-              <a:t>7/23/19</a:t>
-            </a:fld>
-            <a:endParaRPr lang="en-US"/>
-          </a:p>
-        </p:txBody>
-      </p:sp>
-      <p:sp>
-        <p:nvSpPr>
-          <p:cNvPr id="4" name="Slide Image Placeholder 3"/>
-          <p:cNvSpPr>
-            <a:spLocks noGrp="1" noRot="1" noChangeAspect="1"/>
-          </p:cNvSpPr>
-          <p:nvPr>
-            <p:ph type="sldImg" idx="2"/>
-          </p:nvPr>
-        </p:nvSpPr>
-        <p:spPr>
-          <a:xfrm>
-            <a:off x="685800" y="1143000"/>
-            <a:ext cx="5486400" cy="3086100"/>
-          </a:xfrm>
-          <a:prstGeom prst="rect">
-            <a:avLst/>
-          </a:prstGeom>
-          <a:noFill/>
-          <a:ln w="12700">
-            <a:solidFill>
-              <a:prstClr val="black"/>
-            </a:solidFill>
-          </a:ln>
-        </p:spPr>
-        <p:txBody>
-          <a:bodyPr vert="horz" lIns="91440" tIns="45720" rIns="91440" bIns="45720" rtlCol="0" anchor="ctr"/>
-          <a:lstStyle/>
-          <a:p>
-            <a:endParaRPr lang="en-US"/>
-          </a:p>
-        </p:txBody>
-      </p:sp>
-      <p:sp>
-        <p:nvSpPr>
-          <p:cNvPr id="5" name="Notes Placeholder 4"/>
-          <p:cNvSpPr>
-            <a:spLocks noGrp="1"/>
-          </p:cNvSpPr>
-          <p:nvPr>
-            <p:ph type="body" sz="quarter" idx="3"/>
-          </p:nvPr>
-        </p:nvSpPr>
-        <p:spPr>
-          <a:xfrm>
-            <a:off x="685800" y="4400550"/>
-            <a:ext cx="5486400" cy="3600450"/>
-          </a:xfrm>
-          <a:prstGeom prst="rect">
-            <a:avLst/>
-          </a:prstGeom>
-        </p:spPr>
-        <p:txBody>
-          <a:bodyPr vert="horz" lIns="91440" tIns="45720" rIns="91440" bIns="45720" rtlCol="0"/>
-          <a:lstStyle/>
-          <a:p>
-            <a:pPr lvl="0"/>
-            <a:r>
-              <a:rPr lang="en-US"/>
-              <a:t>Click to edit Master text styles</a:t>
-            </a:r>
-          </a:p>
-          <a:p>
-            <a:pPr lvl="1"/>
-            <a:r>
-              <a:rPr lang="en-US"/>
-              <a:t>Second level</a:t>
-            </a:r>
-          </a:p>
-          <a:p>
-            <a:pPr lvl="2"/>
-            <a:r>
-              <a:rPr lang="en-US"/>
-              <a:t>Third level</a:t>
-            </a:r>
-          </a:p>
-          <a:p>
-            <a:pPr lvl="3"/>
-            <a:r>
-              <a:rPr lang="en-US"/>
-              <a:t>Fourth level</a:t>
-            </a:r>
-          </a:p>
-          <a:p>
-            <a:pPr lvl="4"/>
-            <a:r>
-              <a:rPr lang="en-US"/>
-              <a:t>Fifth level</a:t>
-            </a:r>
-          </a:p>
-        </p:txBody>
-      </p:sp>
-      <p:sp>
-        <p:nvSpPr>
-          <p:cNvPr id="6" name="Footer Placeholder 5"/>
-          <p:cNvSpPr>
-            <a:spLocks noGrp="1"/>
-          </p:cNvSpPr>
-          <p:nvPr>
-            <p:ph type="ftr" sz="quarter" idx="4"/>
-          </p:nvPr>
-        </p:nvSpPr>
-        <p:spPr>
-          <a:xfrm>
-            <a:off x="0" y="8685213"/>
-            <a:ext cx="2971800" cy="458787"/>
-          </a:xfrm>
-          <a:prstGeom prst="rect">
-            <a:avLst/>
-          </a:prstGeom>
-        </p:spPr>
-        <p:txBody>
-          <a:bodyPr vert="horz" lIns="91440" tIns="45720" rIns="91440" bIns="45720" rtlCol="0" anchor="b"/>
-          <a:lstStyle>
-            <a:lvl1pPr algn="l">
-              <a:defRPr sz="1200"/>
-            </a:lvl1pPr>
-          </a:lstStyle>
-          <a:p>
-            <a:endParaRPr lang="en-US"/>
-          </a:p>
-        </p:txBody>
-      </p:sp>
-      <p:sp>
-        <p:nvSpPr>
-          <p:cNvPr id="7" name="Slide Number Placeholder 6"/>
-          <p:cNvSpPr>
-            <a:spLocks noGrp="1"/>
-          </p:cNvSpPr>
-          <p:nvPr>
-            <p:ph type="sldNum" sz="quarter" idx="5"/>
-          </p:nvPr>
-        </p:nvSpPr>
-        <p:spPr>
-          <a:xfrm>
-            <a:off x="3884613" y="8685213"/>
-            <a:ext cx="2971800" cy="458787"/>
-          </a:xfrm>
-          <a:prstGeom prst="rect">
-            <a:avLst/>
-          </a:prstGeom>
-        </p:spPr>
-        <p:txBody>
-          <a:bodyPr vert="horz" lIns="91440" tIns="45720" rIns="91440" bIns="45720" rtlCol="0" anchor="b"/>
-          <a:lstStyle>
-            <a:lvl1pPr algn="r">
-              <a:defRPr sz="1200"/>
-            </a:lvl1pPr>
-          </a:lstStyle>
-          <a:p>
-            <a:fld id="{CE5E9CC1-C706-0F49-92D6-E571CC5EEA8F}" type="slidenum">
-              <a:rPr lang="en-US"/>
-              <a:t>‹#›</a:t>
-            </a:fld>
-            <a:endParaRPr lang="en-US"/>
-          </a:p>
-        </p:txBody>
-      </p:sp>
     </p:spTree>
     <p:extLst>
       <p:ext uri="{BB962C8B-B14F-4D97-AF65-F5344CB8AC3E}">
-        <p14:creationId xmlns:p14="http://schemas.microsoft.com/office/powerpoint/2010/main" val="1024086991"/>
+        <p14:creationId xmlns:p14="http://schemas.microsoft.com/office/powerpoint/2010/main" val="3538852504"/>
       </p:ext>
     </p:extLst>
   </p:cSld>
@@ -524,10 +305,6 @@
           <a:bodyPr/>
           <a:lstStyle/>
           <a:p>
-            <a:r>
-              <a:rPr lang="en-US" dirty="0"/>
-              <a:t/>
-            </a:r>
             <a:endParaRPr lang="en-US" dirty="0"/>
           </a:p>
         </p:txBody>
@@ -612,10 +389,6 @@
           <a:bodyPr/>
           <a:lstStyle/>
           <a:p>
-            <a:r>
-              <a:rPr lang="en-US" dirty="0"/>
-              <a:t/>
-            </a:r>
             <a:endParaRPr lang="en-US" dirty="0"/>
           </a:p>
         </p:txBody>
@@ -700,10 +473,6 @@
           <a:bodyPr/>
           <a:lstStyle/>
           <a:p>
-            <a:r>
-              <a:rPr lang="en-US" dirty="0"/>
-              <a:t/>
-            </a:r>
             <a:endParaRPr lang="en-US" dirty="0"/>
           </a:p>
         </p:txBody>
@@ -788,10 +557,6 @@
           <a:bodyPr/>
           <a:lstStyle/>
           <a:p>
-            <a:r>
-              <a:rPr lang="en-US" dirty="0"/>
-              <a:t/>
-            </a:r>
             <a:endParaRPr lang="en-US" dirty="0"/>
           </a:p>
         </p:txBody>
@@ -876,10 +641,6 @@
           <a:bodyPr/>
           <a:lstStyle/>
           <a:p>
-            <a:r>
-              <a:rPr lang="en-US" dirty="0"/>
-              <a:t/>
-            </a:r>
             <a:endParaRPr lang="en-US" dirty="0"/>
           </a:p>
         </p:txBody>
@@ -964,10 +725,6 @@
           <a:bodyPr/>
           <a:lstStyle/>
           <a:p>
-            <a:r>
-              <a:rPr lang="en-US" dirty="0"/>
-              <a:t/>
-            </a:r>
             <a:endParaRPr lang="en-US" dirty="0"/>
           </a:p>
         </p:txBody>
@@ -1052,10 +809,6 @@
           <a:bodyPr/>
           <a:lstStyle/>
           <a:p>
-            <a:r>
-              <a:rPr lang="en-US" dirty="0"/>
-              <a:t/>
-            </a:r>
             <a:endParaRPr lang="en-US" dirty="0"/>
           </a:p>
         </p:txBody>
@@ -1140,10 +893,6 @@
           <a:bodyPr/>
           <a:lstStyle/>
           <a:p>
-            <a:r>
-              <a:rPr lang="en-US" dirty="0"/>
-              <a:t/>
-            </a:r>
             <a:endParaRPr lang="en-US" dirty="0"/>
           </a:p>
         </p:txBody>
@@ -1228,10 +977,6 @@
           <a:bodyPr/>
           <a:lstStyle/>
           <a:p>
-            <a:r>
-              <a:rPr lang="en-US" dirty="0"/>
-              <a:t/>
-            </a:r>
             <a:endParaRPr lang="en-US" dirty="0"/>
           </a:p>
         </p:txBody>
@@ -1316,10 +1061,6 @@
           <a:bodyPr/>
           <a:lstStyle/>
           <a:p>
-            <a:r>
-              <a:rPr lang="en-US" dirty="0"/>
-              <a:t/>
-            </a:r>
             <a:endParaRPr lang="en-US" dirty="0"/>
           </a:p>
         </p:txBody>
@@ -1404,10 +1145,6 @@
           <a:bodyPr/>
           <a:lstStyle/>
           <a:p>
-            <a:r>
-              <a:rPr lang="en-US" dirty="0"/>
-              <a:t/>
-            </a:r>
             <a:endParaRPr lang="en-US" dirty="0"/>
           </a:p>
         </p:txBody>
@@ -1492,10 +1229,6 @@
           <a:bodyPr/>
           <a:lstStyle/>
           <a:p>
-            <a:r>
-              <a:rPr lang="en-US" dirty="0"/>
-              <a:t/>
-            </a:r>
             <a:endParaRPr lang="en-US" dirty="0"/>
           </a:p>
         </p:txBody>
@@ -1580,10 +1313,6 @@
           <a:bodyPr/>
           <a:lstStyle/>
           <a:p>
-            <a:r>
-              <a:rPr lang="en-US" dirty="0"/>
-              <a:t/>
-            </a:r>
             <a:endParaRPr lang="en-US" dirty="0"/>
           </a:p>
         </p:txBody>
@@ -1668,10 +1397,6 @@
           <a:bodyPr/>
           <a:lstStyle/>
           <a:p>
-            <a:r>
-              <a:rPr lang="en-US" dirty="0"/>
-              <a:t/>
-            </a:r>
             <a:endParaRPr lang="en-US" dirty="0"/>
           </a:p>
         </p:txBody>
@@ -1756,10 +1481,6 @@
           <a:bodyPr/>
           <a:lstStyle/>
           <a:p>
-            <a:r>
-              <a:rPr lang="en-US" dirty="0"/>
-              <a:t/>
-            </a:r>
             <a:endParaRPr lang="en-US" dirty="0"/>
           </a:p>
         </p:txBody>
@@ -1844,10 +1565,6 @@
           <a:bodyPr/>
           <a:lstStyle/>
           <a:p>
-            <a:r>
-              <a:rPr lang="en-US" dirty="0"/>
-              <a:t/>
-            </a:r>
             <a:endParaRPr lang="en-US" dirty="0"/>
           </a:p>
         </p:txBody>
@@ -1932,10 +1649,6 @@
           <a:bodyPr/>
           <a:lstStyle/>
           <a:p>
-            <a:r>
-              <a:rPr lang="en-US" dirty="0"/>
-              <a:t/>
-            </a:r>
             <a:endParaRPr lang="en-US" dirty="0"/>
           </a:p>
         </p:txBody>
@@ -2020,10 +1733,6 @@
           <a:bodyPr/>
           <a:lstStyle/>
           <a:p>
-            <a:r>
-              <a:rPr lang="en-US" dirty="0"/>
-              <a:t/>
-            </a:r>
             <a:endParaRPr lang="en-US" dirty="0"/>
           </a:p>
         </p:txBody>
@@ -2108,10 +1817,6 @@
           <a:bodyPr/>
           <a:lstStyle/>
           <a:p>
-            <a:r>
-              <a:rPr lang="en-US" dirty="0"/>
-              <a:t/>
-            </a:r>
             <a:endParaRPr lang="en-US" dirty="0"/>
           </a:p>
         </p:txBody>
@@ -2196,10 +1901,6 @@
           <a:bodyPr/>
           <a:lstStyle/>
           <a:p>
-            <a:r>
-              <a:rPr lang="en-US" dirty="0"/>
-              <a:t/>
-            </a:r>
             <a:endParaRPr lang="en-US" dirty="0"/>
           </a:p>
         </p:txBody>
@@ -2284,10 +1985,6 @@
           <a:bodyPr/>
           <a:lstStyle/>
           <a:p>
-            <a:r>
-              <a:rPr lang="en-US" dirty="0"/>
-              <a:t/>
-            </a:r>
             <a:endParaRPr lang="en-US" dirty="0"/>
           </a:p>
         </p:txBody>
@@ -2372,10 +2069,6 @@
           <a:bodyPr/>
           <a:lstStyle/>
           <a:p>
-            <a:r>
-              <a:rPr lang="en-US" dirty="0"/>
-              <a:t/>
-            </a:r>
             <a:endParaRPr lang="en-US" dirty="0"/>
           </a:p>
         </p:txBody>
@@ -2460,10 +2153,6 @@
           <a:bodyPr/>
           <a:lstStyle/>
           <a:p>
-            <a:r>
-              <a:rPr lang="en-US" dirty="0"/>
-              <a:t/>
-            </a:r>
             <a:endParaRPr lang="en-US" dirty="0"/>
           </a:p>
         </p:txBody>
@@ -2548,10 +2237,6 @@
           <a:bodyPr/>
           <a:lstStyle/>
           <a:p>
-            <a:r>
-              <a:rPr lang="en-US" dirty="0"/>
-              <a:t/>
-            </a:r>
             <a:endParaRPr lang="en-US" dirty="0"/>
           </a:p>
         </p:txBody>
@@ -2636,10 +2321,6 @@
           <a:bodyPr/>
           <a:lstStyle/>
           <a:p>
-            <a:r>
-              <a:rPr lang="en-US" dirty="0"/>
-              <a:t/>
-            </a:r>
             <a:endParaRPr lang="en-US" dirty="0"/>
           </a:p>
         </p:txBody>
@@ -2713,6 +2394,11 @@
 <file path=ppt/slideMasters/slideMaster1.xml><?xml version="1.0" encoding="utf-8"?>
 <p:sldMaster xmlns:a="http://schemas.openxmlformats.org/drawingml/2006/main" xmlns:r="http://schemas.openxmlformats.org/officeDocument/2006/relationships" xmlns:p="http://schemas.openxmlformats.org/presentationml/2006/main">
   <p:cSld>
+    <p:bg>
+      <p:bgRef idx="1001">
+        <a:schemeClr val="bg1"/>
+      </p:bgRef>
+    </p:bg>
     <p:spTree>
       <p:nvGrpSpPr>
         <p:cNvPr id="1" name=""/>
@@ -2995,6 +2681,7 @@
         <a:solidFill>
           <a:srgbClr val="2B2B7A"/>
         </a:solidFill>
+        <a:effectLst/>
       </p:bgPr>
     </p:bg>
     <p:spTree>
@@ -3032,11 +2719,11 @@
           <a:bodyPr wrap="square" lIns="0" tIns="0" rIns="0" bIns="0" rtlCol="0" anchor="ctr"/>
           <a:lstStyle/>
           <a:p>
-            <a:pPr indent="0" marL="0">
-              <a:buNone/>
-            </a:pPr>
-            <a:r>
-              <a:rPr lang="en-US" sz="1500" b="1" spc="400" kern="0" dirty="0">
+            <a:pPr marL="0" indent="0">
+              <a:buNone/>
+            </a:pPr>
+            <a:r>
+              <a:rPr lang="en-US" sz="1500" b="1" kern="0" spc="400" dirty="0">
                 <a:solidFill>
                   <a:srgbClr val="FF8A3D"/>
                 </a:solidFill>
@@ -3071,7 +2758,7 @@
           <a:bodyPr wrap="square" lIns="0" tIns="0" rIns="0" bIns="0" rtlCol="0" anchor="ctr"/>
           <a:lstStyle/>
           <a:p>
-            <a:pPr indent="0" marL="0">
+            <a:pPr marL="0" indent="0">
               <a:lnSpc>
                 <a:spcPct val="105000"/>
               </a:lnSpc>
@@ -3091,7 +2778,7 @@
             <a:endParaRPr lang="en-US" sz="4000" dirty="0"/>
           </a:p>
           <a:p>
-            <a:pPr indent="0" marL="0">
+            <a:pPr marL="0" indent="0">
               <a:lnSpc>
                 <a:spcPct val="105000"/>
               </a:lnSpc>
@@ -3133,7 +2820,7 @@
           <a:bodyPr wrap="square" lIns="0" tIns="0" rIns="0" bIns="0" rtlCol="0" anchor="ctr"/>
           <a:lstStyle/>
           <a:p>
-            <a:pPr indent="0" marL="0">
+            <a:pPr marL="0" indent="0">
               <a:buNone/>
             </a:pPr>
             <a:r>
@@ -3172,7 +2859,7 @@
           <a:bodyPr wrap="square" lIns="0" tIns="0" rIns="0" bIns="0" rtlCol="0" anchor="ctr"/>
           <a:lstStyle/>
           <a:p>
-            <a:pPr indent="0" marL="0">
+            <a:pPr marL="0" indent="0">
               <a:buNone/>
             </a:pPr>
             <a:r>
@@ -3207,7 +2894,7 @@
           <a:noFill/>
         </p:spPr>
         <p:txBody>
-          <a:bodyPr wrap="none" lIns="0" rIns="0" tIns="0" bIns="0">
+          <a:bodyPr wrap="none" lIns="0" tIns="0" rIns="0" bIns="0">
             <a:spAutoFit/>
           </a:bodyPr>
           <a:lstStyle/>
@@ -3249,6 +2936,7 @@
         <a:solidFill>
           <a:srgbClr val="FFFFFF"/>
         </a:solidFill>
+        <a:effectLst/>
       </p:bgPr>
     </p:bg>
     <p:spTree>
@@ -3286,11 +2974,11 @@
           <a:bodyPr wrap="square" lIns="0" tIns="0" rIns="0" bIns="0" rtlCol="0" anchor="ctr"/>
           <a:lstStyle/>
           <a:p>
-            <a:pPr algn="l" indent="0" marL="0">
-              <a:buNone/>
-            </a:pPr>
-            <a:r>
-              <a:rPr lang="en-US" sz="1300" b="1" spc="300" kern="0" dirty="0">
+            <a:pPr marL="0" indent="0" algn="l">
+              <a:buNone/>
+            </a:pPr>
+            <a:r>
+              <a:rPr lang="en-US" sz="1300" b="1" kern="0" spc="300" dirty="0">
                 <a:solidFill>
                   <a:srgbClr val="FF8A3D"/>
                 </a:solidFill>
@@ -3325,7 +3013,7 @@
           <a:bodyPr wrap="square" lIns="0" tIns="0" rIns="0" bIns="0" rtlCol="0" anchor="ctr"/>
           <a:lstStyle/>
           <a:p>
-            <a:pPr algn="l" indent="0" marL="0">
+            <a:pPr marL="0" indent="0" algn="l">
               <a:buNone/>
             </a:pPr>
             <a:r>
@@ -3366,7 +3054,10 @@
         </p:spPr>
         <p:txBody>
           <a:bodyPr/>
-          <a:p/>
+          <a:lstStyle/>
+          <a:p>
+            <a:endParaRPr/>
+          </a:p>
         </p:txBody>
       </p:sp>
       <p:sp>
@@ -3390,7 +3081,7 @@
           <a:bodyPr wrap="square" lIns="0" tIns="0" rIns="0" bIns="0" rtlCol="0" anchor="t"/>
           <a:lstStyle/>
           <a:p>
-            <a:pPr indent="0" marL="0">
+            <a:pPr marL="0" indent="0">
               <a:lnSpc>
                 <a:spcPct val="125000"/>
               </a:lnSpc>
@@ -3410,7 +3101,7 @@
             <a:endParaRPr lang="en-US" sz="1250" dirty="0"/>
           </a:p>
           <a:p>
-            <a:pPr indent="0" marL="0">
+            <a:pPr marL="0" indent="0">
               <a:lnSpc>
                 <a:spcPct val="125000"/>
               </a:lnSpc>
@@ -3457,7 +3148,7 @@
             <a:prstDash val="solid"/>
           </a:ln>
           <a:effectLst>
-            <a:outerShdw sx="100000" sy="100000" kx="0" ky="0" algn="bl" rotWithShape="0" blurRad="101600" dist="38100" dir="5400000">
+            <a:outerShdw blurRad="101600" dist="38100" dir="5400000" algn="bl" rotWithShape="0">
               <a:srgbClr val="000000">
                 <a:alpha val="12000"/>
               </a:srgbClr>
@@ -3466,19 +3157,22 @@
         </p:spPr>
         <p:txBody>
           <a:bodyPr/>
-          <a:p/>
+          <a:lstStyle/>
+          <a:p>
+            <a:endParaRPr/>
+          </a:p>
         </p:txBody>
       </p:sp>
       <p:pic>
         <p:nvPicPr>
-          <p:cNvPr id="7" name="Image 0" descr="D:/GitHub/mern-web-book/docs/assets/img/lecture-08/multiple-shadows-glow.png">    </p:cNvPr>
+          <p:cNvPr id="7" name="Image 0" descr="D:/GitHub/mern-web-book/docs/assets/img/lecture-08/multiple-shadows-glow.png"/>
           <p:cNvPicPr>
             <a:picLocks noChangeAspect="1"/>
           </p:cNvPicPr>
           <p:nvPr/>
         </p:nvPicPr>
         <p:blipFill>
-          <a:blip r:embed="rId1"/>
+          <a:blip r:embed="rId3"/>
           <a:stretch>
             <a:fillRect/>
           </a:stretch>
@@ -3510,7 +3204,7 @@
           <a:noFill/>
         </p:spPr>
         <p:txBody>
-          <a:bodyPr wrap="none" lIns="0" rIns="0" tIns="0" bIns="0">
+          <a:bodyPr wrap="none" lIns="0" tIns="0" rIns="0" bIns="0">
             <a:spAutoFit/>
           </a:bodyPr>
           <a:lstStyle/>
@@ -3552,6 +3246,7 @@
         <a:solidFill>
           <a:srgbClr val="FFFFFF"/>
         </a:solidFill>
+        <a:effectLst/>
       </p:bgPr>
     </p:bg>
     <p:spTree>
@@ -3589,11 +3284,11 @@
           <a:bodyPr wrap="square" lIns="0" tIns="0" rIns="0" bIns="0" rtlCol="0" anchor="ctr"/>
           <a:lstStyle/>
           <a:p>
-            <a:pPr algn="l" indent="0" marL="0">
-              <a:buNone/>
-            </a:pPr>
-            <a:r>
-              <a:rPr lang="en-US" sz="1300" b="1" spc="300" kern="0" dirty="0">
+            <a:pPr marL="0" indent="0" algn="l">
+              <a:buNone/>
+            </a:pPr>
+            <a:r>
+              <a:rPr lang="en-US" sz="1300" b="1" kern="0" spc="300" dirty="0">
                 <a:solidFill>
                   <a:srgbClr val="FF8A3D"/>
                 </a:solidFill>
@@ -3628,7 +3323,7 @@
           <a:bodyPr wrap="square" lIns="0" tIns="0" rIns="0" bIns="0" rtlCol="0" anchor="ctr"/>
           <a:lstStyle/>
           <a:p>
-            <a:pPr algn="l" indent="0" marL="0">
+            <a:pPr marL="0" indent="0" algn="l">
               <a:buNone/>
             </a:pPr>
             <a:r>
@@ -3667,7 +3362,7 @@
           <a:bodyPr wrap="square" lIns="0" tIns="0" rIns="0" bIns="0" rtlCol="0" anchor="ctr"/>
           <a:lstStyle/>
           <a:p>
-            <a:pPr indent="0" marL="0">
+            <a:pPr marL="0" indent="0">
               <a:buNone/>
             </a:pPr>
             <a:r>
@@ -3708,7 +3403,10 @@
         </p:spPr>
         <p:txBody>
           <a:bodyPr/>
-          <a:p/>
+          <a:lstStyle/>
+          <a:p>
+            <a:endParaRPr/>
+          </a:p>
         </p:txBody>
       </p:sp>
       <p:sp>
@@ -3732,7 +3430,7 @@
           <a:bodyPr wrap="square" lIns="0" tIns="0" rIns="0" bIns="0" rtlCol="0" anchor="t"/>
           <a:lstStyle/>
           <a:p>
-            <a:pPr indent="0" marL="0">
+            <a:pPr marL="0" indent="0">
               <a:lnSpc>
                 <a:spcPct val="125000"/>
               </a:lnSpc>
@@ -3752,7 +3450,7 @@
             <a:endParaRPr lang="en-US" sz="1250" dirty="0"/>
           </a:p>
           <a:p>
-            <a:pPr indent="0" marL="0">
+            <a:pPr marL="0" indent="0">
               <a:lnSpc>
                 <a:spcPct val="125000"/>
               </a:lnSpc>
@@ -3772,7 +3470,7 @@
             <a:endParaRPr lang="en-US" sz="1250" dirty="0"/>
           </a:p>
           <a:p>
-            <a:pPr indent="0" marL="0">
+            <a:pPr marL="0" indent="0">
               <a:lnSpc>
                 <a:spcPct val="125000"/>
               </a:lnSpc>
@@ -3819,7 +3517,7 @@
             <a:prstDash val="solid"/>
           </a:ln>
           <a:effectLst>
-            <a:outerShdw sx="100000" sy="100000" kx="0" ky="0" algn="bl" rotWithShape="0" blurRad="101600" dist="38100" dir="5400000">
+            <a:outerShdw blurRad="101600" dist="38100" dir="5400000" algn="bl" rotWithShape="0">
               <a:srgbClr val="000000">
                 <a:alpha val="12000"/>
               </a:srgbClr>
@@ -3828,19 +3526,22 @@
         </p:spPr>
         <p:txBody>
           <a:bodyPr/>
-          <a:p/>
+          <a:lstStyle/>
+          <a:p>
+            <a:endParaRPr/>
+          </a:p>
         </p:txBody>
       </p:sp>
       <p:pic>
         <p:nvPicPr>
-          <p:cNvPr id="8" name="Image 0" descr="D:/GitHub/mern-web-book/docs/assets/img/lecture-08/opacity-comparison.png">    </p:cNvPr>
+          <p:cNvPr id="8" name="Image 0" descr="D:/GitHub/mern-web-book/docs/assets/img/lecture-08/opacity-comparison.png"/>
           <p:cNvPicPr>
             <a:picLocks noChangeAspect="1"/>
           </p:cNvPicPr>
           <p:nvPr/>
         </p:nvPicPr>
         <p:blipFill>
-          <a:blip r:embed="rId1"/>
+          <a:blip r:embed="rId3"/>
           <a:stretch>
             <a:fillRect/>
           </a:stretch>
@@ -3872,7 +3573,7 @@
           <a:noFill/>
         </p:spPr>
         <p:txBody>
-          <a:bodyPr wrap="none" lIns="0" rIns="0" tIns="0" bIns="0">
+          <a:bodyPr wrap="none" lIns="0" tIns="0" rIns="0" bIns="0">
             <a:spAutoFit/>
           </a:bodyPr>
           <a:lstStyle/>
@@ -3914,6 +3615,7 @@
         <a:solidFill>
           <a:srgbClr val="FFFFFF"/>
         </a:solidFill>
+        <a:effectLst/>
       </p:bgPr>
     </p:bg>
     <p:spTree>
@@ -3951,11 +3653,11 @@
           <a:bodyPr wrap="square" lIns="0" tIns="0" rIns="0" bIns="0" rtlCol="0" anchor="ctr"/>
           <a:lstStyle/>
           <a:p>
-            <a:pPr algn="l" indent="0" marL="0">
-              <a:buNone/>
-            </a:pPr>
-            <a:r>
-              <a:rPr lang="en-US" sz="1300" b="1" spc="300" kern="0" dirty="0">
+            <a:pPr marL="0" indent="0" algn="l">
+              <a:buNone/>
+            </a:pPr>
+            <a:r>
+              <a:rPr lang="en-US" sz="1300" b="1" kern="0" spc="300" dirty="0">
                 <a:solidFill>
                   <a:srgbClr val="FF8A3D"/>
                 </a:solidFill>
@@ -3990,7 +3692,7 @@
           <a:bodyPr wrap="square" lIns="0" tIns="0" rIns="0" bIns="0" rtlCol="0" anchor="ctr"/>
           <a:lstStyle/>
           <a:p>
-            <a:pPr algn="l" indent="0" marL="0">
+            <a:pPr marL="0" indent="0" algn="l">
               <a:buNone/>
             </a:pPr>
             <a:r>
@@ -4031,8 +3733,20 @@
             <a:tbl>
               <a:tblPr/>
               <a:tblGrid>
-                <a:gridCol w="3657600"/>
-                <a:gridCol w="7315200"/>
+                <a:gridCol w="3657600">
+                  <a:extLst>
+                    <a:ext uri="{9D8B030D-6E8A-4147-A177-3AD203B41FA5}">
+                      <a16:colId xmlns:a16="http://schemas.microsoft.com/office/drawing/2014/main" val="20000"/>
+                    </a:ext>
+                  </a:extLst>
+                </a:gridCol>
+                <a:gridCol w="7315200">
+                  <a:extLst>
+                    <a:ext uri="{9D8B030D-6E8A-4147-A177-3AD203B41FA5}">
+                      <a16:colId xmlns:a16="http://schemas.microsoft.com/office/drawing/2014/main" val="20001"/>
+                    </a:ext>
+                  </a:extLst>
+                </a:gridCol>
               </a:tblGrid>
               <a:tr h="566928">
                 <a:tc>
@@ -4040,7 +3754,7 @@
                     <a:bodyPr/>
                     <a:lstStyle/>
                     <a:p>
-                      <a:pPr algn="ctr" indent="0" marL="0">
+                      <a:pPr marL="0" indent="0" algn="ctr">
                         <a:buNone/>
                       </a:pPr>
                       <a:r>
@@ -4061,7 +3775,7 @@
                       </a:endParaRPr>
                     </a:p>
                   </a:txBody>
-                  <a:tcPr marL="91440" marR="91440" marT="45720" marB="45720" anchor="ctr">
+                  <a:tcPr anchor="ctr">
                     <a:lnL w="12700" cap="flat" cmpd="sng" algn="ctr">
                       <a:solidFill>
                         <a:srgbClr val="D8D8E6"/>
@@ -4108,7 +3822,7 @@
                     <a:bodyPr/>
                     <a:lstStyle/>
                     <a:p>
-                      <a:pPr algn="ctr" indent="0" marL="0">
+                      <a:pPr marL="0" indent="0" algn="ctr">
                         <a:buNone/>
                       </a:pPr>
                       <a:r>
@@ -4129,7 +3843,7 @@
                       </a:endParaRPr>
                     </a:p>
                   </a:txBody>
-                  <a:tcPr marL="91440" marR="91440" marT="45720" marB="45720" anchor="ctr">
+                  <a:tcPr anchor="ctr">
                     <a:lnL w="12700" cap="flat" cmpd="sng" algn="ctr">
                       <a:solidFill>
                         <a:srgbClr val="D8D8E6"/>
@@ -4171,6 +3885,11 @@
                     </a:solidFill>
                   </a:tcPr>
                 </a:tc>
+                <a:extLst>
+                  <a:ext uri="{0D108BD9-81ED-4DB2-BD59-A6C34878D82A}">
+                    <a16:rowId xmlns:a16="http://schemas.microsoft.com/office/drawing/2014/main" val="10000"/>
+                  </a:ext>
+                </a:extLst>
               </a:tr>
               <a:tr h="566928">
                 <a:tc>
@@ -4178,7 +3897,7 @@
                     <a:bodyPr/>
                     <a:lstStyle/>
                     <a:p>
-                      <a:pPr algn="l" indent="0" marL="0">
+                      <a:pPr marL="0" indent="0" algn="l">
                         <a:buNone/>
                       </a:pPr>
                       <a:r>
@@ -4199,7 +3918,7 @@
                       </a:endParaRPr>
                     </a:p>
                   </a:txBody>
-                  <a:tcPr marL="91440" marR="91440" marT="45720" marB="45720" anchor="ctr">
+                  <a:tcPr anchor="ctr">
                     <a:lnL w="12700" cap="flat" cmpd="sng" algn="ctr">
                       <a:solidFill>
                         <a:srgbClr val="D8D8E6"/>
@@ -4246,7 +3965,7 @@
                     <a:bodyPr/>
                     <a:lstStyle/>
                     <a:p>
-                      <a:pPr algn="ctr" indent="0" marL="0">
+                      <a:pPr marL="0" indent="0" algn="ctr">
                         <a:buNone/>
                       </a:pPr>
                       <a:r>
@@ -4267,7 +3986,7 @@
                       </a:endParaRPr>
                     </a:p>
                   </a:txBody>
-                  <a:tcPr marL="91440" marR="91440" marT="45720" marB="45720" anchor="ctr">
+                  <a:tcPr anchor="ctr">
                     <a:lnL w="12700" cap="flat" cmpd="sng" algn="ctr">
                       <a:solidFill>
                         <a:srgbClr val="D8D8E6"/>
@@ -4309,6 +4028,11 @@
                     </a:solidFill>
                   </a:tcPr>
                 </a:tc>
+                <a:extLst>
+                  <a:ext uri="{0D108BD9-81ED-4DB2-BD59-A6C34878D82A}">
+                    <a16:rowId xmlns:a16="http://schemas.microsoft.com/office/drawing/2014/main" val="10001"/>
+                  </a:ext>
+                </a:extLst>
               </a:tr>
               <a:tr h="566928">
                 <a:tc>
@@ -4316,7 +4040,7 @@
                     <a:bodyPr/>
                     <a:lstStyle/>
                     <a:p>
-                      <a:pPr algn="l" indent="0" marL="0">
+                      <a:pPr marL="0" indent="0" algn="l">
                         <a:buNone/>
                       </a:pPr>
                       <a:r>
@@ -4337,7 +4061,7 @@
                       </a:endParaRPr>
                     </a:p>
                   </a:txBody>
-                  <a:tcPr marL="91440" marR="91440" marT="45720" marB="45720" anchor="ctr">
+                  <a:tcPr anchor="ctr">
                     <a:lnL w="12700" cap="flat" cmpd="sng" algn="ctr">
                       <a:solidFill>
                         <a:srgbClr val="D8D8E6"/>
@@ -4384,7 +4108,7 @@
                     <a:bodyPr/>
                     <a:lstStyle/>
                     <a:p>
-                      <a:pPr algn="ctr" indent="0" marL="0">
+                      <a:pPr marL="0" indent="0" algn="ctr">
                         <a:buNone/>
                       </a:pPr>
                       <a:r>
@@ -4405,7 +4129,7 @@
                       </a:endParaRPr>
                     </a:p>
                   </a:txBody>
-                  <a:tcPr marL="91440" marR="91440" marT="45720" marB="45720" anchor="ctr">
+                  <a:tcPr anchor="ctr">
                     <a:lnL w="12700" cap="flat" cmpd="sng" algn="ctr">
                       <a:solidFill>
                         <a:srgbClr val="D8D8E6"/>
@@ -4447,6 +4171,11 @@
                     </a:solidFill>
                   </a:tcPr>
                 </a:tc>
+                <a:extLst>
+                  <a:ext uri="{0D108BD9-81ED-4DB2-BD59-A6C34878D82A}">
+                    <a16:rowId xmlns:a16="http://schemas.microsoft.com/office/drawing/2014/main" val="10002"/>
+                  </a:ext>
+                </a:extLst>
               </a:tr>
               <a:tr h="566928">
                 <a:tc>
@@ -4454,7 +4183,7 @@
                     <a:bodyPr/>
                     <a:lstStyle/>
                     <a:p>
-                      <a:pPr algn="l" indent="0" marL="0">
+                      <a:pPr marL="0" indent="0" algn="l">
                         <a:buNone/>
                       </a:pPr>
                       <a:r>
@@ -4475,7 +4204,7 @@
                       </a:endParaRPr>
                     </a:p>
                   </a:txBody>
-                  <a:tcPr marL="91440" marR="91440" marT="45720" marB="45720" anchor="ctr">
+                  <a:tcPr anchor="ctr">
                     <a:lnL w="12700" cap="flat" cmpd="sng" algn="ctr">
                       <a:solidFill>
                         <a:srgbClr val="D8D8E6"/>
@@ -4522,7 +4251,7 @@
                     <a:bodyPr/>
                     <a:lstStyle/>
                     <a:p>
-                      <a:pPr algn="ctr" indent="0" marL="0">
+                      <a:pPr marL="0" indent="0" algn="ctr">
                         <a:buNone/>
                       </a:pPr>
                       <a:r>
@@ -4543,7 +4272,7 @@
                       </a:endParaRPr>
                     </a:p>
                   </a:txBody>
-                  <a:tcPr marL="91440" marR="91440" marT="45720" marB="45720" anchor="ctr">
+                  <a:tcPr anchor="ctr">
                     <a:lnL w="12700" cap="flat" cmpd="sng" algn="ctr">
                       <a:solidFill>
                         <a:srgbClr val="D8D8E6"/>
@@ -4585,6 +4314,11 @@
                     </a:solidFill>
                   </a:tcPr>
                 </a:tc>
+                <a:extLst>
+                  <a:ext uri="{0D108BD9-81ED-4DB2-BD59-A6C34878D82A}">
+                    <a16:rowId xmlns:a16="http://schemas.microsoft.com/office/drawing/2014/main" val="10003"/>
+                  </a:ext>
+                </a:extLst>
               </a:tr>
               <a:tr h="566928">
                 <a:tc>
@@ -4592,7 +4326,7 @@
                     <a:bodyPr/>
                     <a:lstStyle/>
                     <a:p>
-                      <a:pPr algn="l" indent="0" marL="0">
+                      <a:pPr marL="0" indent="0" algn="l">
                         <a:buNone/>
                       </a:pPr>
                       <a:r>
@@ -4613,7 +4347,7 @@
                       </a:endParaRPr>
                     </a:p>
                   </a:txBody>
-                  <a:tcPr marL="91440" marR="91440" marT="45720" marB="45720" anchor="ctr">
+                  <a:tcPr anchor="ctr">
                     <a:lnL w="12700" cap="flat" cmpd="sng" algn="ctr">
                       <a:solidFill>
                         <a:srgbClr val="D8D8E6"/>
@@ -4660,7 +4394,7 @@
                     <a:bodyPr/>
                     <a:lstStyle/>
                     <a:p>
-                      <a:pPr algn="ctr" indent="0" marL="0">
+                      <a:pPr marL="0" indent="0" algn="ctr">
                         <a:buNone/>
                       </a:pPr>
                       <a:r>
@@ -4681,7 +4415,7 @@
                       </a:endParaRPr>
                     </a:p>
                   </a:txBody>
-                  <a:tcPr marL="91440" marR="91440" marT="45720" marB="45720" anchor="ctr">
+                  <a:tcPr anchor="ctr">
                     <a:lnL w="12700" cap="flat" cmpd="sng" algn="ctr">
                       <a:solidFill>
                         <a:srgbClr val="D8D8E6"/>
@@ -4723,6 +4457,11 @@
                     </a:solidFill>
                   </a:tcPr>
                 </a:tc>
+                <a:extLst>
+                  <a:ext uri="{0D108BD9-81ED-4DB2-BD59-A6C34878D82A}">
+                    <a16:rowId xmlns:a16="http://schemas.microsoft.com/office/drawing/2014/main" val="10004"/>
+                  </a:ext>
+                </a:extLst>
               </a:tr>
             </a:tbl>
           </a:graphicData>
@@ -4745,7 +4484,7 @@
           <a:noFill/>
         </p:spPr>
         <p:txBody>
-          <a:bodyPr wrap="none" lIns="0" rIns="0" tIns="0" bIns="0">
+          <a:bodyPr wrap="none" lIns="0" tIns="0" rIns="0" bIns="0">
             <a:spAutoFit/>
           </a:bodyPr>
           <a:lstStyle/>
@@ -4787,6 +4526,7 @@
         <a:solidFill>
           <a:srgbClr val="FFFFFF"/>
         </a:solidFill>
+        <a:effectLst/>
       </p:bgPr>
     </p:bg>
     <p:spTree>
@@ -4824,11 +4564,11 @@
           <a:bodyPr wrap="square" lIns="0" tIns="0" rIns="0" bIns="0" rtlCol="0" anchor="ctr"/>
           <a:lstStyle/>
           <a:p>
-            <a:pPr algn="l" indent="0" marL="0">
-              <a:buNone/>
-            </a:pPr>
-            <a:r>
-              <a:rPr lang="en-US" sz="1300" b="1" spc="300" kern="0" dirty="0">
+            <a:pPr marL="0" indent="0" algn="l">
+              <a:buNone/>
+            </a:pPr>
+            <a:r>
+              <a:rPr lang="en-US" sz="1300" b="1" kern="0" spc="300" dirty="0">
                 <a:solidFill>
                   <a:srgbClr val="FF8A3D"/>
                 </a:solidFill>
@@ -4863,7 +4603,7 @@
           <a:bodyPr wrap="square" lIns="0" tIns="0" rIns="0" bIns="0" rtlCol="0" anchor="ctr"/>
           <a:lstStyle/>
           <a:p>
-            <a:pPr algn="l" indent="0" marL="0">
+            <a:pPr marL="0" indent="0" algn="l">
               <a:buNone/>
             </a:pPr>
             <a:r>
@@ -4904,7 +4644,10 @@
         </p:spPr>
         <p:txBody>
           <a:bodyPr/>
-          <a:p/>
+          <a:lstStyle/>
+          <a:p>
+            <a:endParaRPr/>
+          </a:p>
         </p:txBody>
       </p:sp>
       <p:sp>
@@ -4928,7 +4671,7 @@
           <a:bodyPr wrap="square" lIns="0" tIns="0" rIns="0" bIns="0" rtlCol="0" anchor="t"/>
           <a:lstStyle/>
           <a:p>
-            <a:pPr indent="0" marL="0">
+            <a:pPr marL="0" indent="0">
               <a:lnSpc>
                 <a:spcPct val="125000"/>
               </a:lnSpc>
@@ -4948,7 +4691,7 @@
             <a:endParaRPr lang="en-US" sz="1250" dirty="0"/>
           </a:p>
           <a:p>
-            <a:pPr indent="0" marL="0">
+            <a:pPr marL="0" indent="0">
               <a:lnSpc>
                 <a:spcPct val="125000"/>
               </a:lnSpc>
@@ -4968,7 +4711,7 @@
             <a:endParaRPr lang="en-US" sz="1250" dirty="0"/>
           </a:p>
           <a:p>
-            <a:pPr indent="0" marL="0">
+            <a:pPr marL="0" indent="0">
               <a:lnSpc>
                 <a:spcPct val="125000"/>
               </a:lnSpc>
@@ -4988,7 +4731,7 @@
             <a:endParaRPr lang="en-US" sz="1250" dirty="0"/>
           </a:p>
           <a:p>
-            <a:pPr indent="0" marL="0">
+            <a:pPr marL="0" indent="0">
               <a:lnSpc>
                 <a:spcPct val="125000"/>
               </a:lnSpc>
@@ -5008,7 +4751,7 @@
             <a:endParaRPr lang="en-US" sz="1250" dirty="0"/>
           </a:p>
           <a:p>
-            <a:pPr indent="0" marL="0">
+            <a:pPr marL="0" indent="0">
               <a:lnSpc>
                 <a:spcPct val="125000"/>
               </a:lnSpc>
@@ -5055,7 +4798,7 @@
             <a:prstDash val="solid"/>
           </a:ln>
           <a:effectLst>
-            <a:outerShdw sx="100000" sy="100000" kx="0" ky="0" algn="bl" rotWithShape="0" blurRad="101600" dist="38100" dir="5400000">
+            <a:outerShdw blurRad="101600" dist="38100" dir="5400000" algn="bl" rotWithShape="0">
               <a:srgbClr val="000000">
                 <a:alpha val="12000"/>
               </a:srgbClr>
@@ -5064,19 +4807,22 @@
         </p:spPr>
         <p:txBody>
           <a:bodyPr/>
-          <a:p/>
+          <a:lstStyle/>
+          <a:p>
+            <a:endParaRPr/>
+          </a:p>
         </p:txBody>
       </p:sp>
       <p:pic>
         <p:nvPicPr>
-          <p:cNvPr id="7" name="Image 0" descr="D:/GitHub/mern-web-book/docs/assets/img/lecture-08/transforms-2d-comparison.png">    </p:cNvPr>
+          <p:cNvPr id="7" name="Image 0" descr="D:/GitHub/mern-web-book/docs/assets/img/lecture-08/transforms-2d-comparison.png"/>
           <p:cNvPicPr>
             <a:picLocks noChangeAspect="1"/>
           </p:cNvPicPr>
           <p:nvPr/>
         </p:nvPicPr>
         <p:blipFill>
-          <a:blip r:embed="rId1"/>
+          <a:blip r:embed="rId3"/>
           <a:stretch>
             <a:fillRect/>
           </a:stretch>
@@ -5108,7 +4854,7 @@
           <a:noFill/>
         </p:spPr>
         <p:txBody>
-          <a:bodyPr wrap="none" lIns="0" rIns="0" tIns="0" bIns="0">
+          <a:bodyPr wrap="none" lIns="0" tIns="0" rIns="0" bIns="0">
             <a:spAutoFit/>
           </a:bodyPr>
           <a:lstStyle/>
@@ -5150,6 +4896,7 @@
         <a:solidFill>
           <a:srgbClr val="FFFFFF"/>
         </a:solidFill>
+        <a:effectLst/>
       </p:bgPr>
     </p:bg>
     <p:spTree>
@@ -5187,11 +4934,11 @@
           <a:bodyPr wrap="square" lIns="0" tIns="0" rIns="0" bIns="0" rtlCol="0" anchor="ctr"/>
           <a:lstStyle/>
           <a:p>
-            <a:pPr algn="l" indent="0" marL="0">
-              <a:buNone/>
-            </a:pPr>
-            <a:r>
-              <a:rPr lang="en-US" sz="1300" b="1" spc="300" kern="0" dirty="0">
+            <a:pPr marL="0" indent="0" algn="l">
+              <a:buNone/>
+            </a:pPr>
+            <a:r>
+              <a:rPr lang="en-US" sz="1300" b="1" kern="0" spc="300" dirty="0">
                 <a:solidFill>
                   <a:srgbClr val="FF8A3D"/>
                 </a:solidFill>
@@ -5226,7 +4973,7 @@
           <a:bodyPr wrap="square" lIns="0" tIns="0" rIns="0" bIns="0" rtlCol="0" anchor="ctr"/>
           <a:lstStyle/>
           <a:p>
-            <a:pPr algn="l" indent="0" marL="0">
+            <a:pPr marL="0" indent="0" algn="l">
               <a:buNone/>
             </a:pPr>
             <a:r>
@@ -5267,7 +5014,10 @@
         </p:spPr>
         <p:txBody>
           <a:bodyPr/>
-          <a:p/>
+          <a:lstStyle/>
+          <a:p>
+            <a:endParaRPr/>
+          </a:p>
         </p:txBody>
       </p:sp>
       <p:sp>
@@ -5291,7 +5041,7 @@
           <a:bodyPr wrap="square" lIns="0" tIns="0" rIns="0" bIns="0" rtlCol="0" anchor="t"/>
           <a:lstStyle/>
           <a:p>
-            <a:pPr indent="0" marL="0">
+            <a:pPr marL="0" indent="0">
               <a:lnSpc>
                 <a:spcPct val="125000"/>
               </a:lnSpc>
@@ -5311,7 +5061,7 @@
             <a:endParaRPr lang="en-US" sz="1250" dirty="0"/>
           </a:p>
           <a:p>
-            <a:pPr indent="0" marL="0">
+            <a:pPr marL="0" indent="0">
               <a:lnSpc>
                 <a:spcPct val="125000"/>
               </a:lnSpc>
@@ -5320,7 +5070,7 @@
             <a:endParaRPr lang="en-US" sz="1250" dirty="0"/>
           </a:p>
           <a:p>
-            <a:pPr indent="0" marL="0">
+            <a:pPr marL="0" indent="0">
               <a:lnSpc>
                 <a:spcPct val="125000"/>
               </a:lnSpc>
@@ -5340,7 +5090,7 @@
             <a:endParaRPr lang="en-US" sz="1250" dirty="0"/>
           </a:p>
           <a:p>
-            <a:pPr indent="0" marL="0">
+            <a:pPr marL="0" indent="0">
               <a:lnSpc>
                 <a:spcPct val="125000"/>
               </a:lnSpc>
@@ -5360,7 +5110,7 @@
             <a:endParaRPr lang="en-US" sz="1250" dirty="0"/>
           </a:p>
           <a:p>
-            <a:pPr indent="0" marL="0">
+            <a:pPr marL="0" indent="0">
               <a:lnSpc>
                 <a:spcPct val="125000"/>
               </a:lnSpc>
@@ -5380,7 +5130,7 @@
             <a:endParaRPr lang="en-US" sz="1250" dirty="0"/>
           </a:p>
           <a:p>
-            <a:pPr indent="0" marL="0">
+            <a:pPr marL="0" indent="0">
               <a:lnSpc>
                 <a:spcPct val="125000"/>
               </a:lnSpc>
@@ -5400,7 +5150,7 @@
             <a:endParaRPr lang="en-US" sz="1250" dirty="0"/>
           </a:p>
           <a:p>
-            <a:pPr indent="0" marL="0">
+            <a:pPr marL="0" indent="0">
               <a:lnSpc>
                 <a:spcPct val="125000"/>
               </a:lnSpc>
@@ -5447,7 +5197,7 @@
             <a:prstDash val="solid"/>
           </a:ln>
           <a:effectLst>
-            <a:outerShdw sx="100000" sy="100000" kx="0" ky="0" algn="bl" rotWithShape="0" blurRad="101600" dist="38100" dir="5400000">
+            <a:outerShdw blurRad="101600" dist="38100" dir="5400000" algn="bl" rotWithShape="0">
               <a:srgbClr val="000000">
                 <a:alpha val="12000"/>
               </a:srgbClr>
@@ -5456,19 +5206,22 @@
         </p:spPr>
         <p:txBody>
           <a:bodyPr/>
-          <a:p/>
+          <a:lstStyle/>
+          <a:p>
+            <a:endParaRPr/>
+          </a:p>
         </p:txBody>
       </p:sp>
       <p:pic>
         <p:nvPicPr>
-          <p:cNvPr id="7" name="Image 0" descr="D:/GitHub/mern-web-book/slides/assets/lecture-08/card3d.png">    </p:cNvPr>
+          <p:cNvPr id="7" name="Image 0" descr="D:/GitHub/mern-web-book/slides/assets/lecture-08/card3d.png"/>
           <p:cNvPicPr>
             <a:picLocks noChangeAspect="1"/>
           </p:cNvPicPr>
           <p:nvPr/>
         </p:nvPicPr>
         <p:blipFill>
-          <a:blip r:embed="rId1"/>
+          <a:blip r:embed="rId3"/>
           <a:stretch>
             <a:fillRect/>
           </a:stretch>
@@ -5500,7 +5253,7 @@
           <a:noFill/>
         </p:spPr>
         <p:txBody>
-          <a:bodyPr wrap="none" lIns="0" rIns="0" tIns="0" bIns="0">
+          <a:bodyPr wrap="none" lIns="0" tIns="0" rIns="0" bIns="0">
             <a:spAutoFit/>
           </a:bodyPr>
           <a:lstStyle/>
@@ -5542,6 +5295,7 @@
         <a:solidFill>
           <a:srgbClr val="FFFFFF"/>
         </a:solidFill>
+        <a:effectLst/>
       </p:bgPr>
     </p:bg>
     <p:spTree>
@@ -5579,11 +5333,11 @@
           <a:bodyPr wrap="square" lIns="0" tIns="0" rIns="0" bIns="0" rtlCol="0" anchor="ctr"/>
           <a:lstStyle/>
           <a:p>
-            <a:pPr algn="l" indent="0" marL="0">
-              <a:buNone/>
-            </a:pPr>
-            <a:r>
-              <a:rPr lang="en-US" sz="1300" b="1" spc="300" kern="0" dirty="0">
+            <a:pPr marL="0" indent="0" algn="l">
+              <a:buNone/>
+            </a:pPr>
+            <a:r>
+              <a:rPr lang="en-US" sz="1300" b="1" kern="0" spc="300" dirty="0">
                 <a:solidFill>
                   <a:srgbClr val="FF8A3D"/>
                 </a:solidFill>
@@ -5618,7 +5372,7 @@
           <a:bodyPr wrap="square" lIns="0" tIns="0" rIns="0" bIns="0" rtlCol="0" anchor="ctr"/>
           <a:lstStyle/>
           <a:p>
-            <a:pPr algn="l" indent="0" marL="0">
+            <a:pPr marL="0" indent="0" algn="l">
               <a:buNone/>
             </a:pPr>
             <a:r>
@@ -5659,7 +5413,10 @@
         </p:spPr>
         <p:txBody>
           <a:bodyPr/>
-          <a:p/>
+          <a:lstStyle/>
+          <a:p>
+            <a:endParaRPr/>
+          </a:p>
         </p:txBody>
       </p:sp>
       <p:sp>
@@ -5683,7 +5440,7 @@
           <a:bodyPr wrap="square" lIns="0" tIns="0" rIns="0" bIns="0" rtlCol="0" anchor="t"/>
           <a:lstStyle/>
           <a:p>
-            <a:pPr indent="0" marL="0">
+            <a:pPr marL="0" indent="0">
               <a:lnSpc>
                 <a:spcPct val="125000"/>
               </a:lnSpc>
@@ -5703,7 +5460,7 @@
             <a:endParaRPr lang="en-US" sz="1250" dirty="0"/>
           </a:p>
           <a:p>
-            <a:pPr indent="0" marL="0">
+            <a:pPr marL="0" indent="0">
               <a:lnSpc>
                 <a:spcPct val="125000"/>
               </a:lnSpc>
@@ -5723,7 +5480,7 @@
             <a:endParaRPr lang="en-US" sz="1250" dirty="0"/>
           </a:p>
           <a:p>
-            <a:pPr indent="0" marL="0">
+            <a:pPr marL="0" indent="0">
               <a:lnSpc>
                 <a:spcPct val="125000"/>
               </a:lnSpc>
@@ -5743,7 +5500,7 @@
             <a:endParaRPr lang="en-US" sz="1250" dirty="0"/>
           </a:p>
           <a:p>
-            <a:pPr indent="0" marL="0">
+            <a:pPr marL="0" indent="0">
               <a:lnSpc>
                 <a:spcPct val="125000"/>
               </a:lnSpc>
@@ -5763,7 +5520,7 @@
             <a:endParaRPr lang="en-US" sz="1250" dirty="0"/>
           </a:p>
           <a:p>
-            <a:pPr indent="0" marL="0">
+            <a:pPr marL="0" indent="0">
               <a:lnSpc>
                 <a:spcPct val="125000"/>
               </a:lnSpc>
@@ -5783,7 +5540,7 @@
             <a:endParaRPr lang="en-US" sz="1250" dirty="0"/>
           </a:p>
           <a:p>
-            <a:pPr indent="0" marL="0">
+            <a:pPr marL="0" indent="0">
               <a:lnSpc>
                 <a:spcPct val="125000"/>
               </a:lnSpc>
@@ -5803,7 +5560,7 @@
             <a:endParaRPr lang="en-US" sz="1250" dirty="0"/>
           </a:p>
           <a:p>
-            <a:pPr indent="0" marL="0">
+            <a:pPr marL="0" indent="0">
               <a:lnSpc>
                 <a:spcPct val="125000"/>
               </a:lnSpc>
@@ -5823,7 +5580,7 @@
             <a:endParaRPr lang="en-US" sz="1250" dirty="0"/>
           </a:p>
           <a:p>
-            <a:pPr indent="0" marL="0">
+            <a:pPr marL="0" indent="0">
               <a:lnSpc>
                 <a:spcPct val="125000"/>
               </a:lnSpc>
@@ -5870,7 +5627,7 @@
             <a:prstDash val="solid"/>
           </a:ln>
           <a:effectLst>
-            <a:outerShdw sx="100000" sy="100000" kx="0" ky="0" algn="bl" rotWithShape="0" blurRad="101600" dist="38100" dir="5400000">
+            <a:outerShdw blurRad="101600" dist="38100" dir="5400000" algn="bl" rotWithShape="0">
               <a:srgbClr val="000000">
                 <a:alpha val="12000"/>
               </a:srgbClr>
@@ -5879,19 +5636,22 @@
         </p:spPr>
         <p:txBody>
           <a:bodyPr/>
-          <a:p/>
+          <a:lstStyle/>
+          <a:p>
+            <a:endParaRPr/>
+          </a:p>
         </p:txBody>
       </p:sp>
       <p:pic>
         <p:nvPicPr>
-          <p:cNvPr id="7" name="Image 0" descr="D:/GitHub/mern-web-book/slides/assets/lecture-08/transition-btn.png">    </p:cNvPr>
+          <p:cNvPr id="7" name="Image 0" descr="D:/GitHub/mern-web-book/slides/assets/lecture-08/transition-btn.png"/>
           <p:cNvPicPr>
             <a:picLocks noChangeAspect="1"/>
           </p:cNvPicPr>
           <p:nvPr/>
         </p:nvPicPr>
         <p:blipFill>
-          <a:blip r:embed="rId1"/>
+          <a:blip r:embed="rId3"/>
           <a:stretch>
             <a:fillRect/>
           </a:stretch>
@@ -5923,7 +5683,7 @@
           <a:noFill/>
         </p:spPr>
         <p:txBody>
-          <a:bodyPr wrap="none" lIns="0" rIns="0" tIns="0" bIns="0">
+          <a:bodyPr wrap="none" lIns="0" tIns="0" rIns="0" bIns="0">
             <a:spAutoFit/>
           </a:bodyPr>
           <a:lstStyle/>
@@ -5965,6 +5725,7 @@
         <a:solidFill>
           <a:srgbClr val="FFFFFF"/>
         </a:solidFill>
+        <a:effectLst/>
       </p:bgPr>
     </p:bg>
     <p:spTree>
@@ -6002,11 +5763,11 @@
           <a:bodyPr wrap="square" lIns="0" tIns="0" rIns="0" bIns="0" rtlCol="0" anchor="ctr"/>
           <a:lstStyle/>
           <a:p>
-            <a:pPr algn="l" indent="0" marL="0">
-              <a:buNone/>
-            </a:pPr>
-            <a:r>
-              <a:rPr lang="en-US" sz="1300" b="1" spc="300" kern="0" dirty="0">
+            <a:pPr marL="0" indent="0" algn="l">
+              <a:buNone/>
+            </a:pPr>
+            <a:r>
+              <a:rPr lang="en-US" sz="1300" b="1" kern="0" spc="300" dirty="0">
                 <a:solidFill>
                   <a:srgbClr val="FF8A3D"/>
                 </a:solidFill>
@@ -6041,7 +5802,7 @@
           <a:bodyPr wrap="square" lIns="0" tIns="0" rIns="0" bIns="0" rtlCol="0" anchor="ctr"/>
           <a:lstStyle/>
           <a:p>
-            <a:pPr algn="l" indent="0" marL="0">
+            <a:pPr marL="0" indent="0" algn="l">
               <a:buNone/>
             </a:pPr>
             <a:r>
@@ -6082,7 +5843,10 @@
         </p:spPr>
         <p:txBody>
           <a:bodyPr/>
-          <a:p/>
+          <a:lstStyle/>
+          <a:p>
+            <a:endParaRPr/>
+          </a:p>
         </p:txBody>
       </p:sp>
       <p:sp>
@@ -6106,7 +5870,7 @@
           <a:bodyPr wrap="square" lIns="0" tIns="0" rIns="0" bIns="0" rtlCol="0" anchor="t"/>
           <a:lstStyle/>
           <a:p>
-            <a:pPr indent="0" marL="0">
+            <a:pPr marL="0" indent="0">
               <a:lnSpc>
                 <a:spcPct val="125000"/>
               </a:lnSpc>
@@ -6126,7 +5890,7 @@
             <a:endParaRPr lang="en-US" sz="1250" dirty="0"/>
           </a:p>
           <a:p>
-            <a:pPr indent="0" marL="0">
+            <a:pPr marL="0" indent="0">
               <a:lnSpc>
                 <a:spcPct val="125000"/>
               </a:lnSpc>
@@ -6146,7 +5910,7 @@
             <a:endParaRPr lang="en-US" sz="1250" dirty="0"/>
           </a:p>
           <a:p>
-            <a:pPr indent="0" marL="0">
+            <a:pPr marL="0" indent="0">
               <a:lnSpc>
                 <a:spcPct val="125000"/>
               </a:lnSpc>
@@ -6166,7 +5930,7 @@
             <a:endParaRPr lang="en-US" sz="1250" dirty="0"/>
           </a:p>
           <a:p>
-            <a:pPr indent="0" marL="0">
+            <a:pPr marL="0" indent="0">
               <a:lnSpc>
                 <a:spcPct val="125000"/>
               </a:lnSpc>
@@ -6186,7 +5950,7 @@
             <a:endParaRPr lang="en-US" sz="1250" dirty="0"/>
           </a:p>
           <a:p>
-            <a:pPr indent="0" marL="0">
+            <a:pPr marL="0" indent="0">
               <a:lnSpc>
                 <a:spcPct val="125000"/>
               </a:lnSpc>
@@ -6206,7 +5970,7 @@
             <a:endParaRPr lang="en-US" sz="1250" dirty="0"/>
           </a:p>
           <a:p>
-            <a:pPr indent="0" marL="0">
+            <a:pPr marL="0" indent="0">
               <a:lnSpc>
                 <a:spcPct val="125000"/>
               </a:lnSpc>
@@ -6215,7 +5979,7 @@
             <a:endParaRPr lang="en-US" sz="1250" dirty="0"/>
           </a:p>
           <a:p>
-            <a:pPr indent="0" marL="0">
+            <a:pPr marL="0" indent="0">
               <a:lnSpc>
                 <a:spcPct val="125000"/>
               </a:lnSpc>
@@ -6262,7 +6026,7 @@
             <a:prstDash val="solid"/>
           </a:ln>
           <a:effectLst>
-            <a:outerShdw sx="100000" sy="100000" kx="0" ky="0" algn="bl" rotWithShape="0" blurRad="101600" dist="38100" dir="5400000">
+            <a:outerShdw blurRad="101600" dist="38100" dir="5400000" algn="bl" rotWithShape="0">
               <a:srgbClr val="000000">
                 <a:alpha val="12000"/>
               </a:srgbClr>
@@ -6271,19 +6035,22 @@
         </p:spPr>
         <p:txBody>
           <a:bodyPr/>
-          <a:p/>
+          <a:lstStyle/>
+          <a:p>
+            <a:endParaRPr/>
+          </a:p>
         </p:txBody>
       </p:sp>
       <p:pic>
         <p:nvPicPr>
-          <p:cNvPr id="7" name="Image 0" descr="D:/GitHub/mern-web-book/slides/assets/lecture-08/bounce-frames.png">    </p:cNvPr>
+          <p:cNvPr id="7" name="Image 0" descr="D:/GitHub/mern-web-book/slides/assets/lecture-08/bounce-frames.png"/>
           <p:cNvPicPr>
             <a:picLocks noChangeAspect="1"/>
           </p:cNvPicPr>
           <p:nvPr/>
         </p:nvPicPr>
         <p:blipFill>
-          <a:blip r:embed="rId1"/>
+          <a:blip r:embed="rId3"/>
           <a:stretch>
             <a:fillRect/>
           </a:stretch>
@@ -6315,7 +6082,7 @@
           <a:noFill/>
         </p:spPr>
         <p:txBody>
-          <a:bodyPr wrap="none" lIns="0" rIns="0" tIns="0" bIns="0">
+          <a:bodyPr wrap="none" lIns="0" tIns="0" rIns="0" bIns="0">
             <a:spAutoFit/>
           </a:bodyPr>
           <a:lstStyle/>
@@ -6343,7 +6110,9 @@
       </p:sp>
       <p:sp>
         <p:nvSpPr>
-          <p:cNvPr id="11" name="Rounded Rectangle 10"/>
+          <p:cNvPr id="11" name="Rounded Rectangle 10">
+            <a:hlinkClick r:id="rId5"/>
+          </p:cNvPr>
           <p:cNvSpPr/>
           <p:nvPr/>
         </p:nvSpPr>
@@ -6382,7 +6151,7 @@
           </a:fontRef>
         </p:style>
         <p:txBody>
-          <a:bodyPr rtlCol="0" anchor="ctr" wrap="square" lIns="137160" rIns="137160" tIns="73152" bIns="73152"/>
+          <a:bodyPr wrap="square" lIns="137160" tIns="73152" rIns="137160" bIns="73152" rtlCol="0" anchor="ctr"/>
           <a:lstStyle/>
           <a:p>
             <a:pPr algn="ctr"/>
@@ -6427,6 +6196,7 @@
         <a:solidFill>
           <a:srgbClr val="FFFFFF"/>
         </a:solidFill>
+        <a:effectLst/>
       </p:bgPr>
     </p:bg>
     <p:spTree>
@@ -6464,11 +6234,11 @@
           <a:bodyPr wrap="square" lIns="0" tIns="0" rIns="0" bIns="0" rtlCol="0" anchor="ctr"/>
           <a:lstStyle/>
           <a:p>
-            <a:pPr algn="l" indent="0" marL="0">
-              <a:buNone/>
-            </a:pPr>
-            <a:r>
-              <a:rPr lang="en-US" sz="1300" b="1" spc="300" kern="0" dirty="0">
+            <a:pPr marL="0" indent="0" algn="l">
+              <a:buNone/>
+            </a:pPr>
+            <a:r>
+              <a:rPr lang="en-US" sz="1300" b="1" kern="0" spc="300" dirty="0">
                 <a:solidFill>
                   <a:srgbClr val="FF8A3D"/>
                 </a:solidFill>
@@ -6503,7 +6273,7 @@
           <a:bodyPr wrap="square" lIns="0" tIns="0" rIns="0" bIns="0" rtlCol="0" anchor="ctr"/>
           <a:lstStyle/>
           <a:p>
-            <a:pPr algn="l" indent="0" marL="0">
+            <a:pPr marL="0" indent="0" algn="l">
               <a:buNone/>
             </a:pPr>
             <a:r>
@@ -6544,8 +6314,20 @@
             <a:tbl>
               <a:tblPr/>
               <a:tblGrid>
-                <a:gridCol w="2743200"/>
-                <a:gridCol w="8229600"/>
+                <a:gridCol w="2743200">
+                  <a:extLst>
+                    <a:ext uri="{9D8B030D-6E8A-4147-A177-3AD203B41FA5}">
+                      <a16:colId xmlns:a16="http://schemas.microsoft.com/office/drawing/2014/main" val="20000"/>
+                    </a:ext>
+                  </a:extLst>
+                </a:gridCol>
+                <a:gridCol w="8229600">
+                  <a:extLst>
+                    <a:ext uri="{9D8B030D-6E8A-4147-A177-3AD203B41FA5}">
+                      <a16:colId xmlns:a16="http://schemas.microsoft.com/office/drawing/2014/main" val="20001"/>
+                    </a:ext>
+                  </a:extLst>
+                </a:gridCol>
               </a:tblGrid>
               <a:tr h="566928">
                 <a:tc>
@@ -6553,7 +6335,7 @@
                     <a:bodyPr/>
                     <a:lstStyle/>
                     <a:p>
-                      <a:pPr algn="ctr" indent="0" marL="0">
+                      <a:pPr marL="0" indent="0" algn="ctr">
                         <a:buNone/>
                       </a:pPr>
                       <a:r>
@@ -6574,7 +6356,7 @@
                       </a:endParaRPr>
                     </a:p>
                   </a:txBody>
-                  <a:tcPr marL="91440" marR="91440" marT="45720" marB="45720" anchor="ctr">
+                  <a:tcPr anchor="ctr">
                     <a:lnL w="12700" cap="flat" cmpd="sng" algn="ctr">
                       <a:solidFill>
                         <a:srgbClr val="D8D8E6"/>
@@ -6621,7 +6403,7 @@
                     <a:bodyPr/>
                     <a:lstStyle/>
                     <a:p>
-                      <a:pPr algn="ctr" indent="0" marL="0">
+                      <a:pPr marL="0" indent="0" algn="ctr">
                         <a:buNone/>
                       </a:pPr>
                       <a:r>
@@ -6642,7 +6424,7 @@
                       </a:endParaRPr>
                     </a:p>
                   </a:txBody>
-                  <a:tcPr marL="91440" marR="91440" marT="45720" marB="45720" anchor="ctr">
+                  <a:tcPr anchor="ctr">
                     <a:lnL w="12700" cap="flat" cmpd="sng" algn="ctr">
                       <a:solidFill>
                         <a:srgbClr val="D8D8E6"/>
@@ -6684,6 +6466,11 @@
                     </a:solidFill>
                   </a:tcPr>
                 </a:tc>
+                <a:extLst>
+                  <a:ext uri="{0D108BD9-81ED-4DB2-BD59-A6C34878D82A}">
+                    <a16:rowId xmlns:a16="http://schemas.microsoft.com/office/drawing/2014/main" val="10000"/>
+                  </a:ext>
+                </a:extLst>
               </a:tr>
               <a:tr h="566928">
                 <a:tc>
@@ -6691,7 +6478,7 @@
                     <a:bodyPr/>
                     <a:lstStyle/>
                     <a:p>
-                      <a:pPr algn="l" indent="0" marL="0">
+                      <a:pPr marL="0" indent="0" algn="l">
                         <a:buNone/>
                       </a:pPr>
                       <a:r>
@@ -6712,7 +6499,7 @@
                       </a:endParaRPr>
                     </a:p>
                   </a:txBody>
-                  <a:tcPr marL="91440" marR="91440" marT="45720" marB="45720" anchor="ctr">
+                  <a:tcPr anchor="ctr">
                     <a:lnL w="12700" cap="flat" cmpd="sng" algn="ctr">
                       <a:solidFill>
                         <a:srgbClr val="D8D8E6"/>
@@ -6759,7 +6546,7 @@
                     <a:bodyPr/>
                     <a:lstStyle/>
                     <a:p>
-                      <a:pPr algn="ctr" indent="0" marL="0">
+                      <a:pPr marL="0" indent="0" algn="ctr">
                         <a:buNone/>
                       </a:pPr>
                       <a:r>
@@ -6780,7 +6567,7 @@
                       </a:endParaRPr>
                     </a:p>
                   </a:txBody>
-                  <a:tcPr marL="91440" marR="91440" marT="45720" marB="45720" anchor="ctr">
+                  <a:tcPr anchor="ctr">
                     <a:lnL w="12700" cap="flat" cmpd="sng" algn="ctr">
                       <a:solidFill>
                         <a:srgbClr val="D8D8E6"/>
@@ -6822,6 +6609,11 @@
                     </a:solidFill>
                   </a:tcPr>
                 </a:tc>
+                <a:extLst>
+                  <a:ext uri="{0D108BD9-81ED-4DB2-BD59-A6C34878D82A}">
+                    <a16:rowId xmlns:a16="http://schemas.microsoft.com/office/drawing/2014/main" val="10001"/>
+                  </a:ext>
+                </a:extLst>
               </a:tr>
               <a:tr h="566928">
                 <a:tc>
@@ -6829,7 +6621,7 @@
                     <a:bodyPr/>
                     <a:lstStyle/>
                     <a:p>
-                      <a:pPr algn="l" indent="0" marL="0">
+                      <a:pPr marL="0" indent="0" algn="l">
                         <a:buNone/>
                       </a:pPr>
                       <a:r>
@@ -6850,7 +6642,7 @@
                       </a:endParaRPr>
                     </a:p>
                   </a:txBody>
-                  <a:tcPr marL="91440" marR="91440" marT="45720" marB="45720" anchor="ctr">
+                  <a:tcPr anchor="ctr">
                     <a:lnL w="12700" cap="flat" cmpd="sng" algn="ctr">
                       <a:solidFill>
                         <a:srgbClr val="D8D8E6"/>
@@ -6897,7 +6689,7 @@
                     <a:bodyPr/>
                     <a:lstStyle/>
                     <a:p>
-                      <a:pPr algn="ctr" indent="0" marL="0">
+                      <a:pPr marL="0" indent="0" algn="ctr">
                         <a:buNone/>
                       </a:pPr>
                       <a:r>
@@ -6918,7 +6710,7 @@
                       </a:endParaRPr>
                     </a:p>
                   </a:txBody>
-                  <a:tcPr marL="91440" marR="91440" marT="45720" marB="45720" anchor="ctr">
+                  <a:tcPr anchor="ctr">
                     <a:lnL w="12700" cap="flat" cmpd="sng" algn="ctr">
                       <a:solidFill>
                         <a:srgbClr val="D8D8E6"/>
@@ -6960,6 +6752,11 @@
                     </a:solidFill>
                   </a:tcPr>
                 </a:tc>
+                <a:extLst>
+                  <a:ext uri="{0D108BD9-81ED-4DB2-BD59-A6C34878D82A}">
+                    <a16:rowId xmlns:a16="http://schemas.microsoft.com/office/drawing/2014/main" val="10002"/>
+                  </a:ext>
+                </a:extLst>
               </a:tr>
               <a:tr h="566928">
                 <a:tc>
@@ -6967,7 +6764,7 @@
                     <a:bodyPr/>
                     <a:lstStyle/>
                     <a:p>
-                      <a:pPr algn="l" indent="0" marL="0">
+                      <a:pPr marL="0" indent="0" algn="l">
                         <a:buNone/>
                       </a:pPr>
                       <a:r>
@@ -6988,7 +6785,7 @@
                       </a:endParaRPr>
                     </a:p>
                   </a:txBody>
-                  <a:tcPr marL="91440" marR="91440" marT="45720" marB="45720" anchor="ctr">
+                  <a:tcPr anchor="ctr">
                     <a:lnL w="12700" cap="flat" cmpd="sng" algn="ctr">
                       <a:solidFill>
                         <a:srgbClr val="D8D8E6"/>
@@ -7035,7 +6832,7 @@
                     <a:bodyPr/>
                     <a:lstStyle/>
                     <a:p>
-                      <a:pPr algn="ctr" indent="0" marL="0">
+                      <a:pPr marL="0" indent="0" algn="ctr">
                         <a:buNone/>
                       </a:pPr>
                       <a:r>
@@ -7056,7 +6853,7 @@
                       </a:endParaRPr>
                     </a:p>
                   </a:txBody>
-                  <a:tcPr marL="91440" marR="91440" marT="45720" marB="45720" anchor="ctr">
+                  <a:tcPr anchor="ctr">
                     <a:lnL w="12700" cap="flat" cmpd="sng" algn="ctr">
                       <a:solidFill>
                         <a:srgbClr val="D8D8E6"/>
@@ -7098,6 +6895,11 @@
                     </a:solidFill>
                   </a:tcPr>
                 </a:tc>
+                <a:extLst>
+                  <a:ext uri="{0D108BD9-81ED-4DB2-BD59-A6C34878D82A}">
+                    <a16:rowId xmlns:a16="http://schemas.microsoft.com/office/drawing/2014/main" val="10003"/>
+                  </a:ext>
+                </a:extLst>
               </a:tr>
               <a:tr h="566928">
                 <a:tc>
@@ -7105,7 +6907,7 @@
                     <a:bodyPr/>
                     <a:lstStyle/>
                     <a:p>
-                      <a:pPr algn="l" indent="0" marL="0">
+                      <a:pPr marL="0" indent="0" algn="l">
                         <a:buNone/>
                       </a:pPr>
                       <a:r>
@@ -7126,7 +6928,7 @@
                       </a:endParaRPr>
                     </a:p>
                   </a:txBody>
-                  <a:tcPr marL="91440" marR="91440" marT="45720" marB="45720" anchor="ctr">
+                  <a:tcPr anchor="ctr">
                     <a:lnL w="12700" cap="flat" cmpd="sng" algn="ctr">
                       <a:solidFill>
                         <a:srgbClr val="D8D8E6"/>
@@ -7173,7 +6975,7 @@
                     <a:bodyPr/>
                     <a:lstStyle/>
                     <a:p>
-                      <a:pPr algn="ctr" indent="0" marL="0">
+                      <a:pPr marL="0" indent="0" algn="ctr">
                         <a:buNone/>
                       </a:pPr>
                       <a:r>
@@ -7194,7 +6996,7 @@
                       </a:endParaRPr>
                     </a:p>
                   </a:txBody>
-                  <a:tcPr marL="91440" marR="91440" marT="45720" marB="45720" anchor="ctr">
+                  <a:tcPr anchor="ctr">
                     <a:lnL w="12700" cap="flat" cmpd="sng" algn="ctr">
                       <a:solidFill>
                         <a:srgbClr val="D8D8E6"/>
@@ -7236,6 +7038,11 @@
                     </a:solidFill>
                   </a:tcPr>
                 </a:tc>
+                <a:extLst>
+                  <a:ext uri="{0D108BD9-81ED-4DB2-BD59-A6C34878D82A}">
+                    <a16:rowId xmlns:a16="http://schemas.microsoft.com/office/drawing/2014/main" val="10004"/>
+                  </a:ext>
+                </a:extLst>
               </a:tr>
             </a:tbl>
           </a:graphicData>
@@ -7258,7 +7065,7 @@
           <a:noFill/>
         </p:spPr>
         <p:txBody>
-          <a:bodyPr wrap="none" lIns="0" rIns="0" tIns="0" bIns="0">
+          <a:bodyPr wrap="none" lIns="0" tIns="0" rIns="0" bIns="0">
             <a:spAutoFit/>
           </a:bodyPr>
           <a:lstStyle/>
@@ -7300,6 +7107,7 @@
         <a:solidFill>
           <a:srgbClr val="FFFFFF"/>
         </a:solidFill>
+        <a:effectLst/>
       </p:bgPr>
     </p:bg>
     <p:spTree>
@@ -7337,11 +7145,11 @@
           <a:bodyPr wrap="square" lIns="0" tIns="0" rIns="0" bIns="0" rtlCol="0" anchor="ctr"/>
           <a:lstStyle/>
           <a:p>
-            <a:pPr algn="l" indent="0" marL="0">
-              <a:buNone/>
-            </a:pPr>
-            <a:r>
-              <a:rPr lang="en-US" sz="1300" b="1" spc="300" kern="0" dirty="0">
+            <a:pPr marL="0" indent="0" algn="l">
+              <a:buNone/>
+            </a:pPr>
+            <a:r>
+              <a:rPr lang="en-US" sz="1300" b="1" kern="0" spc="300" dirty="0">
                 <a:solidFill>
                   <a:srgbClr val="FF8A3D"/>
                 </a:solidFill>
@@ -7376,7 +7184,7 @@
           <a:bodyPr wrap="square" lIns="0" tIns="0" rIns="0" bIns="0" rtlCol="0" anchor="ctr"/>
           <a:lstStyle/>
           <a:p>
-            <a:pPr algn="l" indent="0" marL="0">
+            <a:pPr marL="0" indent="0" algn="l">
               <a:buNone/>
             </a:pPr>
             <a:r>
@@ -7422,7 +7230,10 @@
         </p:spPr>
         <p:txBody>
           <a:bodyPr/>
-          <a:p/>
+          <a:lstStyle/>
+          <a:p>
+            <a:endParaRPr/>
+          </a:p>
         </p:txBody>
       </p:sp>
       <p:sp>
@@ -7446,11 +7257,11 @@
           <a:bodyPr wrap="square" lIns="0" tIns="0" rIns="0" bIns="0" rtlCol="0" anchor="ctr"/>
           <a:lstStyle/>
           <a:p>
-            <a:pPr indent="0" marL="0">
-              <a:buNone/>
-            </a:pPr>
-            <a:r>
-              <a:rPr lang="en-US" sz="1000" b="1" spc="200" kern="0" dirty="0">
+            <a:pPr marL="0" indent="0">
+              <a:buNone/>
+            </a:pPr>
+            <a:r>
+              <a:rPr lang="en-US" sz="1000" b="1" kern="0" spc="200" dirty="0">
                 <a:solidFill>
                   <a:srgbClr val="1F7A46"/>
                 </a:solidFill>
@@ -7485,7 +7296,7 @@
           <a:bodyPr wrap="square" lIns="0" tIns="0" rIns="0" bIns="0" rtlCol="0" anchor="t"/>
           <a:lstStyle/>
           <a:p>
-            <a:pPr indent="0" marL="0">
+            <a:pPr marL="0" indent="0">
               <a:buNone/>
             </a:pPr>
             <a:r>
@@ -7520,7 +7331,7 @@
           <a:noFill/>
         </p:spPr>
         <p:txBody>
-          <a:bodyPr wrap="none" lIns="0" rIns="0" tIns="0" bIns="0">
+          <a:bodyPr wrap="none" lIns="0" tIns="0" rIns="0" bIns="0">
             <a:spAutoFit/>
           </a:bodyPr>
           <a:lstStyle/>
@@ -7562,6 +7373,7 @@
         <a:solidFill>
           <a:srgbClr val="FFFFFF"/>
         </a:solidFill>
+        <a:effectLst/>
       </p:bgPr>
     </p:bg>
     <p:spTree>
@@ -7599,11 +7411,11 @@
           <a:bodyPr wrap="square" lIns="0" tIns="0" rIns="0" bIns="0" rtlCol="0" anchor="ctr"/>
           <a:lstStyle/>
           <a:p>
-            <a:pPr algn="l" indent="0" marL="0">
-              <a:buNone/>
-            </a:pPr>
-            <a:r>
-              <a:rPr lang="en-US" sz="1300" b="1" spc="300" kern="0" dirty="0">
+            <a:pPr marL="0" indent="0" algn="l">
+              <a:buNone/>
+            </a:pPr>
+            <a:r>
+              <a:rPr lang="en-US" sz="1300" b="1" kern="0" spc="300" dirty="0">
                 <a:solidFill>
                   <a:srgbClr val="FF8A3D"/>
                 </a:solidFill>
@@ -7638,7 +7450,7 @@
           <a:bodyPr wrap="square" lIns="0" tIns="0" rIns="0" bIns="0" rtlCol="0" anchor="ctr"/>
           <a:lstStyle/>
           <a:p>
-            <a:pPr algn="l" indent="0" marL="0">
+            <a:pPr marL="0" indent="0" algn="l">
               <a:buNone/>
             </a:pPr>
             <a:r>
@@ -7677,7 +7489,10 @@
         </p:spPr>
         <p:txBody>
           <a:bodyPr/>
-          <a:p/>
+          <a:lstStyle/>
+          <a:p>
+            <a:endParaRPr/>
+          </a:p>
         </p:txBody>
       </p:sp>
       <p:sp>
@@ -7701,7 +7516,7 @@
           <a:bodyPr wrap="square" lIns="0" tIns="0" rIns="0" bIns="0" rtlCol="0" anchor="ctr"/>
           <a:lstStyle/>
           <a:p>
-            <a:pPr indent="0" marL="0">
+            <a:pPr marL="0" indent="0">
               <a:buNone/>
             </a:pPr>
             <a:r>
@@ -7740,7 +7555,10 @@
         </p:spPr>
         <p:txBody>
           <a:bodyPr/>
-          <a:p/>
+          <a:lstStyle/>
+          <a:p>
+            <a:endParaRPr/>
+          </a:p>
         </p:txBody>
       </p:sp>
       <p:sp>
@@ -7764,7 +7582,7 @@
           <a:bodyPr wrap="square" lIns="0" tIns="0" rIns="0" bIns="0" rtlCol="0" anchor="ctr"/>
           <a:lstStyle/>
           <a:p>
-            <a:pPr indent="0" marL="0">
+            <a:pPr marL="0" indent="0">
               <a:buNone/>
             </a:pPr>
             <a:r>
@@ -7803,7 +7621,10 @@
         </p:spPr>
         <p:txBody>
           <a:bodyPr/>
-          <a:p/>
+          <a:lstStyle/>
+          <a:p>
+            <a:endParaRPr/>
+          </a:p>
         </p:txBody>
       </p:sp>
       <p:sp>
@@ -7827,7 +7648,7 @@
           <a:bodyPr wrap="square" lIns="0" tIns="0" rIns="0" bIns="0" rtlCol="0" anchor="ctr"/>
           <a:lstStyle/>
           <a:p>
-            <a:pPr indent="0" marL="0">
+            <a:pPr marL="0" indent="0">
               <a:buNone/>
             </a:pPr>
             <a:r>
@@ -7862,7 +7683,7 @@
           <a:noFill/>
         </p:spPr>
         <p:txBody>
-          <a:bodyPr wrap="none" lIns="0" rIns="0" tIns="0" bIns="0">
+          <a:bodyPr wrap="none" lIns="0" tIns="0" rIns="0" bIns="0">
             <a:spAutoFit/>
           </a:bodyPr>
           <a:lstStyle/>
@@ -7904,6 +7725,7 @@
         <a:solidFill>
           <a:srgbClr val="FFFFFF"/>
         </a:solidFill>
+        <a:effectLst/>
       </p:bgPr>
     </p:bg>
     <p:spTree>
@@ -7941,11 +7763,11 @@
           <a:bodyPr wrap="square" lIns="0" tIns="0" rIns="0" bIns="0" rtlCol="0" anchor="ctr"/>
           <a:lstStyle/>
           <a:p>
-            <a:pPr algn="l" indent="0" marL="0">
-              <a:buNone/>
-            </a:pPr>
-            <a:r>
-              <a:rPr lang="en-US" sz="1300" b="1" spc="300" kern="0" dirty="0">
+            <a:pPr marL="0" indent="0" algn="l">
+              <a:buNone/>
+            </a:pPr>
+            <a:r>
+              <a:rPr lang="en-US" sz="1300" b="1" kern="0" spc="300" dirty="0">
                 <a:solidFill>
                   <a:srgbClr val="FF8A3D"/>
                 </a:solidFill>
@@ -7980,7 +7802,7 @@
           <a:bodyPr wrap="square" lIns="0" tIns="0" rIns="0" bIns="0" rtlCol="0" anchor="ctr"/>
           <a:lstStyle/>
           <a:p>
-            <a:pPr algn="l" indent="0" marL="0">
+            <a:pPr marL="0" indent="0" algn="l">
               <a:buNone/>
             </a:pPr>
             <a:r>
@@ -8019,7 +7841,10 @@
         </p:spPr>
         <p:txBody>
           <a:bodyPr/>
-          <a:p/>
+          <a:lstStyle/>
+          <a:p>
+            <a:endParaRPr/>
+          </a:p>
         </p:txBody>
       </p:sp>
       <p:sp>
@@ -8043,7 +7868,7 @@
           <a:bodyPr wrap="square" lIns="0" tIns="0" rIns="0" bIns="0" rtlCol="0" anchor="ctr"/>
           <a:lstStyle/>
           <a:p>
-            <a:pPr algn="ctr" indent="0" marL="0">
+            <a:pPr marL="0" indent="0" algn="ctr">
               <a:buNone/>
             </a:pPr>
             <a:r>
@@ -8082,7 +7907,7 @@
           <a:bodyPr wrap="square" lIns="0" tIns="0" rIns="0" bIns="0" rtlCol="0" anchor="ctr"/>
           <a:lstStyle/>
           <a:p>
-            <a:pPr indent="0" marL="0">
+            <a:pPr marL="0" indent="0">
               <a:buNone/>
             </a:pPr>
             <a:r>
@@ -8121,7 +7946,10 @@
         </p:spPr>
         <p:txBody>
           <a:bodyPr/>
-          <a:p/>
+          <a:lstStyle/>
+          <a:p>
+            <a:endParaRPr/>
+          </a:p>
         </p:txBody>
       </p:sp>
       <p:sp>
@@ -8145,7 +7973,7 @@
           <a:bodyPr wrap="square" lIns="0" tIns="0" rIns="0" bIns="0" rtlCol="0" anchor="ctr"/>
           <a:lstStyle/>
           <a:p>
-            <a:pPr algn="ctr" indent="0" marL="0">
+            <a:pPr marL="0" indent="0" algn="ctr">
               <a:buNone/>
             </a:pPr>
             <a:r>
@@ -8184,7 +8012,7 @@
           <a:bodyPr wrap="square" lIns="0" tIns="0" rIns="0" bIns="0" rtlCol="0" anchor="ctr"/>
           <a:lstStyle/>
           <a:p>
-            <a:pPr indent="0" marL="0">
+            <a:pPr marL="0" indent="0">
               <a:buNone/>
             </a:pPr>
             <a:r>
@@ -8223,7 +8051,10 @@
         </p:spPr>
         <p:txBody>
           <a:bodyPr/>
-          <a:p/>
+          <a:lstStyle/>
+          <a:p>
+            <a:endParaRPr/>
+          </a:p>
         </p:txBody>
       </p:sp>
       <p:sp>
@@ -8247,7 +8078,7 @@
           <a:bodyPr wrap="square" lIns="0" tIns="0" rIns="0" bIns="0" rtlCol="0" anchor="ctr"/>
           <a:lstStyle/>
           <a:p>
-            <a:pPr algn="ctr" indent="0" marL="0">
+            <a:pPr marL="0" indent="0" algn="ctr">
               <a:buNone/>
             </a:pPr>
             <a:r>
@@ -8286,7 +8117,7 @@
           <a:bodyPr wrap="square" lIns="0" tIns="0" rIns="0" bIns="0" rtlCol="0" anchor="ctr"/>
           <a:lstStyle/>
           <a:p>
-            <a:pPr indent="0" marL="0">
+            <a:pPr marL="0" indent="0">
               <a:buNone/>
             </a:pPr>
             <a:r>
@@ -8325,7 +8156,10 @@
         </p:spPr>
         <p:txBody>
           <a:bodyPr/>
-          <a:p/>
+          <a:lstStyle/>
+          <a:p>
+            <a:endParaRPr/>
+          </a:p>
         </p:txBody>
       </p:sp>
       <p:sp>
@@ -8349,7 +8183,7 @@
           <a:bodyPr wrap="square" lIns="0" tIns="0" rIns="0" bIns="0" rtlCol="0" anchor="ctr"/>
           <a:lstStyle/>
           <a:p>
-            <a:pPr algn="ctr" indent="0" marL="0">
+            <a:pPr marL="0" indent="0" algn="ctr">
               <a:buNone/>
             </a:pPr>
             <a:r>
@@ -8388,7 +8222,7 @@
           <a:bodyPr wrap="square" lIns="0" tIns="0" rIns="0" bIns="0" rtlCol="0" anchor="ctr"/>
           <a:lstStyle/>
           <a:p>
-            <a:pPr indent="0" marL="0">
+            <a:pPr marL="0" indent="0">
               <a:buNone/>
             </a:pPr>
             <a:r>
@@ -8427,7 +8261,10 @@
         </p:spPr>
         <p:txBody>
           <a:bodyPr/>
-          <a:p/>
+          <a:lstStyle/>
+          <a:p>
+            <a:endParaRPr/>
+          </a:p>
         </p:txBody>
       </p:sp>
       <p:sp>
@@ -8451,7 +8288,7 @@
           <a:bodyPr wrap="square" lIns="0" tIns="0" rIns="0" bIns="0" rtlCol="0" anchor="ctr"/>
           <a:lstStyle/>
           <a:p>
-            <a:pPr algn="ctr" indent="0" marL="0">
+            <a:pPr marL="0" indent="0" algn="ctr">
               <a:buNone/>
             </a:pPr>
             <a:r>
@@ -8490,7 +8327,7 @@
           <a:bodyPr wrap="square" lIns="0" tIns="0" rIns="0" bIns="0" rtlCol="0" anchor="ctr"/>
           <a:lstStyle/>
           <a:p>
-            <a:pPr indent="0" marL="0">
+            <a:pPr marL="0" indent="0">
               <a:buNone/>
             </a:pPr>
             <a:r>
@@ -8525,7 +8362,7 @@
           <a:noFill/>
         </p:spPr>
         <p:txBody>
-          <a:bodyPr wrap="none" lIns="0" rIns="0" tIns="0" bIns="0">
+          <a:bodyPr wrap="none" lIns="0" tIns="0" rIns="0" bIns="0">
             <a:spAutoFit/>
           </a:bodyPr>
           <a:lstStyle/>
@@ -8567,6 +8404,7 @@
         <a:solidFill>
           <a:srgbClr val="FFFFFF"/>
         </a:solidFill>
+        <a:effectLst/>
       </p:bgPr>
     </p:bg>
     <p:spTree>
@@ -8604,11 +8442,11 @@
           <a:bodyPr wrap="square" lIns="0" tIns="0" rIns="0" bIns="0" rtlCol="0" anchor="ctr"/>
           <a:lstStyle/>
           <a:p>
-            <a:pPr algn="l" indent="0" marL="0">
-              <a:buNone/>
-            </a:pPr>
-            <a:r>
-              <a:rPr lang="en-US" sz="1300" b="1" spc="300" kern="0" dirty="0">
+            <a:pPr marL="0" indent="0" algn="l">
+              <a:buNone/>
+            </a:pPr>
+            <a:r>
+              <a:rPr lang="en-US" sz="1300" b="1" kern="0" spc="300" dirty="0">
                 <a:solidFill>
                   <a:srgbClr val="FF8A3D"/>
                 </a:solidFill>
@@ -8643,7 +8481,7 @@
           <a:bodyPr wrap="square" lIns="0" tIns="0" rIns="0" bIns="0" rtlCol="0" anchor="ctr"/>
           <a:lstStyle/>
           <a:p>
-            <a:pPr algn="l" indent="0" marL="0">
+            <a:pPr marL="0" indent="0" algn="l">
               <a:buNone/>
             </a:pPr>
             <a:r>
@@ -8684,7 +8522,10 @@
         </p:spPr>
         <p:txBody>
           <a:bodyPr/>
-          <a:p/>
+          <a:lstStyle/>
+          <a:p>
+            <a:endParaRPr/>
+          </a:p>
         </p:txBody>
       </p:sp>
       <p:sp>
@@ -8708,7 +8549,7 @@
           <a:bodyPr wrap="square" lIns="0" tIns="0" rIns="0" bIns="0" rtlCol="0" anchor="t"/>
           <a:lstStyle/>
           <a:p>
-            <a:pPr indent="0" marL="0">
+            <a:pPr marL="0" indent="0">
               <a:lnSpc>
                 <a:spcPct val="125000"/>
               </a:lnSpc>
@@ -8728,7 +8569,7 @@
             <a:endParaRPr lang="en-US" sz="1400" dirty="0"/>
           </a:p>
           <a:p>
-            <a:pPr indent="0" marL="0">
+            <a:pPr marL="0" indent="0">
               <a:lnSpc>
                 <a:spcPct val="125000"/>
               </a:lnSpc>
@@ -8748,7 +8589,7 @@
             <a:endParaRPr lang="en-US" sz="1400" dirty="0"/>
           </a:p>
           <a:p>
-            <a:pPr indent="0" marL="0">
+            <a:pPr marL="0" indent="0">
               <a:lnSpc>
                 <a:spcPct val="125000"/>
               </a:lnSpc>
@@ -8768,7 +8609,7 @@
             <a:endParaRPr lang="en-US" sz="1400" dirty="0"/>
           </a:p>
           <a:p>
-            <a:pPr indent="0" marL="0">
+            <a:pPr marL="0" indent="0">
               <a:lnSpc>
                 <a:spcPct val="125000"/>
               </a:lnSpc>
@@ -8788,7 +8629,7 @@
             <a:endParaRPr lang="en-US" sz="1400" dirty="0"/>
           </a:p>
           <a:p>
-            <a:pPr indent="0" marL="0">
+            <a:pPr marL="0" indent="0">
               <a:lnSpc>
                 <a:spcPct val="125000"/>
               </a:lnSpc>
@@ -8797,7 +8638,7 @@
             <a:endParaRPr lang="en-US" sz="1400" dirty="0"/>
           </a:p>
           <a:p>
-            <a:pPr indent="0" marL="0">
+            <a:pPr marL="0" indent="0">
               <a:lnSpc>
                 <a:spcPct val="125000"/>
               </a:lnSpc>
@@ -8817,7 +8658,7 @@
             <a:endParaRPr lang="en-US" sz="1400" dirty="0"/>
           </a:p>
           <a:p>
-            <a:pPr indent="0" marL="0">
+            <a:pPr marL="0" indent="0">
               <a:lnSpc>
                 <a:spcPct val="125000"/>
               </a:lnSpc>
@@ -8837,7 +8678,7 @@
             <a:endParaRPr lang="en-US" sz="1400" dirty="0"/>
           </a:p>
           <a:p>
-            <a:pPr indent="0" marL="0">
+            <a:pPr marL="0" indent="0">
               <a:lnSpc>
                 <a:spcPct val="125000"/>
               </a:lnSpc>
@@ -8857,7 +8698,7 @@
             <a:endParaRPr lang="en-US" sz="1400" dirty="0"/>
           </a:p>
           <a:p>
-            <a:pPr indent="0" marL="0">
+            <a:pPr marL="0" indent="0">
               <a:lnSpc>
                 <a:spcPct val="125000"/>
               </a:lnSpc>
@@ -8899,7 +8740,7 @@
           <a:bodyPr wrap="square" lIns="0" tIns="0" rIns="0" bIns="0" rtlCol="0" anchor="t"/>
           <a:lstStyle/>
           <a:p>
-            <a:pPr indent="0" marL="0">
+            <a:pPr marL="0" indent="0">
               <a:buNone/>
             </a:pPr>
             <a:r>
@@ -8934,7 +8775,7 @@
           <a:noFill/>
         </p:spPr>
         <p:txBody>
-          <a:bodyPr wrap="none" lIns="0" rIns="0" tIns="0" bIns="0">
+          <a:bodyPr wrap="none" lIns="0" tIns="0" rIns="0" bIns="0">
             <a:spAutoFit/>
           </a:bodyPr>
           <a:lstStyle/>
@@ -8976,6 +8817,7 @@
         <a:solidFill>
           <a:srgbClr val="FFFFFF"/>
         </a:solidFill>
+        <a:effectLst/>
       </p:bgPr>
     </p:bg>
     <p:spTree>
@@ -9013,11 +8855,11 @@
           <a:bodyPr wrap="square" lIns="0" tIns="0" rIns="0" bIns="0" rtlCol="0" anchor="ctr"/>
           <a:lstStyle/>
           <a:p>
-            <a:pPr algn="l" indent="0" marL="0">
-              <a:buNone/>
-            </a:pPr>
-            <a:r>
-              <a:rPr lang="en-US" sz="1300" b="1" spc="300" kern="0" dirty="0">
+            <a:pPr marL="0" indent="0" algn="l">
+              <a:buNone/>
+            </a:pPr>
+            <a:r>
+              <a:rPr lang="en-US" sz="1300" b="1" kern="0" spc="300" dirty="0">
                 <a:solidFill>
                   <a:srgbClr val="FF8A3D"/>
                 </a:solidFill>
@@ -9052,7 +8894,7 @@
           <a:bodyPr wrap="square" lIns="0" tIns="0" rIns="0" bIns="0" rtlCol="0" anchor="ctr"/>
           <a:lstStyle/>
           <a:p>
-            <a:pPr algn="l" indent="0" marL="0">
+            <a:pPr marL="0" indent="0" algn="l">
               <a:buNone/>
             </a:pPr>
             <a:r>
@@ -9091,7 +8933,7 @@
           <a:bodyPr wrap="square" lIns="0" tIns="0" rIns="0" bIns="0" rtlCol="0" anchor="ctr"/>
           <a:lstStyle/>
           <a:p>
-            <a:pPr indent="0" marL="0">
+            <a:pPr marL="0" indent="0">
               <a:buNone/>
             </a:pPr>
             <a:r>
@@ -9135,7 +8977,7 @@
             <a:prstDash val="solid"/>
           </a:ln>
           <a:effectLst>
-            <a:outerShdw sx="100000" sy="100000" kx="0" ky="0" algn="bl" rotWithShape="0" blurRad="101600" dist="38100" dir="5400000">
+            <a:outerShdw blurRad="101600" dist="38100" dir="5400000" algn="bl" rotWithShape="0">
               <a:srgbClr val="000000">
                 <a:alpha val="12000"/>
               </a:srgbClr>
@@ -9144,19 +8986,22 @@
         </p:spPr>
         <p:txBody>
           <a:bodyPr/>
-          <a:p/>
+          <a:lstStyle/>
+          <a:p>
+            <a:endParaRPr/>
+          </a:p>
         </p:txBody>
       </p:sp>
       <p:pic>
         <p:nvPicPr>
-          <p:cNvPr id="6" name="Image 0" descr="D:/GitHub/mern-web-book/docs/assets/img/lecture-08/custom-properties-demo.png">    </p:cNvPr>
+          <p:cNvPr id="6" name="Image 0" descr="D:/GitHub/mern-web-book/docs/assets/img/lecture-08/custom-properties-demo.png"/>
           <p:cNvPicPr>
             <a:picLocks noChangeAspect="1"/>
           </p:cNvPicPr>
           <p:nvPr/>
         </p:nvPicPr>
         <p:blipFill>
-          <a:blip r:embed="rId1"/>
+          <a:blip r:embed="rId3"/>
           <a:stretch>
             <a:fillRect/>
           </a:stretch>
@@ -9188,7 +9033,7 @@
           <a:noFill/>
         </p:spPr>
         <p:txBody>
-          <a:bodyPr wrap="none" lIns="0" rIns="0" tIns="0" bIns="0">
+          <a:bodyPr wrap="none" lIns="0" tIns="0" rIns="0" bIns="0">
             <a:spAutoFit/>
           </a:bodyPr>
           <a:lstStyle/>
@@ -9230,6 +9075,7 @@
         <a:solidFill>
           <a:srgbClr val="FFFFFF"/>
         </a:solidFill>
+        <a:effectLst/>
       </p:bgPr>
     </p:bg>
     <p:spTree>
@@ -9267,11 +9113,11 @@
           <a:bodyPr wrap="square" lIns="0" tIns="0" rIns="0" bIns="0" rtlCol="0" anchor="ctr"/>
           <a:lstStyle/>
           <a:p>
-            <a:pPr algn="l" indent="0" marL="0">
-              <a:buNone/>
-            </a:pPr>
-            <a:r>
-              <a:rPr lang="en-US" sz="1300" b="1" spc="300" kern="0" dirty="0">
+            <a:pPr marL="0" indent="0" algn="l">
+              <a:buNone/>
+            </a:pPr>
+            <a:r>
+              <a:rPr lang="en-US" sz="1300" b="1" kern="0" spc="300" dirty="0">
                 <a:solidFill>
                   <a:srgbClr val="FF8A3D"/>
                 </a:solidFill>
@@ -9306,7 +9152,7 @@
           <a:bodyPr wrap="square" lIns="0" tIns="0" rIns="0" bIns="0" rtlCol="0" anchor="ctr"/>
           <a:lstStyle/>
           <a:p>
-            <a:pPr algn="l" indent="0" marL="0">
+            <a:pPr marL="0" indent="0" algn="l">
               <a:buNone/>
             </a:pPr>
             <a:r>
@@ -9345,7 +9191,10 @@
         </p:spPr>
         <p:txBody>
           <a:bodyPr/>
-          <a:p/>
+          <a:lstStyle/>
+          <a:p>
+            <a:endParaRPr/>
+          </a:p>
         </p:txBody>
       </p:sp>
       <p:sp>
@@ -9369,7 +9218,7 @@
           <a:bodyPr wrap="square" lIns="0" tIns="0" rIns="0" bIns="0" rtlCol="0" anchor="ctr"/>
           <a:lstStyle/>
           <a:p>
-            <a:pPr indent="0" marL="0">
+            <a:pPr marL="0" indent="0">
               <a:buNone/>
             </a:pPr>
             <a:r>
@@ -9408,7 +9257,10 @@
         </p:spPr>
         <p:txBody>
           <a:bodyPr/>
-          <a:p/>
+          <a:lstStyle/>
+          <a:p>
+            <a:endParaRPr/>
+          </a:p>
         </p:txBody>
       </p:sp>
       <p:sp>
@@ -9432,7 +9284,7 @@
           <a:bodyPr wrap="square" lIns="0" tIns="0" rIns="0" bIns="0" rtlCol="0" anchor="ctr"/>
           <a:lstStyle/>
           <a:p>
-            <a:pPr indent="0" marL="0">
+            <a:pPr marL="0" indent="0">
               <a:buNone/>
             </a:pPr>
             <a:r>
@@ -9471,7 +9323,10 @@
         </p:spPr>
         <p:txBody>
           <a:bodyPr/>
-          <a:p/>
+          <a:lstStyle/>
+          <a:p>
+            <a:endParaRPr/>
+          </a:p>
         </p:txBody>
       </p:sp>
       <p:sp>
@@ -9495,7 +9350,7 @@
           <a:bodyPr wrap="square" lIns="0" tIns="0" rIns="0" bIns="0" rtlCol="0" anchor="ctr"/>
           <a:lstStyle/>
           <a:p>
-            <a:pPr indent="0" marL="0">
+            <a:pPr marL="0" indent="0">
               <a:buNone/>
             </a:pPr>
             <a:r>
@@ -9530,7 +9385,7 @@
           <a:noFill/>
         </p:spPr>
         <p:txBody>
-          <a:bodyPr wrap="none" lIns="0" rIns="0" tIns="0" bIns="0">
+          <a:bodyPr wrap="none" lIns="0" tIns="0" rIns="0" bIns="0">
             <a:spAutoFit/>
           </a:bodyPr>
           <a:lstStyle/>
@@ -9572,6 +9427,7 @@
         <a:solidFill>
           <a:srgbClr val="FFFFFF"/>
         </a:solidFill>
+        <a:effectLst/>
       </p:bgPr>
     </p:bg>
     <p:spTree>
@@ -9609,11 +9465,11 @@
           <a:bodyPr wrap="square" lIns="0" tIns="0" rIns="0" bIns="0" rtlCol="0" anchor="ctr"/>
           <a:lstStyle/>
           <a:p>
-            <a:pPr algn="l" indent="0" marL="0">
-              <a:buNone/>
-            </a:pPr>
-            <a:r>
-              <a:rPr lang="en-US" sz="1300" b="1" spc="300" kern="0" dirty="0">
+            <a:pPr marL="0" indent="0" algn="l">
+              <a:buNone/>
+            </a:pPr>
+            <a:r>
+              <a:rPr lang="en-US" sz="1300" b="1" kern="0" spc="300" dirty="0">
                 <a:solidFill>
                   <a:srgbClr val="FF8A3D"/>
                 </a:solidFill>
@@ -9648,7 +9504,7 @@
           <a:bodyPr wrap="square" lIns="0" tIns="0" rIns="0" bIns="0" rtlCol="0" anchor="ctr"/>
           <a:lstStyle/>
           <a:p>
-            <a:pPr algn="l" indent="0" marL="0">
+            <a:pPr marL="0" indent="0" algn="l">
               <a:buNone/>
             </a:pPr>
             <a:r>
@@ -9689,8 +9545,20 @@
             <a:tbl>
               <a:tblPr/>
               <a:tblGrid>
-                <a:gridCol w="3108960"/>
-                <a:gridCol w="7863840"/>
+                <a:gridCol w="3108960">
+                  <a:extLst>
+                    <a:ext uri="{9D8B030D-6E8A-4147-A177-3AD203B41FA5}">
+                      <a16:colId xmlns:a16="http://schemas.microsoft.com/office/drawing/2014/main" val="20000"/>
+                    </a:ext>
+                  </a:extLst>
+                </a:gridCol>
+                <a:gridCol w="7863840">
+                  <a:extLst>
+                    <a:ext uri="{9D8B030D-6E8A-4147-A177-3AD203B41FA5}">
+                      <a16:colId xmlns:a16="http://schemas.microsoft.com/office/drawing/2014/main" val="20001"/>
+                    </a:ext>
+                  </a:extLst>
+                </a:gridCol>
               </a:tblGrid>
               <a:tr h="566928">
                 <a:tc>
@@ -9698,7 +9566,7 @@
                     <a:bodyPr/>
                     <a:lstStyle/>
                     <a:p>
-                      <a:pPr algn="ctr" indent="0" marL="0">
+                      <a:pPr marL="0" indent="0" algn="ctr">
                         <a:buNone/>
                       </a:pPr>
                       <a:r>
@@ -9719,7 +9587,7 @@
                       </a:endParaRPr>
                     </a:p>
                   </a:txBody>
-                  <a:tcPr marL="91440" marR="91440" marT="45720" marB="45720" anchor="ctr">
+                  <a:tcPr anchor="ctr">
                     <a:lnL w="12700" cap="flat" cmpd="sng" algn="ctr">
                       <a:solidFill>
                         <a:srgbClr val="D8D8E6"/>
@@ -9766,7 +9634,7 @@
                     <a:bodyPr/>
                     <a:lstStyle/>
                     <a:p>
-                      <a:pPr algn="ctr" indent="0" marL="0">
+                      <a:pPr marL="0" indent="0" algn="ctr">
                         <a:buNone/>
                       </a:pPr>
                       <a:r>
@@ -9787,7 +9655,7 @@
                       </a:endParaRPr>
                     </a:p>
                   </a:txBody>
-                  <a:tcPr marL="91440" marR="91440" marT="45720" marB="45720" anchor="ctr">
+                  <a:tcPr anchor="ctr">
                     <a:lnL w="12700" cap="flat" cmpd="sng" algn="ctr">
                       <a:solidFill>
                         <a:srgbClr val="D8D8E6"/>
@@ -9829,6 +9697,11 @@
                     </a:solidFill>
                   </a:tcPr>
                 </a:tc>
+                <a:extLst>
+                  <a:ext uri="{0D108BD9-81ED-4DB2-BD59-A6C34878D82A}">
+                    <a16:rowId xmlns:a16="http://schemas.microsoft.com/office/drawing/2014/main" val="10000"/>
+                  </a:ext>
+                </a:extLst>
               </a:tr>
               <a:tr h="566928">
                 <a:tc>
@@ -9836,7 +9709,7 @@
                     <a:bodyPr/>
                     <a:lstStyle/>
                     <a:p>
-                      <a:pPr algn="l" indent="0" marL="0">
+                      <a:pPr marL="0" indent="0" algn="l">
                         <a:buNone/>
                       </a:pPr>
                       <a:r>
@@ -9857,7 +9730,7 @@
                       </a:endParaRPr>
                     </a:p>
                   </a:txBody>
-                  <a:tcPr marL="91440" marR="91440" marT="45720" marB="45720" anchor="ctr">
+                  <a:tcPr anchor="ctr">
                     <a:lnL w="12700" cap="flat" cmpd="sng" algn="ctr">
                       <a:solidFill>
                         <a:srgbClr val="D8D8E6"/>
@@ -9904,7 +9777,7 @@
                     <a:bodyPr/>
                     <a:lstStyle/>
                     <a:p>
-                      <a:pPr algn="ctr" indent="0" marL="0">
+                      <a:pPr marL="0" indent="0" algn="ctr">
                         <a:buNone/>
                       </a:pPr>
                       <a:r>
@@ -9925,7 +9798,7 @@
                       </a:endParaRPr>
                     </a:p>
                   </a:txBody>
-                  <a:tcPr marL="91440" marR="91440" marT="45720" marB="45720" anchor="ctr">
+                  <a:tcPr anchor="ctr">
                     <a:lnL w="12700" cap="flat" cmpd="sng" algn="ctr">
                       <a:solidFill>
                         <a:srgbClr val="D8D8E6"/>
@@ -9967,6 +9840,11 @@
                     </a:solidFill>
                   </a:tcPr>
                 </a:tc>
+                <a:extLst>
+                  <a:ext uri="{0D108BD9-81ED-4DB2-BD59-A6C34878D82A}">
+                    <a16:rowId xmlns:a16="http://schemas.microsoft.com/office/drawing/2014/main" val="10001"/>
+                  </a:ext>
+                </a:extLst>
               </a:tr>
               <a:tr h="566928">
                 <a:tc>
@@ -9974,7 +9852,7 @@
                     <a:bodyPr/>
                     <a:lstStyle/>
                     <a:p>
-                      <a:pPr algn="l" indent="0" marL="0">
+                      <a:pPr marL="0" indent="0" algn="l">
                         <a:buNone/>
                       </a:pPr>
                       <a:r>
@@ -9995,7 +9873,7 @@
                       </a:endParaRPr>
                     </a:p>
                   </a:txBody>
-                  <a:tcPr marL="91440" marR="91440" marT="45720" marB="45720" anchor="ctr">
+                  <a:tcPr anchor="ctr">
                     <a:lnL w="12700" cap="flat" cmpd="sng" algn="ctr">
                       <a:solidFill>
                         <a:srgbClr val="D8D8E6"/>
@@ -10042,7 +9920,7 @@
                     <a:bodyPr/>
                     <a:lstStyle/>
                     <a:p>
-                      <a:pPr algn="ctr" indent="0" marL="0">
+                      <a:pPr marL="0" indent="0" algn="ctr">
                         <a:buNone/>
                       </a:pPr>
                       <a:r>
@@ -10063,7 +9941,7 @@
                       </a:endParaRPr>
                     </a:p>
                   </a:txBody>
-                  <a:tcPr marL="91440" marR="91440" marT="45720" marB="45720" anchor="ctr">
+                  <a:tcPr anchor="ctr">
                     <a:lnL w="12700" cap="flat" cmpd="sng" algn="ctr">
                       <a:solidFill>
                         <a:srgbClr val="D8D8E6"/>
@@ -10105,6 +9983,11 @@
                     </a:solidFill>
                   </a:tcPr>
                 </a:tc>
+                <a:extLst>
+                  <a:ext uri="{0D108BD9-81ED-4DB2-BD59-A6C34878D82A}">
+                    <a16:rowId xmlns:a16="http://schemas.microsoft.com/office/drawing/2014/main" val="10002"/>
+                  </a:ext>
+                </a:extLst>
               </a:tr>
               <a:tr h="566928">
                 <a:tc>
@@ -10112,7 +9995,7 @@
                     <a:bodyPr/>
                     <a:lstStyle/>
                     <a:p>
-                      <a:pPr algn="l" indent="0" marL="0">
+                      <a:pPr marL="0" indent="0" algn="l">
                         <a:buNone/>
                       </a:pPr>
                       <a:r>
@@ -10133,7 +10016,7 @@
                       </a:endParaRPr>
                     </a:p>
                   </a:txBody>
-                  <a:tcPr marL="91440" marR="91440" marT="45720" marB="45720" anchor="ctr">
+                  <a:tcPr anchor="ctr">
                     <a:lnL w="12700" cap="flat" cmpd="sng" algn="ctr">
                       <a:solidFill>
                         <a:srgbClr val="D8D8E6"/>
@@ -10180,7 +10063,7 @@
                     <a:bodyPr/>
                     <a:lstStyle/>
                     <a:p>
-                      <a:pPr algn="ctr" indent="0" marL="0">
+                      <a:pPr marL="0" indent="0" algn="ctr">
                         <a:buNone/>
                       </a:pPr>
                       <a:r>
@@ -10201,7 +10084,7 @@
                       </a:endParaRPr>
                     </a:p>
                   </a:txBody>
-                  <a:tcPr marL="91440" marR="91440" marT="45720" marB="45720" anchor="ctr">
+                  <a:tcPr anchor="ctr">
                     <a:lnL w="12700" cap="flat" cmpd="sng" algn="ctr">
                       <a:solidFill>
                         <a:srgbClr val="D8D8E6"/>
@@ -10243,6 +10126,11 @@
                     </a:solidFill>
                   </a:tcPr>
                 </a:tc>
+                <a:extLst>
+                  <a:ext uri="{0D108BD9-81ED-4DB2-BD59-A6C34878D82A}">
+                    <a16:rowId xmlns:a16="http://schemas.microsoft.com/office/drawing/2014/main" val="10003"/>
+                  </a:ext>
+                </a:extLst>
               </a:tr>
               <a:tr h="566928">
                 <a:tc>
@@ -10250,7 +10138,7 @@
                     <a:bodyPr/>
                     <a:lstStyle/>
                     <a:p>
-                      <a:pPr algn="l" indent="0" marL="0">
+                      <a:pPr marL="0" indent="0" algn="l">
                         <a:buNone/>
                       </a:pPr>
                       <a:r>
@@ -10271,7 +10159,7 @@
                       </a:endParaRPr>
                     </a:p>
                   </a:txBody>
-                  <a:tcPr marL="91440" marR="91440" marT="45720" marB="45720" anchor="ctr">
+                  <a:tcPr anchor="ctr">
                     <a:lnL w="12700" cap="flat" cmpd="sng" algn="ctr">
                       <a:solidFill>
                         <a:srgbClr val="D8D8E6"/>
@@ -10318,7 +10206,7 @@
                     <a:bodyPr/>
                     <a:lstStyle/>
                     <a:p>
-                      <a:pPr algn="ctr" indent="0" marL="0">
+                      <a:pPr marL="0" indent="0" algn="ctr">
                         <a:buNone/>
                       </a:pPr>
                       <a:r>
@@ -10339,7 +10227,7 @@
                       </a:endParaRPr>
                     </a:p>
                   </a:txBody>
-                  <a:tcPr marL="91440" marR="91440" marT="45720" marB="45720" anchor="ctr">
+                  <a:tcPr anchor="ctr">
                     <a:lnL w="12700" cap="flat" cmpd="sng" algn="ctr">
                       <a:solidFill>
                         <a:srgbClr val="D8D8E6"/>
@@ -10381,6 +10269,11 @@
                     </a:solidFill>
                   </a:tcPr>
                 </a:tc>
+                <a:extLst>
+                  <a:ext uri="{0D108BD9-81ED-4DB2-BD59-A6C34878D82A}">
+                    <a16:rowId xmlns:a16="http://schemas.microsoft.com/office/drawing/2014/main" val="10004"/>
+                  </a:ext>
+                </a:extLst>
               </a:tr>
             </a:tbl>
           </a:graphicData>
@@ -10407,7 +10300,7 @@
           <a:bodyPr wrap="square" lIns="0" tIns="0" rIns="0" bIns="0" rtlCol="0" anchor="ctr"/>
           <a:lstStyle/>
           <a:p>
-            <a:pPr indent="0" marL="0">
+            <a:pPr marL="0" indent="0">
               <a:buNone/>
             </a:pPr>
             <a:r>
@@ -10442,7 +10335,7 @@
           <a:noFill/>
         </p:spPr>
         <p:txBody>
-          <a:bodyPr wrap="none" lIns="0" rIns="0" tIns="0" bIns="0">
+          <a:bodyPr wrap="none" lIns="0" tIns="0" rIns="0" bIns="0">
             <a:spAutoFit/>
           </a:bodyPr>
           <a:lstStyle/>
@@ -10484,6 +10377,7 @@
         <a:solidFill>
           <a:srgbClr val="FFFFFF"/>
         </a:solidFill>
+        <a:effectLst/>
       </p:bgPr>
     </p:bg>
     <p:spTree>
@@ -10521,11 +10415,11 @@
           <a:bodyPr wrap="square" lIns="0" tIns="0" rIns="0" bIns="0" rtlCol="0" anchor="ctr"/>
           <a:lstStyle/>
           <a:p>
-            <a:pPr algn="l" indent="0" marL="0">
-              <a:buNone/>
-            </a:pPr>
-            <a:r>
-              <a:rPr lang="en-US" sz="1300" b="1" spc="300" kern="0" dirty="0">
+            <a:pPr marL="0" indent="0" algn="l">
+              <a:buNone/>
+            </a:pPr>
+            <a:r>
+              <a:rPr lang="en-US" sz="1300" b="1" kern="0" spc="300" dirty="0">
                 <a:solidFill>
                   <a:srgbClr val="FF8A3D"/>
                 </a:solidFill>
@@ -10560,7 +10454,7 @@
           <a:bodyPr wrap="square" lIns="0" tIns="0" rIns="0" bIns="0" rtlCol="0" anchor="ctr"/>
           <a:lstStyle/>
           <a:p>
-            <a:pPr algn="l" indent="0" marL="0">
+            <a:pPr marL="0" indent="0" algn="l">
               <a:buNone/>
             </a:pPr>
             <a:r>
@@ -10603,7 +10497,10 @@
         </p:spPr>
         <p:txBody>
           <a:bodyPr/>
-          <a:p/>
+          <a:lstStyle/>
+          <a:p>
+            <a:endParaRPr/>
+          </a:p>
         </p:txBody>
       </p:sp>
       <p:sp>
@@ -10631,7 +10528,10 @@
         </p:spPr>
         <p:txBody>
           <a:bodyPr/>
-          <a:p/>
+          <a:lstStyle/>
+          <a:p>
+            <a:endParaRPr/>
+          </a:p>
         </p:txBody>
       </p:sp>
       <p:sp>
@@ -10657,7 +10557,7 @@
           <a:bodyPr wrap="square" lIns="0" tIns="0" rIns="0" bIns="0" rtlCol="0" anchor="ctr"/>
           <a:lstStyle/>
           <a:p>
-            <a:pPr algn="ctr" indent="0" marL="0">
+            <a:pPr marL="0" indent="0" algn="ctr">
               <a:buNone/>
             </a:pPr>
             <a:r>
@@ -10700,7 +10600,10 @@
         </p:spPr>
         <p:txBody>
           <a:bodyPr/>
-          <a:p/>
+          <a:lstStyle/>
+          <a:p>
+            <a:endParaRPr/>
+          </a:p>
         </p:txBody>
       </p:sp>
       <p:sp>
@@ -10726,7 +10629,7 @@
           <a:bodyPr wrap="square" lIns="0" tIns="0" rIns="0" bIns="0" rtlCol="0" anchor="ctr"/>
           <a:lstStyle/>
           <a:p>
-            <a:pPr algn="ctr" indent="0" marL="0">
+            <a:pPr marL="0" indent="0" algn="ctr">
               <a:buNone/>
             </a:pPr>
             <a:r>
@@ -10769,7 +10672,10 @@
         </p:spPr>
         <p:txBody>
           <a:bodyPr/>
-          <a:p/>
+          <a:lstStyle/>
+          <a:p>
+            <a:endParaRPr/>
+          </a:p>
         </p:txBody>
       </p:sp>
       <p:sp>
@@ -10797,7 +10703,10 @@
         </p:spPr>
         <p:txBody>
           <a:bodyPr/>
-          <a:p/>
+          <a:lstStyle/>
+          <a:p>
+            <a:endParaRPr/>
+          </a:p>
         </p:txBody>
       </p:sp>
       <p:sp>
@@ -10825,7 +10734,10 @@
         </p:spPr>
         <p:txBody>
           <a:bodyPr/>
-          <a:p/>
+          <a:lstStyle/>
+          <a:p>
+            <a:endParaRPr/>
+          </a:p>
         </p:txBody>
       </p:sp>
       <p:sp>
@@ -10849,7 +10761,10 @@
         </p:spPr>
         <p:txBody>
           <a:bodyPr/>
-          <a:p/>
+          <a:lstStyle/>
+          <a:p>
+            <a:endParaRPr/>
+          </a:p>
         </p:txBody>
       </p:sp>
       <p:sp>
@@ -10873,7 +10788,7 @@
           <a:bodyPr wrap="square" lIns="0" tIns="0" rIns="0" bIns="0" rtlCol="0" anchor="ctr"/>
           <a:lstStyle/>
           <a:p>
-            <a:pPr algn="ctr" indent="0" marL="0">
+            <a:pPr marL="0" indent="0" algn="ctr">
               <a:lnSpc>
                 <a:spcPct val="105000"/>
               </a:lnSpc>
@@ -10915,7 +10830,10 @@
         </p:spPr>
         <p:txBody>
           <a:bodyPr/>
-          <a:p/>
+          <a:lstStyle/>
+          <a:p>
+            <a:endParaRPr/>
+          </a:p>
         </p:txBody>
       </p:sp>
       <p:sp>
@@ -10939,7 +10857,7 @@
           <a:bodyPr wrap="square" lIns="0" tIns="0" rIns="0" bIns="0" rtlCol="0" anchor="ctr"/>
           <a:lstStyle/>
           <a:p>
-            <a:pPr algn="ctr" indent="0" marL="0">
+            <a:pPr marL="0" indent="0" algn="ctr">
               <a:lnSpc>
                 <a:spcPct val="105000"/>
               </a:lnSpc>
@@ -10959,7 +10877,7 @@
             <a:endParaRPr lang="en-US" sz="1150" dirty="0"/>
           </a:p>
           <a:p>
-            <a:pPr algn="ctr" indent="0" marL="0">
+            <a:pPr marL="0" indent="0" algn="ctr">
               <a:lnSpc>
                 <a:spcPct val="105000"/>
               </a:lnSpc>
@@ -11001,7 +10919,10 @@
         </p:spPr>
         <p:txBody>
           <a:bodyPr/>
-          <a:p/>
+          <a:lstStyle/>
+          <a:p>
+            <a:endParaRPr/>
+          </a:p>
         </p:txBody>
       </p:sp>
       <p:sp>
@@ -11025,7 +10946,7 @@
           <a:bodyPr wrap="square" lIns="0" tIns="0" rIns="0" bIns="0" rtlCol="0" anchor="ctr"/>
           <a:lstStyle/>
           <a:p>
-            <a:pPr algn="ctr" indent="0" marL="0">
+            <a:pPr marL="0" indent="0" algn="ctr">
               <a:lnSpc>
                 <a:spcPct val="105000"/>
               </a:lnSpc>
@@ -11045,7 +10966,7 @@
             <a:endParaRPr lang="en-US" sz="1100" dirty="0"/>
           </a:p>
           <a:p>
-            <a:pPr algn="ctr" indent="0" marL="0">
+            <a:pPr marL="0" indent="0" algn="ctr">
               <a:lnSpc>
                 <a:spcPct val="105000"/>
               </a:lnSpc>
@@ -11065,7 +10986,7 @@
             <a:endParaRPr lang="en-US" sz="1100" dirty="0"/>
           </a:p>
           <a:p>
-            <a:pPr algn="ctr" indent="0" marL="0">
+            <a:pPr marL="0" indent="0" algn="ctr">
               <a:lnSpc>
                 <a:spcPct val="105000"/>
               </a:lnSpc>
@@ -11107,7 +11028,10 @@
         </p:spPr>
         <p:txBody>
           <a:bodyPr/>
-          <a:p/>
+          <a:lstStyle/>
+          <a:p>
+            <a:endParaRPr/>
+          </a:p>
         </p:txBody>
       </p:sp>
       <p:sp>
@@ -11131,7 +11055,7 @@
           <a:bodyPr wrap="square" lIns="0" tIns="0" rIns="0" bIns="0" rtlCol="0" anchor="ctr"/>
           <a:lstStyle/>
           <a:p>
-            <a:pPr algn="ctr" indent="0" marL="0">
+            <a:pPr marL="0" indent="0" algn="ctr">
               <a:lnSpc>
                 <a:spcPct val="105000"/>
               </a:lnSpc>
@@ -11151,7 +11075,7 @@
             <a:endParaRPr lang="en-US" sz="1200" dirty="0"/>
           </a:p>
           <a:p>
-            <a:pPr algn="ctr" indent="0" marL="0">
+            <a:pPr marL="0" indent="0" algn="ctr">
               <a:lnSpc>
                 <a:spcPct val="105000"/>
               </a:lnSpc>
@@ -11193,7 +11117,10 @@
         </p:spPr>
         <p:txBody>
           <a:bodyPr/>
-          <a:p/>
+          <a:lstStyle/>
+          <a:p>
+            <a:endParaRPr/>
+          </a:p>
         </p:txBody>
       </p:sp>
       <p:sp>
@@ -11217,7 +11144,7 @@
           <a:bodyPr wrap="square" lIns="0" tIns="0" rIns="0" bIns="0" rtlCol="0" anchor="ctr"/>
           <a:lstStyle/>
           <a:p>
-            <a:pPr algn="ctr" indent="0" marL="0">
+            <a:pPr marL="0" indent="0" algn="ctr">
               <a:lnSpc>
                 <a:spcPct val="105000"/>
               </a:lnSpc>
@@ -11259,7 +11186,10 @@
         </p:spPr>
         <p:txBody>
           <a:bodyPr/>
-          <a:p/>
+          <a:lstStyle/>
+          <a:p>
+            <a:endParaRPr/>
+          </a:p>
         </p:txBody>
       </p:sp>
       <p:sp>
@@ -11283,7 +11213,7 @@
           <a:bodyPr wrap="square" lIns="0" tIns="0" rIns="0" bIns="0" rtlCol="0" anchor="ctr"/>
           <a:lstStyle/>
           <a:p>
-            <a:pPr algn="ctr" indent="0" marL="0">
+            <a:pPr marL="0" indent="0" algn="ctr">
               <a:lnSpc>
                 <a:spcPct val="105000"/>
               </a:lnSpc>
@@ -11321,7 +11251,7 @@
           <a:noFill/>
         </p:spPr>
         <p:txBody>
-          <a:bodyPr wrap="none" lIns="0" rIns="0" tIns="0" bIns="0">
+          <a:bodyPr wrap="none" lIns="0" tIns="0" rIns="0" bIns="0">
             <a:spAutoFit/>
           </a:bodyPr>
           <a:lstStyle/>
@@ -11363,6 +11293,7 @@
         <a:solidFill>
           <a:srgbClr val="2B2B7A"/>
         </a:solidFill>
+        <a:effectLst/>
       </p:bgPr>
     </p:bg>
     <p:spTree>
@@ -11400,11 +11331,11 @@
           <a:bodyPr wrap="square" lIns="0" tIns="0" rIns="0" bIns="0" rtlCol="0" anchor="ctr"/>
           <a:lstStyle/>
           <a:p>
-            <a:pPr indent="0" marL="0">
-              <a:buNone/>
-            </a:pPr>
-            <a:r>
-              <a:rPr lang="en-US" sz="1500" b="1" spc="400" kern="0" dirty="0">
+            <a:pPr marL="0" indent="0">
+              <a:buNone/>
+            </a:pPr>
+            <a:r>
+              <a:rPr lang="en-US" sz="1500" b="1" kern="0" spc="400" dirty="0">
                 <a:solidFill>
                   <a:srgbClr val="FF8A3D"/>
                 </a:solidFill>
@@ -11439,7 +11370,7 @@
           <a:bodyPr wrap="square" lIns="0" tIns="0" rIns="0" bIns="0" rtlCol="0" anchor="ctr"/>
           <a:lstStyle/>
           <a:p>
-            <a:pPr indent="0" marL="0">
+            <a:pPr marL="0" indent="0">
               <a:buNone/>
             </a:pPr>
             <a:r>
@@ -11478,7 +11409,10 @@
         </p:spPr>
         <p:txBody>
           <a:bodyPr/>
-          <a:p/>
+          <a:lstStyle/>
+          <a:p>
+            <a:endParaRPr/>
+          </a:p>
         </p:txBody>
       </p:sp>
       <p:sp>
@@ -11502,7 +11436,7 @@
           <a:bodyPr wrap="square" lIns="0" tIns="0" rIns="0" bIns="0" rtlCol="0" anchor="ctr"/>
           <a:lstStyle/>
           <a:p>
-            <a:pPr algn="ctr" indent="0" marL="0">
+            <a:pPr marL="0" indent="0" algn="ctr">
               <a:buNone/>
             </a:pPr>
             <a:r>
@@ -11541,7 +11475,7 @@
           <a:bodyPr wrap="square" lIns="0" tIns="0" rIns="0" bIns="0" rtlCol="0" anchor="ctr"/>
           <a:lstStyle/>
           <a:p>
-            <a:pPr indent="0" marL="0">
+            <a:pPr marL="0" indent="0">
               <a:buNone/>
             </a:pPr>
             <a:r>
@@ -11580,7 +11514,10 @@
         </p:spPr>
         <p:txBody>
           <a:bodyPr/>
-          <a:p/>
+          <a:lstStyle/>
+          <a:p>
+            <a:endParaRPr/>
+          </a:p>
         </p:txBody>
       </p:sp>
       <p:sp>
@@ -11604,7 +11541,7 @@
           <a:bodyPr wrap="square" lIns="0" tIns="0" rIns="0" bIns="0" rtlCol="0" anchor="ctr"/>
           <a:lstStyle/>
           <a:p>
-            <a:pPr algn="ctr" indent="0" marL="0">
+            <a:pPr marL="0" indent="0" algn="ctr">
               <a:buNone/>
             </a:pPr>
             <a:r>
@@ -11643,7 +11580,7 @@
           <a:bodyPr wrap="square" lIns="0" tIns="0" rIns="0" bIns="0" rtlCol="0" anchor="ctr"/>
           <a:lstStyle/>
           <a:p>
-            <a:pPr indent="0" marL="0">
+            <a:pPr marL="0" indent="0">
               <a:buNone/>
             </a:pPr>
             <a:r>
@@ -11682,7 +11619,10 @@
         </p:spPr>
         <p:txBody>
           <a:bodyPr/>
-          <a:p/>
+          <a:lstStyle/>
+          <a:p>
+            <a:endParaRPr/>
+          </a:p>
         </p:txBody>
       </p:sp>
       <p:sp>
@@ -11706,7 +11646,7 @@
           <a:bodyPr wrap="square" lIns="0" tIns="0" rIns="0" bIns="0" rtlCol="0" anchor="ctr"/>
           <a:lstStyle/>
           <a:p>
-            <a:pPr algn="ctr" indent="0" marL="0">
+            <a:pPr marL="0" indent="0" algn="ctr">
               <a:buNone/>
             </a:pPr>
             <a:r>
@@ -11745,7 +11685,7 @@
           <a:bodyPr wrap="square" lIns="0" tIns="0" rIns="0" bIns="0" rtlCol="0" anchor="ctr"/>
           <a:lstStyle/>
           <a:p>
-            <a:pPr indent="0" marL="0">
+            <a:pPr marL="0" indent="0">
               <a:buNone/>
             </a:pPr>
             <a:r>
@@ -11784,7 +11724,10 @@
         </p:spPr>
         <p:txBody>
           <a:bodyPr/>
-          <a:p/>
+          <a:lstStyle/>
+          <a:p>
+            <a:endParaRPr/>
+          </a:p>
         </p:txBody>
       </p:sp>
       <p:sp>
@@ -11808,7 +11751,7 @@
           <a:bodyPr wrap="square" lIns="0" tIns="0" rIns="0" bIns="0" rtlCol="0" anchor="ctr"/>
           <a:lstStyle/>
           <a:p>
-            <a:pPr algn="ctr" indent="0" marL="0">
+            <a:pPr marL="0" indent="0" algn="ctr">
               <a:buNone/>
             </a:pPr>
             <a:r>
@@ -11847,7 +11790,7 @@
           <a:bodyPr wrap="square" lIns="0" tIns="0" rIns="0" bIns="0" rtlCol="0" anchor="ctr"/>
           <a:lstStyle/>
           <a:p>
-            <a:pPr indent="0" marL="0">
+            <a:pPr marL="0" indent="0">
               <a:buNone/>
             </a:pPr>
             <a:r>
@@ -11886,7 +11829,10 @@
         </p:spPr>
         <p:txBody>
           <a:bodyPr/>
-          <a:p/>
+          <a:lstStyle/>
+          <a:p>
+            <a:endParaRPr/>
+          </a:p>
         </p:txBody>
       </p:sp>
       <p:sp>
@@ -11910,7 +11856,7 @@
           <a:bodyPr wrap="square" lIns="0" tIns="0" rIns="0" bIns="0" rtlCol="0" anchor="ctr"/>
           <a:lstStyle/>
           <a:p>
-            <a:pPr algn="ctr" indent="0" marL="0">
+            <a:pPr marL="0" indent="0" algn="ctr">
               <a:buNone/>
             </a:pPr>
             <a:r>
@@ -11949,7 +11895,7 @@
           <a:bodyPr wrap="square" lIns="0" tIns="0" rIns="0" bIns="0" rtlCol="0" anchor="ctr"/>
           <a:lstStyle/>
           <a:p>
-            <a:pPr indent="0" marL="0">
+            <a:pPr marL="0" indent="0">
               <a:buNone/>
             </a:pPr>
             <a:r>
@@ -11988,7 +11934,10 @@
         </p:spPr>
         <p:txBody>
           <a:bodyPr/>
-          <a:p/>
+          <a:lstStyle/>
+          <a:p>
+            <a:endParaRPr/>
+          </a:p>
         </p:txBody>
       </p:sp>
       <p:sp>
@@ -12012,7 +11961,7 @@
           <a:bodyPr wrap="square" lIns="0" tIns="0" rIns="0" bIns="0" rtlCol="0" anchor="ctr"/>
           <a:lstStyle/>
           <a:p>
-            <a:pPr algn="ctr" indent="0" marL="0">
+            <a:pPr marL="0" indent="0" algn="ctr">
               <a:buNone/>
             </a:pPr>
             <a:r>
@@ -12051,7 +12000,7 @@
           <a:bodyPr wrap="square" lIns="0" tIns="0" rIns="0" bIns="0" rtlCol="0" anchor="ctr"/>
           <a:lstStyle/>
           <a:p>
-            <a:pPr indent="0" marL="0">
+            <a:pPr marL="0" indent="0">
               <a:buNone/>
             </a:pPr>
             <a:r>
@@ -12086,7 +12035,7 @@
           <a:noFill/>
         </p:spPr>
         <p:txBody>
-          <a:bodyPr wrap="none" lIns="0" rIns="0" tIns="0" bIns="0">
+          <a:bodyPr wrap="none" lIns="0" tIns="0" rIns="0" bIns="0">
             <a:spAutoFit/>
           </a:bodyPr>
           <a:lstStyle/>
@@ -12128,6 +12077,7 @@
         <a:solidFill>
           <a:srgbClr val="FFFFFF"/>
         </a:solidFill>
+        <a:effectLst/>
       </p:bgPr>
     </p:bg>
     <p:spTree>
@@ -12165,11 +12115,11 @@
           <a:bodyPr wrap="square" lIns="0" tIns="0" rIns="0" bIns="0" rtlCol="0" anchor="ctr"/>
           <a:lstStyle/>
           <a:p>
-            <a:pPr algn="l" indent="0" marL="0">
-              <a:buNone/>
-            </a:pPr>
-            <a:r>
-              <a:rPr lang="en-US" sz="1300" b="1" spc="300" kern="0" dirty="0">
+            <a:pPr marL="0" indent="0" algn="l">
+              <a:buNone/>
+            </a:pPr>
+            <a:r>
+              <a:rPr lang="en-US" sz="1300" b="1" kern="0" spc="300" dirty="0">
                 <a:solidFill>
                   <a:srgbClr val="FF8A3D"/>
                 </a:solidFill>
@@ -12204,7 +12154,7 @@
           <a:bodyPr wrap="square" lIns="0" tIns="0" rIns="0" bIns="0" rtlCol="0" anchor="ctr"/>
           <a:lstStyle/>
           <a:p>
-            <a:pPr algn="l" indent="0" marL="0">
+            <a:pPr marL="0" indent="0" algn="l">
               <a:buNone/>
             </a:pPr>
             <a:r>
@@ -12245,7 +12195,10 @@
         </p:spPr>
         <p:txBody>
           <a:bodyPr/>
-          <a:p/>
+          <a:lstStyle/>
+          <a:p>
+            <a:endParaRPr/>
+          </a:p>
         </p:txBody>
       </p:sp>
       <p:sp>
@@ -12269,7 +12222,7 @@
           <a:bodyPr wrap="square" lIns="0" tIns="0" rIns="0" bIns="0" rtlCol="0" anchor="t"/>
           <a:lstStyle/>
           <a:p>
-            <a:pPr indent="0" marL="0">
+            <a:pPr marL="0" indent="0">
               <a:lnSpc>
                 <a:spcPct val="125000"/>
               </a:lnSpc>
@@ -12289,7 +12242,7 @@
             <a:endParaRPr lang="en-US" sz="1400" dirty="0"/>
           </a:p>
           <a:p>
-            <a:pPr indent="0" marL="0">
+            <a:pPr marL="0" indent="0">
               <a:lnSpc>
                 <a:spcPct val="125000"/>
               </a:lnSpc>
@@ -12309,7 +12262,7 @@
             <a:endParaRPr lang="en-US" sz="1400" dirty="0"/>
           </a:p>
           <a:p>
-            <a:pPr indent="0" marL="0">
+            <a:pPr marL="0" indent="0">
               <a:lnSpc>
                 <a:spcPct val="125000"/>
               </a:lnSpc>
@@ -12351,7 +12304,7 @@
           <a:bodyPr wrap="square" lIns="0" tIns="0" rIns="0" bIns="0" rtlCol="0" anchor="t"/>
           <a:lstStyle/>
           <a:p>
-            <a:pPr indent="0" marL="0">
+            <a:pPr marL="0" indent="0">
               <a:buNone/>
             </a:pPr>
             <a:r>
@@ -12386,7 +12339,7 @@
           <a:noFill/>
         </p:spPr>
         <p:txBody>
-          <a:bodyPr wrap="none" lIns="0" rIns="0" tIns="0" bIns="0">
+          <a:bodyPr wrap="none" lIns="0" tIns="0" rIns="0" bIns="0">
             <a:spAutoFit/>
           </a:bodyPr>
           <a:lstStyle/>
@@ -12428,6 +12381,7 @@
         <a:solidFill>
           <a:srgbClr val="FFFFFF"/>
         </a:solidFill>
+        <a:effectLst/>
       </p:bgPr>
     </p:bg>
     <p:spTree>
@@ -12465,11 +12419,11 @@
           <a:bodyPr wrap="square" lIns="0" tIns="0" rIns="0" bIns="0" rtlCol="0" anchor="ctr"/>
           <a:lstStyle/>
           <a:p>
-            <a:pPr algn="l" indent="0" marL="0">
-              <a:buNone/>
-            </a:pPr>
-            <a:r>
-              <a:rPr lang="en-US" sz="1300" b="1" spc="300" kern="0" dirty="0">
+            <a:pPr marL="0" indent="0" algn="l">
+              <a:buNone/>
+            </a:pPr>
+            <a:r>
+              <a:rPr lang="en-US" sz="1300" b="1" kern="0" spc="300" dirty="0">
                 <a:solidFill>
                   <a:srgbClr val="FF8A3D"/>
                 </a:solidFill>
@@ -12504,7 +12458,7 @@
           <a:bodyPr wrap="square" lIns="0" tIns="0" rIns="0" bIns="0" rtlCol="0" anchor="ctr"/>
           <a:lstStyle/>
           <a:p>
-            <a:pPr algn="l" indent="0" marL="0">
+            <a:pPr marL="0" indent="0" algn="l">
               <a:buNone/>
             </a:pPr>
             <a:r>
@@ -12548,7 +12502,7 @@
             <a:prstDash val="solid"/>
           </a:ln>
           <a:effectLst>
-            <a:outerShdw sx="100000" sy="100000" kx="0" ky="0" algn="bl" rotWithShape="0" blurRad="101600" dist="38100" dir="5400000">
+            <a:outerShdw blurRad="101600" dist="38100" dir="5400000" algn="bl" rotWithShape="0">
               <a:srgbClr val="000000">
                 <a:alpha val="12000"/>
               </a:srgbClr>
@@ -12557,19 +12511,22 @@
         </p:spPr>
         <p:txBody>
           <a:bodyPr/>
-          <a:p/>
+          <a:lstStyle/>
+          <a:p>
+            <a:endParaRPr/>
+          </a:p>
         </p:txBody>
       </p:sp>
       <p:pic>
         <p:nvPicPr>
-          <p:cNvPr id="5" name="Image 0" descr="D:/GitHub/mern-web-book/docs/assets/img/lecture-08/border-radius-shapes.png">    </p:cNvPr>
+          <p:cNvPr id="5" name="Image 0" descr="D:/GitHub/mern-web-book/docs/assets/img/lecture-08/border-radius-shapes.png"/>
           <p:cNvPicPr>
             <a:picLocks noChangeAspect="1"/>
           </p:cNvPicPr>
           <p:nvPr/>
         </p:nvPicPr>
         <p:blipFill>
-          <a:blip r:embed="rId1"/>
+          <a:blip r:embed="rId3"/>
           <a:stretch>
             <a:fillRect/>
           </a:stretch>
@@ -12601,7 +12558,7 @@
           <a:noFill/>
         </p:spPr>
         <p:txBody>
-          <a:bodyPr wrap="none" lIns="0" rIns="0" tIns="0" bIns="0">
+          <a:bodyPr wrap="none" lIns="0" tIns="0" rIns="0" bIns="0">
             <a:spAutoFit/>
           </a:bodyPr>
           <a:lstStyle/>
@@ -12643,6 +12600,7 @@
         <a:solidFill>
           <a:srgbClr val="FFFFFF"/>
         </a:solidFill>
+        <a:effectLst/>
       </p:bgPr>
     </p:bg>
     <p:spTree>
@@ -12680,11 +12638,11 @@
           <a:bodyPr wrap="square" lIns="0" tIns="0" rIns="0" bIns="0" rtlCol="0" anchor="ctr"/>
           <a:lstStyle/>
           <a:p>
-            <a:pPr algn="l" indent="0" marL="0">
-              <a:buNone/>
-            </a:pPr>
-            <a:r>
-              <a:rPr lang="en-US" sz="1300" b="1" spc="300" kern="0" dirty="0">
+            <a:pPr marL="0" indent="0" algn="l">
+              <a:buNone/>
+            </a:pPr>
+            <a:r>
+              <a:rPr lang="en-US" sz="1300" b="1" kern="0" spc="300" dirty="0">
                 <a:solidFill>
                   <a:srgbClr val="FF8A3D"/>
                 </a:solidFill>
@@ -12719,7 +12677,7 @@
           <a:bodyPr wrap="square" lIns="0" tIns="0" rIns="0" bIns="0" rtlCol="0" anchor="ctr"/>
           <a:lstStyle/>
           <a:p>
-            <a:pPr algn="l" indent="0" marL="0">
+            <a:pPr marL="0" indent="0" algn="l">
               <a:buNone/>
             </a:pPr>
             <a:r>
@@ -12760,7 +12718,10 @@
         </p:spPr>
         <p:txBody>
           <a:bodyPr/>
-          <a:p/>
+          <a:lstStyle/>
+          <a:p>
+            <a:endParaRPr/>
+          </a:p>
         </p:txBody>
       </p:sp>
       <p:sp>
@@ -12784,7 +12745,7 @@
           <a:bodyPr wrap="square" lIns="0" tIns="0" rIns="0" bIns="0" rtlCol="0" anchor="t"/>
           <a:lstStyle/>
           <a:p>
-            <a:pPr indent="0" marL="0">
+            <a:pPr marL="0" indent="0">
               <a:lnSpc>
                 <a:spcPct val="125000"/>
               </a:lnSpc>
@@ -12804,7 +12765,7 @@
             <a:endParaRPr lang="en-US" sz="1400" dirty="0"/>
           </a:p>
           <a:p>
-            <a:pPr indent="0" marL="0">
+            <a:pPr marL="0" indent="0">
               <a:lnSpc>
                 <a:spcPct val="125000"/>
               </a:lnSpc>
@@ -12824,7 +12785,7 @@
             <a:endParaRPr lang="en-US" sz="1400" dirty="0"/>
           </a:p>
           <a:p>
-            <a:pPr indent="0" marL="0">
+            <a:pPr marL="0" indent="0">
               <a:lnSpc>
                 <a:spcPct val="125000"/>
               </a:lnSpc>
@@ -12862,7 +12823,7 @@
           <a:noFill/>
         </p:spPr>
         <p:txBody>
-          <a:bodyPr wrap="none" lIns="0" rIns="0" tIns="0" bIns="0">
+          <a:bodyPr wrap="none" lIns="0" tIns="0" rIns="0" bIns="0">
             <a:spAutoFit/>
           </a:bodyPr>
           <a:lstStyle/>
@@ -12904,6 +12865,7 @@
         <a:solidFill>
           <a:srgbClr val="FFFFFF"/>
         </a:solidFill>
+        <a:effectLst/>
       </p:bgPr>
     </p:bg>
     <p:spTree>
@@ -12941,11 +12903,11 @@
           <a:bodyPr wrap="square" lIns="0" tIns="0" rIns="0" bIns="0" rtlCol="0" anchor="ctr"/>
           <a:lstStyle/>
           <a:p>
-            <a:pPr algn="l" indent="0" marL="0">
-              <a:buNone/>
-            </a:pPr>
-            <a:r>
-              <a:rPr lang="en-US" sz="1300" b="1" spc="300" kern="0" dirty="0">
+            <a:pPr marL="0" indent="0" algn="l">
+              <a:buNone/>
+            </a:pPr>
+            <a:r>
+              <a:rPr lang="en-US" sz="1300" b="1" kern="0" spc="300" dirty="0">
                 <a:solidFill>
                   <a:srgbClr val="FF8A3D"/>
                 </a:solidFill>
@@ -12980,7 +12942,7 @@
           <a:bodyPr wrap="square" lIns="0" tIns="0" rIns="0" bIns="0" rtlCol="0" anchor="ctr"/>
           <a:lstStyle/>
           <a:p>
-            <a:pPr algn="l" indent="0" marL="0">
+            <a:pPr marL="0" indent="0" algn="l">
               <a:buNone/>
             </a:pPr>
             <a:r>
@@ -13024,7 +12986,7 @@
             <a:prstDash val="solid"/>
           </a:ln>
           <a:effectLst>
-            <a:outerShdw sx="100000" sy="100000" kx="0" ky="0" algn="bl" rotWithShape="0" blurRad="101600" dist="38100" dir="5400000">
+            <a:outerShdw blurRad="101600" dist="38100" dir="5400000" algn="bl" rotWithShape="0">
               <a:srgbClr val="000000">
                 <a:alpha val="12000"/>
               </a:srgbClr>
@@ -13033,19 +12995,22 @@
         </p:spPr>
         <p:txBody>
           <a:bodyPr/>
-          <a:p/>
+          <a:lstStyle/>
+          <a:p>
+            <a:endParaRPr/>
+          </a:p>
         </p:txBody>
       </p:sp>
       <p:pic>
         <p:nvPicPr>
-          <p:cNvPr id="5" name="Image 0" descr="D:/GitHub/mern-web-book/docs/assets/img/lecture-08/gradients-linear-radial-diagonal.png">    </p:cNvPr>
+          <p:cNvPr id="5" name="Image 0" descr="D:/GitHub/mern-web-book/docs/assets/img/lecture-08/gradients-linear-radial-diagonal.png"/>
           <p:cNvPicPr>
             <a:picLocks noChangeAspect="1"/>
           </p:cNvPicPr>
           <p:nvPr/>
         </p:nvPicPr>
         <p:blipFill>
-          <a:blip r:embed="rId1"/>
+          <a:blip r:embed="rId3"/>
           <a:stretch>
             <a:fillRect/>
           </a:stretch>
@@ -13077,7 +13042,7 @@
           <a:noFill/>
         </p:spPr>
         <p:txBody>
-          <a:bodyPr wrap="none" lIns="0" rIns="0" tIns="0" bIns="0">
+          <a:bodyPr wrap="none" lIns="0" tIns="0" rIns="0" bIns="0">
             <a:spAutoFit/>
           </a:bodyPr>
           <a:lstStyle/>
@@ -13119,6 +13084,7 @@
         <a:solidFill>
           <a:srgbClr val="FFFFFF"/>
         </a:solidFill>
+        <a:effectLst/>
       </p:bgPr>
     </p:bg>
     <p:spTree>
@@ -13156,11 +13122,11 @@
           <a:bodyPr wrap="square" lIns="0" tIns="0" rIns="0" bIns="0" rtlCol="0" anchor="ctr"/>
           <a:lstStyle/>
           <a:p>
-            <a:pPr algn="l" indent="0" marL="0">
-              <a:buNone/>
-            </a:pPr>
-            <a:r>
-              <a:rPr lang="en-US" sz="1300" b="1" spc="300" kern="0" dirty="0">
+            <a:pPr marL="0" indent="0" algn="l">
+              <a:buNone/>
+            </a:pPr>
+            <a:r>
+              <a:rPr lang="en-US" sz="1300" b="1" kern="0" spc="300" dirty="0">
                 <a:solidFill>
                   <a:srgbClr val="FF8A3D"/>
                 </a:solidFill>
@@ -13195,7 +13161,7 @@
           <a:bodyPr wrap="square" lIns="0" tIns="0" rIns="0" bIns="0" rtlCol="0" anchor="ctr"/>
           <a:lstStyle/>
           <a:p>
-            <a:pPr algn="l" indent="0" marL="0">
+            <a:pPr marL="0" indent="0" algn="l">
               <a:buNone/>
             </a:pPr>
             <a:r>
@@ -13236,7 +13202,10 @@
         </p:spPr>
         <p:txBody>
           <a:bodyPr/>
-          <a:p/>
+          <a:lstStyle/>
+          <a:p>
+            <a:endParaRPr/>
+          </a:p>
         </p:txBody>
       </p:sp>
       <p:sp>
@@ -13260,7 +13229,7 @@
           <a:bodyPr wrap="square" lIns="0" tIns="0" rIns="0" bIns="0" rtlCol="0" anchor="t"/>
           <a:lstStyle/>
           <a:p>
-            <a:pPr indent="0" marL="0">
+            <a:pPr marL="0" indent="0">
               <a:lnSpc>
                 <a:spcPct val="125000"/>
               </a:lnSpc>
@@ -13280,7 +13249,7 @@
             <a:endParaRPr lang="en-US" sz="1250" dirty="0"/>
           </a:p>
           <a:p>
-            <a:pPr indent="0" marL="0">
+            <a:pPr marL="0" indent="0">
               <a:lnSpc>
                 <a:spcPct val="125000"/>
               </a:lnSpc>
@@ -13300,7 +13269,7 @@
             <a:endParaRPr lang="en-US" sz="1250" dirty="0"/>
           </a:p>
           <a:p>
-            <a:pPr indent="0" marL="0">
+            <a:pPr marL="0" indent="0">
               <a:lnSpc>
                 <a:spcPct val="125000"/>
               </a:lnSpc>
@@ -13320,7 +13289,7 @@
             <a:endParaRPr lang="en-US" sz="1250" dirty="0"/>
           </a:p>
           <a:p>
-            <a:pPr indent="0" marL="0">
+            <a:pPr marL="0" indent="0">
               <a:lnSpc>
                 <a:spcPct val="125000"/>
               </a:lnSpc>
@@ -13340,7 +13309,7 @@
             <a:endParaRPr lang="en-US" sz="1250" dirty="0"/>
           </a:p>
           <a:p>
-            <a:pPr indent="0" marL="0">
+            <a:pPr marL="0" indent="0">
               <a:lnSpc>
                 <a:spcPct val="125000"/>
               </a:lnSpc>
@@ -13360,7 +13329,7 @@
             <a:endParaRPr lang="en-US" sz="1250" dirty="0"/>
           </a:p>
           <a:p>
-            <a:pPr indent="0" marL="0">
+            <a:pPr marL="0" indent="0">
               <a:lnSpc>
                 <a:spcPct val="125000"/>
               </a:lnSpc>
@@ -13407,7 +13376,7 @@
             <a:prstDash val="solid"/>
           </a:ln>
           <a:effectLst>
-            <a:outerShdw sx="100000" sy="100000" kx="0" ky="0" algn="bl" rotWithShape="0" blurRad="101600" dist="38100" dir="5400000">
+            <a:outerShdw blurRad="101600" dist="38100" dir="5400000" algn="bl" rotWithShape="0">
               <a:srgbClr val="000000">
                 <a:alpha val="12000"/>
               </a:srgbClr>
@@ -13416,19 +13385,22 @@
         </p:spPr>
         <p:txBody>
           <a:bodyPr/>
-          <a:p/>
+          <a:lstStyle/>
+          <a:p>
+            <a:endParaRPr/>
+          </a:p>
         </p:txBody>
       </p:sp>
       <p:pic>
         <p:nvPicPr>
-          <p:cNvPr id="7" name="Image 0" descr="D:/GitHub/mern-web-book/docs/assets/img/lecture-08/gradient-rainbow-stops.png">    </p:cNvPr>
+          <p:cNvPr id="7" name="Image 0" descr="D:/GitHub/mern-web-book/docs/assets/img/lecture-08/gradient-rainbow-stops.png"/>
           <p:cNvPicPr>
             <a:picLocks noChangeAspect="1"/>
           </p:cNvPicPr>
           <p:nvPr/>
         </p:nvPicPr>
         <p:blipFill>
-          <a:blip r:embed="rId1"/>
+          <a:blip r:embed="rId3"/>
           <a:stretch>
             <a:fillRect/>
           </a:stretch>
@@ -13460,7 +13432,7 @@
           <a:noFill/>
         </p:spPr>
         <p:txBody>
-          <a:bodyPr wrap="none" lIns="0" rIns="0" tIns="0" bIns="0">
+          <a:bodyPr wrap="none" lIns="0" tIns="0" rIns="0" bIns="0">
             <a:spAutoFit/>
           </a:bodyPr>
           <a:lstStyle/>
@@ -13502,6 +13474,7 @@
         <a:solidFill>
           <a:srgbClr val="FFFFFF"/>
         </a:solidFill>
+        <a:effectLst/>
       </p:bgPr>
     </p:bg>
     <p:spTree>
@@ -13539,11 +13512,11 @@
           <a:bodyPr wrap="square" lIns="0" tIns="0" rIns="0" bIns="0" rtlCol="0" anchor="ctr"/>
           <a:lstStyle/>
           <a:p>
-            <a:pPr algn="l" indent="0" marL="0">
-              <a:buNone/>
-            </a:pPr>
-            <a:r>
-              <a:rPr lang="en-US" sz="1300" b="1" spc="300" kern="0" dirty="0">
+            <a:pPr marL="0" indent="0" algn="l">
+              <a:buNone/>
+            </a:pPr>
+            <a:r>
+              <a:rPr lang="en-US" sz="1300" b="1" kern="0" spc="300" dirty="0">
                 <a:solidFill>
                   <a:srgbClr val="FF8A3D"/>
                 </a:solidFill>
@@ -13578,7 +13551,7 @@
           <a:bodyPr wrap="square" lIns="0" tIns="0" rIns="0" bIns="0" rtlCol="0" anchor="ctr"/>
           <a:lstStyle/>
           <a:p>
-            <a:pPr algn="l" indent="0" marL="0">
+            <a:pPr marL="0" indent="0" algn="l">
               <a:buNone/>
             </a:pPr>
             <a:r>
@@ -13617,7 +13590,7 @@
           <a:bodyPr wrap="square" lIns="0" tIns="0" rIns="0" bIns="0" rtlCol="0" anchor="ctr"/>
           <a:lstStyle/>
           <a:p>
-            <a:pPr indent="0" marL="0">
+            <a:pPr marL="0" indent="0">
               <a:buNone/>
             </a:pPr>
             <a:r>
@@ -13658,7 +13631,10 @@
         </p:spPr>
         <p:txBody>
           <a:bodyPr/>
-          <a:p/>
+          <a:lstStyle/>
+          <a:p>
+            <a:endParaRPr/>
+          </a:p>
         </p:txBody>
       </p:sp>
       <p:sp>
@@ -13682,7 +13658,7 @@
           <a:bodyPr wrap="square" lIns="0" tIns="0" rIns="0" bIns="0" rtlCol="0" anchor="t"/>
           <a:lstStyle/>
           <a:p>
-            <a:pPr indent="0" marL="0">
+            <a:pPr marL="0" indent="0">
               <a:lnSpc>
                 <a:spcPct val="125000"/>
               </a:lnSpc>
@@ -13702,7 +13678,7 @@
             <a:endParaRPr lang="en-US" sz="1250" dirty="0"/>
           </a:p>
           <a:p>
-            <a:pPr indent="0" marL="0">
+            <a:pPr marL="0" indent="0">
               <a:lnSpc>
                 <a:spcPct val="125000"/>
               </a:lnSpc>
@@ -13722,7 +13698,7 @@
             <a:endParaRPr lang="en-US" sz="1250" dirty="0"/>
           </a:p>
           <a:p>
-            <a:pPr indent="0" marL="0">
+            <a:pPr marL="0" indent="0">
               <a:lnSpc>
                 <a:spcPct val="125000"/>
               </a:lnSpc>
@@ -13742,7 +13718,7 @@
             <a:endParaRPr lang="en-US" sz="1250" dirty="0"/>
           </a:p>
           <a:p>
-            <a:pPr indent="0" marL="0">
+            <a:pPr marL="0" indent="0">
               <a:lnSpc>
                 <a:spcPct val="125000"/>
               </a:lnSpc>
@@ -13762,7 +13738,7 @@
             <a:endParaRPr lang="en-US" sz="1250" dirty="0"/>
           </a:p>
           <a:p>
-            <a:pPr indent="0" marL="0">
+            <a:pPr marL="0" indent="0">
               <a:lnSpc>
                 <a:spcPct val="125000"/>
               </a:lnSpc>
@@ -13782,7 +13758,7 @@
             <a:endParaRPr lang="en-US" sz="1250" dirty="0"/>
           </a:p>
           <a:p>
-            <a:pPr indent="0" marL="0">
+            <a:pPr marL="0" indent="0">
               <a:lnSpc>
                 <a:spcPct val="125000"/>
               </a:lnSpc>
@@ -13829,7 +13805,7 @@
             <a:prstDash val="solid"/>
           </a:ln>
           <a:effectLst>
-            <a:outerShdw sx="100000" sy="100000" kx="0" ky="0" algn="bl" rotWithShape="0" blurRad="101600" dist="38100" dir="5400000">
+            <a:outerShdw blurRad="101600" dist="38100" dir="5400000" algn="bl" rotWithShape="0">
               <a:srgbClr val="000000">
                 <a:alpha val="12000"/>
               </a:srgbClr>
@@ -13838,19 +13814,22 @@
         </p:spPr>
         <p:txBody>
           <a:bodyPr/>
-          <a:p/>
+          <a:lstStyle/>
+          <a:p>
+            <a:endParaRPr/>
+          </a:p>
         </p:txBody>
       </p:sp>
       <p:pic>
         <p:nvPicPr>
-          <p:cNvPr id="8" name="Image 0" descr="D:/GitHub/mern-web-book/slides/assets/lecture-08/shadow-hover.png">    </p:cNvPr>
+          <p:cNvPr id="8" name="Image 0" descr="D:/GitHub/mern-web-book/slides/assets/lecture-08/shadow-hover.png"/>
           <p:cNvPicPr>
             <a:picLocks noChangeAspect="1"/>
           </p:cNvPicPr>
           <p:nvPr/>
         </p:nvPicPr>
         <p:blipFill>
-          <a:blip r:embed="rId1"/>
+          <a:blip r:embed="rId3"/>
           <a:stretch>
             <a:fillRect/>
           </a:stretch>
@@ -13882,7 +13861,7 @@
           <a:noFill/>
         </p:spPr>
         <p:txBody>
-          <a:bodyPr wrap="none" lIns="0" rIns="0" tIns="0" bIns="0">
+          <a:bodyPr wrap="none" lIns="0" tIns="0" rIns="0" bIns="0">
             <a:spAutoFit/>
           </a:bodyPr>
           <a:lstStyle/>
@@ -13924,6 +13903,7 @@
         <a:solidFill>
           <a:srgbClr val="FFFFFF"/>
         </a:solidFill>
+        <a:effectLst/>
       </p:bgPr>
     </p:bg>
     <p:spTree>
@@ -13961,11 +13941,11 @@
           <a:bodyPr wrap="square" lIns="0" tIns="0" rIns="0" bIns="0" rtlCol="0" anchor="ctr"/>
           <a:lstStyle/>
           <a:p>
-            <a:pPr algn="l" indent="0" marL="0">
-              <a:buNone/>
-            </a:pPr>
-            <a:r>
-              <a:rPr lang="en-US" sz="1300" b="1" spc="300" kern="0" dirty="0">
+            <a:pPr marL="0" indent="0" algn="l">
+              <a:buNone/>
+            </a:pPr>
+            <a:r>
+              <a:rPr lang="en-US" sz="1300" b="1" kern="0" spc="300" dirty="0">
                 <a:solidFill>
                   <a:srgbClr val="FF8A3D"/>
                 </a:solidFill>
@@ -14000,7 +13980,7 @@
           <a:bodyPr wrap="square" lIns="0" tIns="0" rIns="0" bIns="0" rtlCol="0" anchor="ctr"/>
           <a:lstStyle/>
           <a:p>
-            <a:pPr algn="l" indent="0" marL="0">
+            <a:pPr marL="0" indent="0" algn="l">
               <a:buNone/>
             </a:pPr>
             <a:r>
@@ -14041,7 +14021,10 @@
         </p:spPr>
         <p:txBody>
           <a:bodyPr/>
-          <a:p/>
+          <a:lstStyle/>
+          <a:p>
+            <a:endParaRPr/>
+          </a:p>
         </p:txBody>
       </p:sp>
       <p:sp>
@@ -14065,7 +14048,7 @@
           <a:bodyPr wrap="square" lIns="0" tIns="0" rIns="0" bIns="0" rtlCol="0" anchor="t"/>
           <a:lstStyle/>
           <a:p>
-            <a:pPr indent="0" marL="0">
+            <a:pPr marL="0" indent="0">
               <a:lnSpc>
                 <a:spcPct val="125000"/>
               </a:lnSpc>
@@ -14085,7 +14068,7 @@
             <a:endParaRPr lang="en-US" sz="1250" dirty="0"/>
           </a:p>
           <a:p>
-            <a:pPr indent="0" marL="0">
+            <a:pPr marL="0" indent="0">
               <a:lnSpc>
                 <a:spcPct val="125000"/>
               </a:lnSpc>
@@ -14105,7 +14088,7 @@
             <a:endParaRPr lang="en-US" sz="1250" dirty="0"/>
           </a:p>
           <a:p>
-            <a:pPr indent="0" marL="0">
+            <a:pPr marL="0" indent="0">
               <a:lnSpc>
                 <a:spcPct val="125000"/>
               </a:lnSpc>
@@ -14152,7 +14135,7 @@
             <a:prstDash val="solid"/>
           </a:ln>
           <a:effectLst>
-            <a:outerShdw sx="100000" sy="100000" kx="0" ky="0" algn="bl" rotWithShape="0" blurRad="101600" dist="38100" dir="5400000">
+            <a:outerShdw blurRad="101600" dist="38100" dir="5400000" algn="bl" rotWithShape="0">
               <a:srgbClr val="000000">
                 <a:alpha val="12000"/>
               </a:srgbClr>
@@ -14161,19 +14144,22 @@
         </p:spPr>
         <p:txBody>
           <a:bodyPr/>
-          <a:p/>
+          <a:lstStyle/>
+          <a:p>
+            <a:endParaRPr/>
+          </a:p>
         </p:txBody>
       </p:sp>
       <p:pic>
         <p:nvPicPr>
-          <p:cNvPr id="7" name="Image 0" descr="D:/GitHub/mern-web-book/docs/assets/img/lecture-08/text-shadow-heading.png">    </p:cNvPr>
+          <p:cNvPr id="7" name="Image 0" descr="D:/GitHub/mern-web-book/docs/assets/img/lecture-08/text-shadow-heading.png"/>
           <p:cNvPicPr>
             <a:picLocks noChangeAspect="1"/>
           </p:cNvPicPr>
           <p:nvPr/>
         </p:nvPicPr>
         <p:blipFill>
-          <a:blip r:embed="rId1"/>
+          <a:blip r:embed="rId3"/>
           <a:stretch>
             <a:fillRect/>
           </a:stretch>
@@ -14205,7 +14191,7 @@
           <a:noFill/>
         </p:spPr>
         <p:txBody>
-          <a:bodyPr wrap="none" lIns="0" rIns="0" tIns="0" bIns="0">
+          <a:bodyPr wrap="none" lIns="0" tIns="0" rIns="0" bIns="0">
             <a:spAutoFit/>
           </a:bodyPr>
           <a:lstStyle/>
@@ -14532,4 +14518,299 @@
     </a:ext>
   </a:extLst>
 </a:theme>
+</file>
+
+<file path=ppt/theme/theme2.xml><?xml version="1.0" encoding="utf-8"?>
+<a:theme xmlns:a="http://schemas.openxmlformats.org/drawingml/2006/main" name="Office Theme">
+  <a:themeElements>
+    <a:clrScheme name="Office">
+      <a:dk1>
+        <a:sysClr val="windowText" lastClr="000000"/>
+      </a:dk1>
+      <a:lt1>
+        <a:sysClr val="window" lastClr="FFFFFF"/>
+      </a:lt1>
+      <a:dk2>
+        <a:srgbClr val="44546A"/>
+      </a:dk2>
+      <a:lt2>
+        <a:srgbClr val="E7E6E6"/>
+      </a:lt2>
+      <a:accent1>
+        <a:srgbClr val="4472C4"/>
+      </a:accent1>
+      <a:accent2>
+        <a:srgbClr val="ED7D31"/>
+      </a:accent2>
+      <a:accent3>
+        <a:srgbClr val="A5A5A5"/>
+      </a:accent3>
+      <a:accent4>
+        <a:srgbClr val="FFC000"/>
+      </a:accent4>
+      <a:accent5>
+        <a:srgbClr val="5B9BD5"/>
+      </a:accent5>
+      <a:accent6>
+        <a:srgbClr val="70AD47"/>
+      </a:accent6>
+      <a:hlink>
+        <a:srgbClr val="0563C1"/>
+      </a:hlink>
+      <a:folHlink>
+        <a:srgbClr val="954F72"/>
+      </a:folHlink>
+    </a:clrScheme>
+    <a:fontScheme name="Office">
+      <a:majorFont>
+        <a:latin typeface="Calibri Light" panose="020F0302020204030204"/>
+        <a:ea typeface=""/>
+        <a:cs typeface=""/>
+        <a:font script="Jpan" typeface="游ゴシック Light"/>
+        <a:font script="Hang" typeface="맑은 고딕"/>
+        <a:font script="Hans" typeface="等线 Light"/>
+        <a:font script="Hant" typeface="新細明體"/>
+        <a:font script="Arab" typeface="Times New Roman"/>
+        <a:font script="Hebr" typeface="Times New Roman"/>
+        <a:font script="Thai" typeface="Angsana New"/>
+        <a:font script="Ethi" typeface="Nyala"/>
+        <a:font script="Beng" typeface="Vrinda"/>
+        <a:font script="Gujr" typeface="Shruti"/>
+        <a:font script="Khmr" typeface="MoolBoran"/>
+        <a:font script="Knda" typeface="Tunga"/>
+        <a:font script="Guru" typeface="Raavi"/>
+        <a:font script="Cans" typeface="Euphemia"/>
+        <a:font script="Cher" typeface="Plantagenet Cherokee"/>
+        <a:font script="Yiii" typeface="Microsoft Yi Baiti"/>
+        <a:font script="Tibt" typeface="Microsoft Himalaya"/>
+        <a:font script="Thaa" typeface="MV Boli"/>
+        <a:font script="Deva" typeface="Mangal"/>
+        <a:font script="Telu" typeface="Gautami"/>
+        <a:font script="Taml" typeface="Latha"/>
+        <a:font script="Syrc" typeface="Estrangelo Edessa"/>
+        <a:font script="Orya" typeface="Kalinga"/>
+        <a:font script="Mlym" typeface="Kartika"/>
+        <a:font script="Laoo" typeface="DokChampa"/>
+        <a:font script="Sinh" typeface="Iskoola Pota"/>
+        <a:font script="Mong" typeface="Mongolian Baiti"/>
+        <a:font script="Viet" typeface="Times New Roman"/>
+        <a:font script="Uigh" typeface="Microsoft Uighur"/>
+        <a:font script="Geor" typeface="Sylfaen"/>
+        <a:font script="Armn" typeface="Arial"/>
+        <a:font script="Bugi" typeface="Leelawadee UI"/>
+        <a:font script="Bopo" typeface="Microsoft JhengHei"/>
+        <a:font script="Java" typeface="Javanese Text"/>
+        <a:font script="Lisu" typeface="Segoe UI"/>
+        <a:font script="Mymr" typeface="Myanmar Text"/>
+        <a:font script="Nkoo" typeface="Ebrima"/>
+        <a:font script="Olck" typeface="Nirmala UI"/>
+        <a:font script="Osma" typeface="Ebrima"/>
+        <a:font script="Phag" typeface="Phagspa"/>
+        <a:font script="Syrn" typeface="Estrangelo Edessa"/>
+        <a:font script="Syrj" typeface="Estrangelo Edessa"/>
+        <a:font script="Syre" typeface="Estrangelo Edessa"/>
+        <a:font script="Sora" typeface="Nirmala UI"/>
+        <a:font script="Tale" typeface="Microsoft Tai Le"/>
+        <a:font script="Talu" typeface="Microsoft New Tai Lue"/>
+        <a:font script="Tfng" typeface="Ebrima"/>
+      </a:majorFont>
+      <a:minorFont>
+        <a:latin typeface="Calibri" panose="020F0502020204030204"/>
+        <a:ea typeface=""/>
+        <a:cs typeface=""/>
+        <a:font script="Jpan" typeface="游ゴシック"/>
+        <a:font script="Hang" typeface="맑은 고딕"/>
+        <a:font script="Hans" typeface="等线"/>
+        <a:font script="Hant" typeface="新細明體"/>
+        <a:font script="Arab" typeface="Arial"/>
+        <a:font script="Hebr" typeface="Arial"/>
+        <a:font script="Thai" typeface="Cordia New"/>
+        <a:font script="Ethi" typeface="Nyala"/>
+        <a:font script="Beng" typeface="Vrinda"/>
+        <a:font script="Gujr" typeface="Shruti"/>
+        <a:font script="Khmr" typeface="DaunPenh"/>
+        <a:font script="Knda" typeface="Tunga"/>
+        <a:font script="Guru" typeface="Raavi"/>
+        <a:font script="Cans" typeface="Euphemia"/>
+        <a:font script="Cher" typeface="Plantagenet Cherokee"/>
+        <a:font script="Yiii" typeface="Microsoft Yi Baiti"/>
+        <a:font script="Tibt" typeface="Microsoft Himalaya"/>
+        <a:font script="Thaa" typeface="MV Boli"/>
+        <a:font script="Deva" typeface="Mangal"/>
+        <a:font script="Telu" typeface="Gautami"/>
+        <a:font script="Taml" typeface="Latha"/>
+        <a:font script="Syrc" typeface="Estrangelo Edessa"/>
+        <a:font script="Orya" typeface="Kalinga"/>
+        <a:font script="Mlym" typeface="Kartika"/>
+        <a:font script="Laoo" typeface="DokChampa"/>
+        <a:font script="Sinh" typeface="Iskoola Pota"/>
+        <a:font script="Mong" typeface="Mongolian Baiti"/>
+        <a:font script="Viet" typeface="Arial"/>
+        <a:font script="Uigh" typeface="Microsoft Uighur"/>
+        <a:font script="Geor" typeface="Sylfaen"/>
+        <a:font script="Armn" typeface="Arial"/>
+        <a:font script="Bugi" typeface="Leelawadee UI"/>
+        <a:font script="Bopo" typeface="Microsoft JhengHei"/>
+        <a:font script="Java" typeface="Javanese Text"/>
+        <a:font script="Lisu" typeface="Segoe UI"/>
+        <a:font script="Mymr" typeface="Myanmar Text"/>
+        <a:font script="Nkoo" typeface="Ebrima"/>
+        <a:font script="Olck" typeface="Nirmala UI"/>
+        <a:font script="Osma" typeface="Ebrima"/>
+        <a:font script="Phag" typeface="Phagspa"/>
+        <a:font script="Syrn" typeface="Estrangelo Edessa"/>
+        <a:font script="Syrj" typeface="Estrangelo Edessa"/>
+        <a:font script="Syre" typeface="Estrangelo Edessa"/>
+        <a:font script="Sora" typeface="Nirmala UI"/>
+        <a:font script="Tale" typeface="Microsoft Tai Le"/>
+        <a:font script="Talu" typeface="Microsoft New Tai Lue"/>
+        <a:font script="Tfng" typeface="Ebrima"/>
+      </a:minorFont>
+    </a:fontScheme>
+    <a:fmtScheme name="Office">
+      <a:fillStyleLst>
+        <a:solidFill>
+          <a:schemeClr val="phClr"/>
+        </a:solidFill>
+        <a:gradFill rotWithShape="1">
+          <a:gsLst>
+            <a:gs pos="0">
+              <a:schemeClr val="phClr">
+                <a:lumMod val="110000"/>
+                <a:satMod val="105000"/>
+                <a:tint val="67000"/>
+              </a:schemeClr>
+            </a:gs>
+            <a:gs pos="50000">
+              <a:schemeClr val="phClr">
+                <a:lumMod val="105000"/>
+                <a:satMod val="103000"/>
+                <a:tint val="73000"/>
+              </a:schemeClr>
+            </a:gs>
+            <a:gs pos="100000">
+              <a:schemeClr val="phClr">
+                <a:lumMod val="105000"/>
+                <a:satMod val="109000"/>
+                <a:tint val="81000"/>
+              </a:schemeClr>
+            </a:gs>
+          </a:gsLst>
+          <a:lin ang="5400000" scaled="0"/>
+        </a:gradFill>
+        <a:gradFill rotWithShape="1">
+          <a:gsLst>
+            <a:gs pos="0">
+              <a:schemeClr val="phClr">
+                <a:satMod val="103000"/>
+                <a:lumMod val="102000"/>
+                <a:tint val="94000"/>
+              </a:schemeClr>
+            </a:gs>
+            <a:gs pos="50000">
+              <a:schemeClr val="phClr">
+                <a:satMod val="110000"/>
+                <a:lumMod val="100000"/>
+                <a:shade val="100000"/>
+              </a:schemeClr>
+            </a:gs>
+            <a:gs pos="100000">
+              <a:schemeClr val="phClr">
+                <a:lumMod val="99000"/>
+                <a:satMod val="120000"/>
+                <a:shade val="78000"/>
+              </a:schemeClr>
+            </a:gs>
+          </a:gsLst>
+          <a:lin ang="5400000" scaled="0"/>
+        </a:gradFill>
+      </a:fillStyleLst>
+      <a:lnStyleLst>
+        <a:ln w="6350" cap="flat" cmpd="sng" algn="ctr">
+          <a:solidFill>
+            <a:schemeClr val="phClr"/>
+          </a:solidFill>
+          <a:prstDash val="solid"/>
+          <a:miter lim="800000"/>
+        </a:ln>
+        <a:ln w="12700" cap="flat" cmpd="sng" algn="ctr">
+          <a:solidFill>
+            <a:schemeClr val="phClr"/>
+          </a:solidFill>
+          <a:prstDash val="solid"/>
+          <a:miter lim="800000"/>
+        </a:ln>
+        <a:ln w="19050" cap="flat" cmpd="sng" algn="ctr">
+          <a:solidFill>
+            <a:schemeClr val="phClr"/>
+          </a:solidFill>
+          <a:prstDash val="solid"/>
+          <a:miter lim="800000"/>
+        </a:ln>
+      </a:lnStyleLst>
+      <a:effectStyleLst>
+        <a:effectStyle>
+          <a:effectLst/>
+        </a:effectStyle>
+        <a:effectStyle>
+          <a:effectLst/>
+        </a:effectStyle>
+        <a:effectStyle>
+          <a:effectLst>
+            <a:outerShdw blurRad="57150" dist="19050" dir="5400000" algn="ctr" rotWithShape="0">
+              <a:srgbClr val="000000">
+                <a:alpha val="63000"/>
+              </a:srgbClr>
+            </a:outerShdw>
+          </a:effectLst>
+        </a:effectStyle>
+      </a:effectStyleLst>
+      <a:bgFillStyleLst>
+        <a:solidFill>
+          <a:schemeClr val="phClr"/>
+        </a:solidFill>
+        <a:solidFill>
+          <a:schemeClr val="phClr">
+            <a:tint val="95000"/>
+            <a:satMod val="170000"/>
+          </a:schemeClr>
+        </a:solidFill>
+        <a:gradFill rotWithShape="1">
+          <a:gsLst>
+            <a:gs pos="0">
+              <a:schemeClr val="phClr">
+                <a:tint val="93000"/>
+                <a:satMod val="150000"/>
+                <a:shade val="98000"/>
+                <a:lumMod val="102000"/>
+              </a:schemeClr>
+            </a:gs>
+            <a:gs pos="50000">
+              <a:schemeClr val="phClr">
+                <a:tint val="98000"/>
+                <a:satMod val="130000"/>
+                <a:shade val="90000"/>
+                <a:lumMod val="103000"/>
+              </a:schemeClr>
+            </a:gs>
+            <a:gs pos="100000">
+              <a:schemeClr val="phClr">
+                <a:shade val="63000"/>
+                <a:satMod val="120000"/>
+              </a:schemeClr>
+            </a:gs>
+          </a:gsLst>
+          <a:lin ang="5400000" scaled="0"/>
+        </a:gradFill>
+      </a:bgFillStyleLst>
+    </a:fmtScheme>
+  </a:themeElements>
+  <a:objectDefaults/>
+  <a:extraClrSchemeLst/>
+  <a:extLst>
+    <a:ext uri="{05A4C25C-085E-4340-85A3-A5531E510DB2}">
+      <thm15:themeFamily xmlns:thm15="http://schemas.microsoft.com/office/thememl/2012/main" name="Office Theme" id="{62F939B6-93AF-4DB8-9C6B-D6C7DFDC589F}" vid="{4A3C46E8-61CC-4603-A589-7422A47A8E4A}"/>
+    </a:ext>
+  </a:extLst>
+</a:theme>
 </file>
</xml_diff>